<commit_message>
feat(phase2): deliver comprehensive Second Phase Work (Mid-Term Exam - 20 Marks) report & presentation with UML Class Diagram, Sequence Diagram, Data Dictionary, and Screen Validations
</commit_message>
<xml_diff>
--- a/Deep_Koshiya_ProjectPresentation.pptx
+++ b/Deep_Koshiya_ProjectPresentation.pptx
@@ -3268,18 +3268,18 @@
         </p:nvSpPr>
         <p:spPr>
           <a:xfrm>
-            <a:off x="2926080" y="2148840"/>
-            <a:ext cx="6339535" cy="384048"/>
+            <a:off x="2743200" y="2148840"/>
+            <a:ext cx="6705295" cy="384048"/>
           </a:xfrm>
           <a:prstGeom prst="roundRect">
             <a:avLst/>
           </a:prstGeom>
           <a:solidFill>
-            <a:srgbClr val="EFF6FF"/>
+            <a:srgbClr val="ECFDF5"/>
           </a:solidFill>
           <a:ln w="12700">
             <a:solidFill>
-              <a:srgbClr val="2563EB"/>
+              <a:srgbClr val="10B981"/>
             </a:solidFill>
           </a:ln>
         </p:spPr>
@@ -3313,8 +3313,8 @@
         </p:nvSpPr>
         <p:spPr>
           <a:xfrm>
-            <a:off x="2926080" y="2148840"/>
-            <a:ext cx="6339535" cy="384048"/>
+            <a:off x="2743200" y="2148840"/>
+            <a:ext cx="6705295" cy="384048"/>
           </a:xfrm>
           <a:prstGeom prst="rect">
             <a:avLst/>
@@ -3330,13 +3330,13 @@
             <a:pPr algn="ctr">
               <a:defRPr sz="1000" b="1">
                 <a:solidFill>
-                  <a:srgbClr val="2563EB"/>
+                  <a:srgbClr val="10B981"/>
                 </a:solidFill>
                 <a:latin typeface="Arial"/>
               </a:defRPr>
             </a:pPr>
             <a:r>
-              <a:t>FIRST PROGRESS WORK PRESENTATION  •  24TH SEPTEMBER 2026  •  10 MARKS</a:t>
+              <a:t>SECOND PROGRESS WORK (MID-TERM EXAM)  •  13TH OCTOBER 2026  •  20 MARKS</a:t>
             </a:r>
           </a:p>
         </p:txBody>
@@ -3389,7 +3389,7 @@
               </a:defRPr>
             </a:pPr>
             <a:r>
-              <a:t>An Applied Machine Learning &amp; Analytics Engineering System for Behavioral Cohort Optimization</a:t>
+              <a:t>Second Phase Technical Report: UML Class &amp; Sequence Models, Data Dictionary &amp; UI Layout Validations</a:t>
             </a:r>
           </a:p>
         </p:txBody>
@@ -3641,7 +3641,7 @@
               </a:defRPr>
             </a:pPr>
             <a:r>
-              <a:t>EVALUATION &amp; MILESTONE SCOPE</a:t>
+              <a:t>EVALUATION &amp; DELIVERABLE SCOPE</a:t>
             </a:r>
           </a:p>
           <a:p>
@@ -3659,7 +3659,7 @@
                   <a:srgbClr val="0F172A"/>
                 </a:solidFill>
               </a:rPr>
-              <a:t>First Progress Work Evaluation</a:t>
+              <a:t>Second Progress Work (Mid-Term)</a:t>
             </a:r>
           </a:p>
           <a:p>
@@ -3677,7 +3677,7 @@
                   <a:srgbClr val="0F172A"/>
                 </a:solidFill>
               </a:rPr>
-              <a:t>24th September 2026 (10 AM - 5 PM)</a:t>
+              <a:t>13th October 2026 (10 AM - 5 PM)</a:t>
             </a:r>
           </a:p>
           <a:p>
@@ -3695,7 +3695,7 @@
                   <a:srgbClr val="0F172A"/>
                 </a:solidFill>
               </a:rPr>
-              <a:t>10 Marks (Curriculum Deliverable)</a:t>
+              <a:t>20 Marks (Mid-Term Assessment)</a:t>
             </a:r>
           </a:p>
           <a:p>
@@ -3713,7 +3713,7 @@
                   <a:srgbClr val="0F172A"/>
                 </a:solidFill>
               </a:rPr>
-              <a:t>Sections 1.1, 1.2, 1.3, 2.1, 2.2</a:t>
+              <a:t>Sections 2.3, 2.4, 3.1, 4.1</a:t>
             </a:r>
           </a:p>
           <a:p>
@@ -4074,7 +4074,7 @@
                   <a:srgbClr val="475569"/>
                 </a:solidFill>
               </a:rPr>
-              <a:t>First Progress Work (24/09/2026  •  10 Marks)</a:t>
+              <a:t>Second Progress Work / Mid-Term Exam (13/10/2026  •  20 Marks)</a:t>
             </a:r>
           </a:p>
           <a:p>
@@ -4143,7 +4143,7 @@
                   <a:srgbClr val="475569"/>
                 </a:solidFill>
               </a:rPr>
-              <a:t>Refinery Pipeline, RFM Engine, UML/DFD Models &amp; Dashboard Complete</a:t>
+              <a:t>Class &amp; Sequence Diagrams, Star Schema Marts &amp; UI Validations Complete</a:t>
             </a:r>
           </a:p>
         </p:txBody>
@@ -4242,7 +4242,7 @@
               </a:defRPr>
             </a:pPr>
             <a:r>
-              <a:t>SECTION 1.1  •  ABOUT THE SYSTEM</a:t>
+              <a:t>PROGRESSIVE ARCHITECTURE  •  OVERVIEW</a:t>
             </a:r>
           </a:p>
         </p:txBody>
@@ -4278,7 +4278,7 @@
               </a:defRPr>
             </a:pPr>
             <a:r>
-              <a:t>Problem Definition &amp; Commercial Context</a:t>
+              <a:t>System Architecture &amp; Phase 1 Foundations Recap</a:t>
             </a:r>
           </a:p>
         </p:txBody>
@@ -4395,7 +4395,7 @@
               </a:defRPr>
             </a:pPr>
             <a:r>
-              <a:t>B.Sc. in Artificial Intelligence &amp; Data Science (Sem V)  •  Institute of Advanced Research  •  First Progress Work (24/09/2026)</a:t>
+              <a:t>B.Sc. in Artificial Intelligence &amp; Data Science (Sem V)  •  Institute of Advanced Research  •  Second Progress Work (13/10/2026)</a:t>
             </a:r>
           </a:p>
         </p:txBody>
@@ -4468,14 +4468,14 @@
           <a:lstStyle/>
           <a:p>
             <a:pPr>
-              <a:defRPr sz="1400" b="1">
+              <a:defRPr sz="1350" b="1">
                 <a:solidFill>
                   <a:srgbClr val="7A003C"/>
                 </a:solidFill>
               </a:defRPr>
             </a:pPr>
             <a:r>
-              <a:t>1. Commercial Retention Dilemma</a:t>
+              <a:t>1. Phase 1 Foundations (10 Marks)</a:t>
             </a:r>
           </a:p>
           <a:p>
@@ -4485,20 +4485,20 @@
               </a:spcBef>
             </a:pPr>
             <a:r>
-              <a:rPr b="1" sz="1050">
+              <a:rPr b="1" sz="1000">
                 <a:solidFill>
                   <a:srgbClr val="1E1B4B"/>
                 </a:solidFill>
               </a:rPr>
-              <a:t>• Surging Acquisition Costs: </a:t>
-            </a:r>
-            <a:r>
-              <a:rPr sz="1000">
+              <a:t>• Problem Formulation (1.1): </a:t>
+            </a:r>
+            <a:r>
+              <a:rPr sz="950">
                 <a:solidFill>
                   <a:srgbClr val="0F172A"/>
                 </a:solidFill>
               </a:rPr>
-              <a:t>Digital advertising CAC has increased over 60%, making organic customer retention the primary driver of profitability.</a:t>
+              <a:t>Defined retention economics, surging CAC, and OLTP operational gaps.</a:t>
             </a:r>
           </a:p>
           <a:p>
@@ -4508,20 +4508,20 @@
               </a:spcBef>
             </a:pPr>
             <a:r>
-              <a:rPr b="1" sz="1050">
+              <a:rPr b="1" sz="1000">
                 <a:solidFill>
                   <a:srgbClr val="1E1B4B"/>
                 </a:solidFill>
               </a:rPr>
-              <a:t>• Homogenous Marketing: </a:t>
-            </a:r>
-            <a:r>
-              <a:rPr sz="1000">
+              <a:t>• Requirement Matrix (1.2): </a:t>
+            </a:r>
+            <a:r>
+              <a:rPr sz="950">
                 <a:solidFill>
                   <a:srgbClr val="0F172A"/>
                 </a:solidFill>
               </a:rPr>
-              <a:t>Treating all shoppers equally leads to margin-eroding discounts for customers who would have purchased anyway.</a:t>
+              <a:t>Specified FR-01 through FR-06 and NFR-01 to NFR-03 with hardware specs.</a:t>
             </a:r>
           </a:p>
           <a:p>
@@ -4531,20 +4531,20 @@
               </a:spcBef>
             </a:pPr>
             <a:r>
-              <a:rPr b="1" sz="1050">
+              <a:rPr b="1" sz="1000">
                 <a:solidFill>
                   <a:srgbClr val="1E1B4B"/>
                 </a:solidFill>
               </a:rPr>
-              <a:t>• Undetected Churn Risk: </a:t>
-            </a:r>
-            <a:r>
-              <a:rPr sz="1000">
+              <a:t>• Tech Stack Layering (1.3): </a:t>
+            </a:r>
+            <a:r>
+              <a:rPr sz="950">
                 <a:solidFill>
                   <a:srgbClr val="0F172A"/>
                 </a:solidFill>
               </a:rPr>
-              <a:t>Historically high-value accounts slip into dormancy silently without early churn detection triggers.</a:t>
+              <a:t>Configured Python 3.9, Pandas 2.3, Scikit-Learn 1.6, and Chart.js.</a:t>
             </a:r>
           </a:p>
           <a:p>
@@ -4554,20 +4554,20 @@
               </a:spcBef>
             </a:pPr>
             <a:r>
-              <a:rPr b="1" sz="1050">
+              <a:rPr b="1" sz="1000">
                 <a:solidFill>
                   <a:srgbClr val="1E1B4B"/>
                 </a:solidFill>
               </a:rPr>
-              <a:t>• Missed Lifetime Value: </a:t>
-            </a:r>
-            <a:r>
-              <a:rPr sz="1000">
+              <a:t>• DFD Architecture (2.1): </a:t>
+            </a:r>
+            <a:r>
+              <a:rPr sz="950">
                 <a:solidFill>
                   <a:srgbClr val="0F172A"/>
                 </a:solidFill>
               </a:rPr>
-              <a:t>E-commerce retailers fail to identify and nurture accounts transitioning into Champions.</a:t>
+              <a:t>Constructed Context Level 0, Level 1 Pipeline, and Level 2 Decomposition DFDs.</a:t>
             </a:r>
           </a:p>
         </p:txBody>
@@ -4581,6 +4581,178 @@
         <p:spPr>
           <a:xfrm>
             <a:off x="4425696" y="1371600"/>
+            <a:ext cx="3328416" cy="4754880"/>
+          </a:xfrm>
+          <a:prstGeom prst="roundRect">
+            <a:avLst/>
+          </a:prstGeom>
+          <a:solidFill>
+            <a:srgbClr val="F0FDF4"/>
+          </a:solidFill>
+          <a:ln w="12700">
+            <a:solidFill>
+              <a:srgbClr val="10B981"/>
+            </a:solidFill>
+          </a:ln>
+        </p:spPr>
+        <p:style>
+          <a:lnRef idx="1">
+            <a:schemeClr val="accent1"/>
+          </a:lnRef>
+          <a:fillRef idx="3">
+            <a:schemeClr val="accent1"/>
+          </a:fillRef>
+          <a:effectRef idx="2">
+            <a:schemeClr val="accent1"/>
+          </a:effectRef>
+          <a:fontRef idx="minor">
+            <a:schemeClr val="lt1"/>
+          </a:fontRef>
+        </p:style>
+        <p:txBody>
+          <a:bodyPr rtlCol="0" anchor="ctr"/>
+          <a:lstStyle/>
+          <a:p>
+            <a:pPr algn="ctr"/>
+          </a:p>
+        </p:txBody>
+      </p:sp>
+      <p:sp>
+        <p:nvSpPr>
+          <p:cNvPr id="11" name="TextBox 10"/>
+          <p:cNvSpPr txBox="1"/>
+          <p:nvPr/>
+        </p:nvSpPr>
+        <p:spPr>
+          <a:xfrm>
+            <a:off x="4562856" y="1508760"/>
+            <a:ext cx="3054096" cy="4480560"/>
+          </a:xfrm>
+          <a:prstGeom prst="rect">
+            <a:avLst/>
+          </a:prstGeom>
+          <a:noFill/>
+        </p:spPr>
+        <p:txBody>
+          <a:bodyPr wrap="square">
+            <a:spAutoFit/>
+          </a:bodyPr>
+          <a:lstStyle/>
+          <a:p>
+            <a:pPr>
+              <a:defRPr sz="1350" b="1">
+                <a:solidFill>
+                  <a:srgbClr val="10B981"/>
+                </a:solidFill>
+              </a:defRPr>
+            </a:pPr>
+            <a:r>
+              <a:t>2. Phase 2 Deliverables (20 Marks)</a:t>
+            </a:r>
+          </a:p>
+          <a:p>
+            <a:pPr>
+              <a:spcBef>
+                <a:spcPts val="800"/>
+              </a:spcBef>
+            </a:pPr>
+            <a:r>
+              <a:rPr b="1" sz="1000">
+                <a:solidFill>
+                  <a:srgbClr val="1E1B4B"/>
+                </a:solidFill>
+              </a:rPr>
+              <a:t>• UML Class Diagram (2.3): </a:t>
+            </a:r>
+            <a:r>
+              <a:rPr sz="950">
+                <a:solidFill>
+                  <a:srgbClr val="0F172A"/>
+                </a:solidFill>
+              </a:rPr>
+              <a:t>Domain entity model &amp; pipeline class architecture (TransactionRecord, Refinery, RFM, KMeans).</a:t>
+            </a:r>
+          </a:p>
+          <a:p>
+            <a:pPr>
+              <a:spcBef>
+                <a:spcPts val="800"/>
+              </a:spcBef>
+            </a:pPr>
+            <a:r>
+              <a:rPr b="1" sz="1000">
+                <a:solidFill>
+                  <a:srgbClr val="1E1B4B"/>
+                </a:solidFill>
+              </a:rPr>
+              <a:t>• UML Sequence Diagram (2.4): </a:t>
+            </a:r>
+            <a:r>
+              <a:rPr sz="950">
+                <a:solidFill>
+                  <a:srgbClr val="0F172A"/>
+                </a:solidFill>
+              </a:rPr>
+              <a:t>11-step synchronous/asynchronous message dispatch protocol across system lifelines.</a:t>
+            </a:r>
+          </a:p>
+          <a:p>
+            <a:pPr>
+              <a:spcBef>
+                <a:spcPts val="800"/>
+              </a:spcBef>
+            </a:pPr>
+            <a:r>
+              <a:rPr b="1" sz="1000">
+                <a:solidFill>
+                  <a:srgbClr val="1E1B4B"/>
+                </a:solidFill>
+              </a:rPr>
+              <a:t>• Data Dictionary (3.1): </a:t>
+            </a:r>
+            <a:r>
+              <a:rPr sz="950">
+                <a:solidFill>
+                  <a:srgbClr val="0F172A"/>
+                </a:solidFill>
+              </a:rPr>
+              <a:t>Complete star-schema catalog: FACT_TRANSACTIONS, FACT_REVERSALS, DIM_CUSTOMERS.</a:t>
+            </a:r>
+          </a:p>
+          <a:p>
+            <a:pPr>
+              <a:spcBef>
+                <a:spcPts val="800"/>
+              </a:spcBef>
+            </a:pPr>
+            <a:r>
+              <a:rPr b="1" sz="1000">
+                <a:solidFill>
+                  <a:srgbClr val="1E1B4B"/>
+                </a:solidFill>
+              </a:rPr>
+              <a:t>• Screen Layouts (4.1): </a:t>
+            </a:r>
+            <a:r>
+              <a:rPr sz="950">
+                <a:solidFill>
+                  <a:srgbClr val="0F172A"/>
+                </a:solidFill>
+              </a:rPr>
+              <a:t>Multi-screen UI layouts with operational input validations (VAL-01 to VAL-04).</a:t>
+            </a:r>
+          </a:p>
+        </p:txBody>
+      </p:sp>
+      <p:sp>
+        <p:nvSpPr>
+          <p:cNvPr id="12" name="Rounded Rectangle 11"/>
+          <p:cNvSpPr/>
+          <p:nvPr/>
+        </p:nvSpPr>
+        <p:spPr>
+          <a:xfrm>
+            <a:off x="8119872" y="1371600"/>
             <a:ext cx="3328416" cy="4754880"/>
           </a:xfrm>
           <a:prstGeom prst="roundRect">
@@ -4619,13 +4791,13 @@
       </p:sp>
       <p:sp>
         <p:nvSpPr>
-          <p:cNvPr id="11" name="TextBox 10"/>
+          <p:cNvPr id="13" name="TextBox 12"/>
           <p:cNvSpPr txBox="1"/>
           <p:nvPr/>
         </p:nvSpPr>
         <p:spPr>
           <a:xfrm>
-            <a:off x="4562856" y="1508760"/>
+            <a:off x="8257032" y="1508760"/>
             <a:ext cx="3054096" cy="4480560"/>
           </a:xfrm>
           <a:prstGeom prst="rect">
@@ -4640,14 +4812,14 @@
           <a:lstStyle/>
           <a:p>
             <a:pPr>
-              <a:defRPr sz="1400" b="1">
+              <a:defRPr sz="1350" b="1">
                 <a:solidFill>
                   <a:srgbClr val="7A003C"/>
                 </a:solidFill>
               </a:defRPr>
             </a:pPr>
             <a:r>
-              <a:t>2. Limitations of OLTP Systems</a:t>
+              <a:t>3. Technical Value Proposition</a:t>
             </a:r>
           </a:p>
           <a:p>
@@ -4657,20 +4829,20 @@
               </a:spcBef>
             </a:pPr>
             <a:r>
-              <a:rPr b="1" sz="1050">
+              <a:rPr b="1" sz="1000">
                 <a:solidFill>
                   <a:srgbClr val="1E1B4B"/>
                 </a:solidFill>
               </a:rPr>
-              <a:t>• Order-Centric Storage: </a:t>
-            </a:r>
-            <a:r>
-              <a:rPr sz="1000">
+              <a:t>• Zero Data Leakage: </a:t>
+            </a:r>
+            <a:r>
+              <a:rPr sz="950">
                 <a:solidFill>
                   <a:srgbClr val="0F172A"/>
                 </a:solidFill>
               </a:rPr>
-              <a:t>Traditional databases record individual shopping transactions, not longitudinal customer behavioral lifecycles.</a:t>
+              <a:t>Strict segregation of reversals ensures return items never pollute positive purchase frequency counts.</a:t>
             </a:r>
           </a:p>
           <a:p>
@@ -4680,20 +4852,20 @@
               </a:spcBef>
             </a:pPr>
             <a:r>
-              <a:rPr b="1" sz="1050">
+              <a:rPr b="1" sz="1000">
                 <a:solidFill>
                   <a:srgbClr val="1E1B4B"/>
                 </a:solidFill>
               </a:rPr>
-              <a:t>• Data Quality Deficits: </a:t>
-            </a:r>
-            <a:r>
-              <a:rPr sz="1000">
+              <a:t>• Skew-Resistant Clustering: </a:t>
+            </a:r>
+            <a:r>
+              <a:rPr sz="950">
                 <a:solidFill>
                   <a:srgbClr val="0F172A"/>
                 </a:solidFill>
               </a:rPr>
-              <a:t>Event logs contain guest checkouts lacking CustomerID, cancellations, and administrative line-items.</a:t>
+              <a:t>Log1p scaling neutralizes Pareto monetary power laws for robust K-Means clustering.</a:t>
             </a:r>
           </a:p>
           <a:p>
@@ -4703,20 +4875,20 @@
               </a:spcBef>
             </a:pPr>
             <a:r>
-              <a:rPr b="1" sz="1050">
+              <a:rPr b="1" sz="1000">
                 <a:solidFill>
                   <a:srgbClr val="1E1B4B"/>
                 </a:solidFill>
               </a:rPr>
-              <a:t>• Distribution Anomalies: </a:t>
-            </a:r>
-            <a:r>
-              <a:rPr sz="1000">
+              <a:t>• BI Mart Compatibility: </a:t>
+            </a:r>
+            <a:r>
+              <a:rPr sz="950">
                 <a:solidFill>
                   <a:srgbClr val="0F172A"/>
                 </a:solidFill>
               </a:rPr>
-              <a:t>Extreme wholesale B2B distributor purchases contaminate standard consumer metrics.</a:t>
+              <a:t>Star schema facilitates native query performance in Tableau, Power BI, and SQL engines.</a:t>
             </a:r>
           </a:p>
           <a:p>
@@ -4726,192 +4898,20 @@
               </a:spcBef>
             </a:pPr>
             <a:r>
-              <a:rPr b="1" sz="1050">
+              <a:rPr b="1" sz="1000">
                 <a:solidFill>
                   <a:srgbClr val="1E1B4B"/>
                 </a:solidFill>
               </a:rPr>
-              <a:t>• No Analytical Layer: </a:t>
-            </a:r>
-            <a:r>
-              <a:rPr sz="1000">
+              <a:t>• Instant CRM Activation: </a:t>
+            </a:r>
+            <a:r>
+              <a:rPr sz="950">
                 <a:solidFill>
                   <a:srgbClr val="0F172A"/>
                 </a:solidFill>
               </a:rPr>
-              <a:t>Decision-makers lack an automated transformation pipeline bridging raw order rows with strategic marketing actions.</a:t>
-            </a:r>
-          </a:p>
-        </p:txBody>
-      </p:sp>
-      <p:sp>
-        <p:nvSpPr>
-          <p:cNvPr id="12" name="Rounded Rectangle 11"/>
-          <p:cNvSpPr/>
-          <p:nvPr/>
-        </p:nvSpPr>
-        <p:spPr>
-          <a:xfrm>
-            <a:off x="8119872" y="1371600"/>
-            <a:ext cx="3328416" cy="4754880"/>
-          </a:xfrm>
-          <a:prstGeom prst="roundRect">
-            <a:avLst/>
-          </a:prstGeom>
-          <a:solidFill>
-            <a:srgbClr val="F8FAFC"/>
-          </a:solidFill>
-          <a:ln w="12700">
-            <a:solidFill>
-              <a:srgbClr val="E2E8F0"/>
-            </a:solidFill>
-          </a:ln>
-        </p:spPr>
-        <p:style>
-          <a:lnRef idx="1">
-            <a:schemeClr val="accent1"/>
-          </a:lnRef>
-          <a:fillRef idx="3">
-            <a:schemeClr val="accent1"/>
-          </a:fillRef>
-          <a:effectRef idx="2">
-            <a:schemeClr val="accent1"/>
-          </a:effectRef>
-          <a:fontRef idx="minor">
-            <a:schemeClr val="lt1"/>
-          </a:fontRef>
-        </p:style>
-        <p:txBody>
-          <a:bodyPr rtlCol="0" anchor="ctr"/>
-          <a:lstStyle/>
-          <a:p>
-            <a:pPr algn="ctr"/>
-          </a:p>
-        </p:txBody>
-      </p:sp>
-      <p:sp>
-        <p:nvSpPr>
-          <p:cNvPr id="13" name="TextBox 12"/>
-          <p:cNvSpPr txBox="1"/>
-          <p:nvPr/>
-        </p:nvSpPr>
-        <p:spPr>
-          <a:xfrm>
-            <a:off x="8257032" y="1508760"/>
-            <a:ext cx="3054096" cy="4480560"/>
-          </a:xfrm>
-          <a:prstGeom prst="rect">
-            <a:avLst/>
-          </a:prstGeom>
-          <a:noFill/>
-        </p:spPr>
-        <p:txBody>
-          <a:bodyPr wrap="square">
-            <a:spAutoFit/>
-          </a:bodyPr>
-          <a:lstStyle/>
-          <a:p>
-            <a:pPr>
-              <a:defRPr sz="1400" b="1">
-                <a:solidFill>
-                  <a:srgbClr val="7A003C"/>
-                </a:solidFill>
-              </a:defRPr>
-            </a:pPr>
-            <a:r>
-              <a:t>3. Targeted Project Solution</a:t>
-            </a:r>
-          </a:p>
-          <a:p>
-            <a:pPr>
-              <a:spcBef>
-                <a:spcPts val="800"/>
-              </a:spcBef>
-            </a:pPr>
-            <a:r>
-              <a:rPr b="1" sz="1050">
-                <a:solidFill>
-                  <a:srgbClr val="1E1B4B"/>
-                </a:solidFill>
-              </a:rPr>
-              <a:t>• Automated Refinery: </a:t>
-            </a:r>
-            <a:r>
-              <a:rPr sz="1000">
-                <a:solidFill>
-                  <a:srgbClr val="0F172A"/>
-                </a:solidFill>
-              </a:rPr>
-              <a:t>Cleanses raw transactions, isolates reversals into an audit ledger, and caps outliers via Tukey IQR fences.</a:t>
-            </a:r>
-          </a:p>
-          <a:p>
-            <a:pPr>
-              <a:spcBef>
-                <a:spcPts val="800"/>
-              </a:spcBef>
-            </a:pPr>
-            <a:r>
-              <a:rPr b="1" sz="1050">
-                <a:solidFill>
-                  <a:srgbClr val="1E1B4B"/>
-                </a:solidFill>
-              </a:rPr>
-              <a:t>• Vectorized RFM Feature Store: </a:t>
-            </a:r>
-            <a:r>
-              <a:rPr sz="1000">
-                <a:solidFill>
-                  <a:srgbClr val="0F172A"/>
-                </a:solidFill>
-              </a:rPr>
-              <a:t>Aggregates transactions into Recency, Frequency, Monetary spend, and Average Order Value (AOV).</a:t>
-            </a:r>
-          </a:p>
-          <a:p>
-            <a:pPr>
-              <a:spcBef>
-                <a:spcPts val="800"/>
-              </a:spcBef>
-            </a:pPr>
-            <a:r>
-              <a:rPr b="1" sz="1050">
-                <a:solidFill>
-                  <a:srgbClr val="1E1B4B"/>
-                </a:solidFill>
-              </a:rPr>
-              <a:t>• Skew-Resistant ML Clustering: </a:t>
-            </a:r>
-            <a:r>
-              <a:rPr sz="1000">
-                <a:solidFill>
-                  <a:srgbClr val="0F172A"/>
-                </a:solidFill>
-              </a:rPr>
-              <a:t>Applies log1p and StandardScaler before K-Means modeling, validated via Silhouette diagnostics.</a:t>
-            </a:r>
-          </a:p>
-          <a:p>
-            <a:pPr>
-              <a:spcBef>
-                <a:spcPts val="800"/>
-              </a:spcBef>
-            </a:pPr>
-            <a:r>
-              <a:rPr b="1" sz="1050">
-                <a:solidFill>
-                  <a:srgbClr val="1E1B4B"/>
-                </a:solidFill>
-              </a:rPr>
-              <a:t>• Executive BI Dashboard: </a:t>
-            </a:r>
-            <a:r>
-              <a:rPr sz="1000">
-                <a:solidFill>
-                  <a:srgbClr val="0F172A"/>
-                </a:solidFill>
-              </a:rPr>
-              <a:t>Interactive web UI with portfolio KPI scorecards, spatial scatterplots, and exportable CRM cohorts.</a:t>
+              <a:t>Interactive UI enables commercial teams to filter and export high-value at-risk cohorts instantly.</a:t>
             </a:r>
           </a:p>
         </p:txBody>
@@ -5010,7 +5010,7 @@
               </a:defRPr>
             </a:pPr>
             <a:r>
-              <a:t>SECTION 1.2  •  PRODUCT SPECIFICATIONS</a:t>
+              <a:t>SECTION 2.3  •  SYSTEM DESIGN</a:t>
             </a:r>
           </a:p>
         </p:txBody>
@@ -5046,7 +5046,7 @@
               </a:defRPr>
             </a:pPr>
             <a:r>
-              <a:t>Requirement Specifications (Functional &amp; Non-Functional)</a:t>
+              <a:t>UML Class Diagram (Domain Model &amp; Object Architecture)</a:t>
             </a:r>
           </a:p>
         </p:txBody>
@@ -5163,7 +5163,7 @@
               </a:defRPr>
             </a:pPr>
             <a:r>
-              <a:t>B.Sc. in Artificial Intelligence &amp; Data Science (Sem V)  •  Institute of Advanced Research  •  First Progress Work (24/09/2026)</a:t>
+              <a:t>B.Sc. in Artificial Intelligence &amp; Data Science (Sem V)  •  Institute of Advanced Research  •  Second Progress Work (13/10/2026)</a:t>
             </a:r>
           </a:p>
         </p:txBody>
@@ -5213,16 +5213,40 @@
           </a:p>
         </p:txBody>
       </p:sp>
-      <p:sp>
-        <p:nvSpPr>
-          <p:cNvPr id="9" name="TextBox 8"/>
+      <p:pic>
+        <p:nvPicPr>
+          <p:cNvPr id="9" name="Picture 8" descr="fig_class_diagram.png"/>
+          <p:cNvPicPr>
+            <a:picLocks noChangeAspect="1"/>
+          </p:cNvPicPr>
+          <p:nvPr/>
+        </p:nvPicPr>
+        <p:blipFill>
+          <a:blip r:embed="rId2"/>
+          <a:stretch>
+            <a:fillRect/>
+          </a:stretch>
+        </p:blipFill>
+        <p:spPr>
+          <a:xfrm>
+            <a:off x="868680" y="1554480"/>
+            <a:ext cx="5943600" cy="3714750"/>
+          </a:xfrm>
+          <a:prstGeom prst="rect">
+            <a:avLst/>
+          </a:prstGeom>
+        </p:spPr>
+      </p:pic>
+      <p:sp>
+        <p:nvSpPr>
+          <p:cNvPr id="10" name="TextBox 9"/>
           <p:cNvSpPr txBox="1"/>
           <p:nvPr/>
         </p:nvSpPr>
         <p:spPr>
           <a:xfrm>
-            <a:off x="914400" y="1508760"/>
-            <a:ext cx="5852160" cy="4480560"/>
+            <a:off x="731520" y="5715000"/>
+            <a:ext cx="6217920" cy="320040"/>
           </a:xfrm>
           <a:prstGeom prst="rect">
             <a:avLst/>
@@ -5230,172 +5254,34 @@
           <a:noFill/>
         </p:spPr>
         <p:txBody>
-          <a:bodyPr wrap="square">
+          <a:bodyPr wrap="none">
             <a:spAutoFit/>
           </a:bodyPr>
           <a:lstStyle/>
           <a:p>
-            <a:pPr>
-              <a:defRPr sz="1350" b="1">
-                <a:solidFill>
-                  <a:srgbClr val="7A003C"/>
+            <a:pPr algn="ctr">
+              <a:defRPr sz="950" b="1">
+                <a:solidFill>
+                  <a:srgbClr val="475569"/>
                 </a:solidFill>
               </a:defRPr>
             </a:pPr>
             <a:r>
-              <a:t>Functional Requirements Specifications (FR-01 to FR-06)</a:t>
-            </a:r>
-          </a:p>
-          <a:p>
-            <a:pPr>
-              <a:spcBef>
-                <a:spcPts val="400"/>
-              </a:spcBef>
-            </a:pPr>
-            <a:r>
-              <a:rPr b="1" sz="950">
-                <a:solidFill>
-                  <a:srgbClr val="1E1B4B"/>
-                </a:solidFill>
-              </a:rPr>
-              <a:t>FR-01: Ingestion &amp; Schema Typing: </a:t>
-            </a:r>
-            <a:r>
-              <a:rPr sz="900">
-                <a:solidFill>
-                  <a:srgbClr val="0F172A"/>
-                </a:solidFill>
-              </a:rPr>
-              <a:t>Ingests raw CSV streams, validates typing (InvoiceDate to datetime64[ns], Quantity/UnitPrice to floats), and sanitizes SKU descriptions.</a:t>
-            </a:r>
-          </a:p>
-          <a:p>
-            <a:pPr>
-              <a:spcBef>
-                <a:spcPts val="400"/>
-              </a:spcBef>
-            </a:pPr>
-            <a:r>
-              <a:rPr b="1" sz="950">
-                <a:solidFill>
-                  <a:srgbClr val="1E1B4B"/>
-                </a:solidFill>
-              </a:rPr>
-              <a:t>FR-02: Missing Entity Resolution: </a:t>
-            </a:r>
-            <a:r>
-              <a:rPr sz="900">
-                <a:solidFill>
-                  <a:srgbClr val="0F172A"/>
-                </a:solidFill>
-              </a:rPr>
-              <a:t>Detects and filters guest checkouts missing CustomerID to protect longitudinal cohort integrity.</a:t>
-            </a:r>
-          </a:p>
-          <a:p>
-            <a:pPr>
-              <a:spcBef>
-                <a:spcPts val="400"/>
-              </a:spcBef>
-            </a:pPr>
-            <a:r>
-              <a:rPr b="1" sz="950">
-                <a:solidFill>
-                  <a:srgbClr val="1E1B4B"/>
-                </a:solidFill>
-              </a:rPr>
-              <a:t>FR-03: Reverse Logistics Isolation: </a:t>
-            </a:r>
-            <a:r>
-              <a:rPr sz="900">
-                <a:solidFill>
-                  <a:srgbClr val="0F172A"/>
-                </a:solidFill>
-              </a:rPr>
-              <a:t>Routes cancellations ('^C') and credit adjustments to an isolated audit store (fact_reversals_audit.csv) without distorting purchase counts.</a:t>
-            </a:r>
-          </a:p>
-          <a:p>
-            <a:pPr>
-              <a:spcBef>
-                <a:spcPts val="400"/>
-              </a:spcBef>
-            </a:pPr>
-            <a:r>
-              <a:rPr b="1" sz="950">
-                <a:solidFill>
-                  <a:srgbClr val="1E1B4B"/>
-                </a:solidFill>
-              </a:rPr>
-              <a:t>FR-04: Tukey IQR Outlier Capping: </a:t>
-            </a:r>
-            <a:r>
-              <a:rPr sz="900">
-                <a:solidFill>
-                  <a:srgbClr val="0F172A"/>
-                </a:solidFill>
-              </a:rPr>
-              <a:t>Applies fences [Q1 - 1.5*IQR, Q3 + 1.5*IQR] on Quantity and Price, neutralizing bulk distributor volume spikes.</a:t>
-            </a:r>
-          </a:p>
-          <a:p>
-            <a:pPr>
-              <a:spcBef>
-                <a:spcPts val="400"/>
-              </a:spcBef>
-            </a:pPr>
-            <a:r>
-              <a:rPr b="1" sz="950">
-                <a:solidFill>
-                  <a:srgbClr val="1E1B4B"/>
-                </a:solidFill>
-              </a:rPr>
-              <a:t>FR-05: Vectorized RFM Derivation: </a:t>
-            </a:r>
-            <a:r>
-              <a:rPr sz="900">
-                <a:solidFill>
-                  <a:srgbClr val="0F172A"/>
-                </a:solidFill>
-              </a:rPr>
-              <a:t>Computes Recency days relative to T_obs = max(Date) + 1, Frequency (distinct visits), and cumulative Monetary spend.</a:t>
-            </a:r>
-          </a:p>
-          <a:p>
-            <a:pPr>
-              <a:spcBef>
-                <a:spcPts val="400"/>
-              </a:spcBef>
-            </a:pPr>
-            <a:r>
-              <a:rPr b="1" sz="950">
-                <a:solidFill>
-                  <a:srgbClr val="1E1B4B"/>
-                </a:solidFill>
-              </a:rPr>
-              <a:t>FR-06: ML Clustering &amp; Scoring: </a:t>
-            </a:r>
-            <a:r>
-              <a:rPr sz="900">
-                <a:solidFill>
-                  <a:srgbClr val="0F172A"/>
-                </a:solidFill>
-              </a:rPr>
-              <a:t>Standardizes features via log1p and StandardScaler, fits K-Means, and assigns 1–5 quantile scores mapping to 8 business tiers.</a:t>
-            </a:r>
-          </a:p>
-        </p:txBody>
-      </p:sp>
-      <p:sp>
-        <p:nvSpPr>
-          <p:cNvPr id="10" name="Rounded Rectangle 9"/>
+              <a:t>Figure 2.5: UML Class Diagram (Domain Model &amp; Pipeline Services)</a:t>
+            </a:r>
+          </a:p>
+        </p:txBody>
+      </p:sp>
+      <p:sp>
+        <p:nvSpPr>
+          <p:cNvPr id="11" name="Rounded Rectangle 10"/>
           <p:cNvSpPr/>
           <p:nvPr/>
         </p:nvSpPr>
         <p:spPr>
           <a:xfrm>
             <a:off x="7223760" y="1371600"/>
-            <a:ext cx="4236415" cy="2286000"/>
+            <a:ext cx="4236415" cy="4754880"/>
           </a:xfrm>
           <a:prstGeom prst="roundRect">
             <a:avLst/>
@@ -5433,14 +5319,14 @@
       </p:sp>
       <p:sp>
         <p:nvSpPr>
-          <p:cNvPr id="11" name="TextBox 10"/>
+          <p:cNvPr id="12" name="TextBox 11"/>
           <p:cNvSpPr txBox="1"/>
           <p:nvPr/>
         </p:nvSpPr>
         <p:spPr>
           <a:xfrm>
             <a:off x="7406640" y="1508760"/>
-            <a:ext cx="3840480" cy="2011680"/>
+            <a:ext cx="3840480" cy="4480560"/>
           </a:xfrm>
           <a:prstGeom prst="rect">
             <a:avLst/>
@@ -5454,14 +5340,14 @@
           <a:lstStyle/>
           <a:p>
             <a:pPr>
-              <a:defRPr sz="1300" b="1">
+              <a:defRPr sz="1350" b="1">
                 <a:solidFill>
                   <a:srgbClr val="7A003C"/>
                 </a:solidFill>
               </a:defRPr>
             </a:pPr>
             <a:r>
-              <a:t>Non-Functional Requirements (NFR)</a:t>
+              <a:t>Core Pipeline Classes &amp; Relationships</a:t>
             </a:r>
           </a:p>
           <a:p>
@@ -5476,15 +5362,15 @@
                   <a:srgbClr val="1E1B4B"/>
                 </a:solidFill>
               </a:rPr>
-              <a:t>NFR-01 (Latency): </a:t>
-            </a:r>
-            <a:r>
-              <a:rPr sz="900">
+              <a:t>• TransactionRecord: </a:t>
+            </a:r>
+            <a:r>
+              <a:rPr sz="880">
                 <a:solidFill>
                   <a:srgbClr val="0F172A"/>
                 </a:solidFill>
               </a:rPr>
-              <a:t>Processes 15,000+ orders in &lt;5.0 seconds using vectorized Pandas C-routines.</a:t>
+              <a:t>Domain entity representing single line-item purchases with validation and pricing methods.</a:t>
             </a:r>
           </a:p>
           <a:p>
@@ -5499,15 +5385,15 @@
                   <a:srgbClr val="1E1B4B"/>
                 </a:solidFill>
               </a:rPr>
-              <a:t>NFR-02 (Reproducibility): </a:t>
-            </a:r>
-            <a:r>
-              <a:rPr sz="900">
+              <a:t>• CleanRefineryPipeline: </a:t>
+            </a:r>
+            <a:r>
+              <a:rPr sz="880">
                 <a:solidFill>
                   <a:srgbClr val="0F172A"/>
                 </a:solidFill>
               </a:rPr>
-              <a:t>Fixed seed (seed=42) guarantees 100% deterministic clustering across platforms.</a:t>
+              <a:t>Orchestrates ingestion, typing, guest session filtering, reversal quarantine, and Tukey IQR capping.</a:t>
             </a:r>
           </a:p>
           <a:p>
@@ -5522,101 +5408,21 @@
                   <a:srgbClr val="1E1B4B"/>
                 </a:solidFill>
               </a:rPr>
-              <a:t>NFR-03 (Modularity): </a:t>
-            </a:r>
-            <a:r>
-              <a:rPr sz="900">
+              <a:t>• RFMFeatureEngineer: </a:t>
+            </a:r>
+            <a:r>
+              <a:rPr sz="880">
                 <a:solidFill>
                   <a:srgbClr val="0F172A"/>
                 </a:solidFill>
               </a:rPr>
-              <a:t>Clean star schema data marts (FACT_TRANSACTIONS, DIM_CUSTOMERS).</a:t>
-            </a:r>
-          </a:p>
-        </p:txBody>
-      </p:sp>
-      <p:sp>
-        <p:nvSpPr>
-          <p:cNvPr id="12" name="Rounded Rectangle 11"/>
-          <p:cNvSpPr/>
-          <p:nvPr/>
-        </p:nvSpPr>
-        <p:spPr>
-          <a:xfrm>
-            <a:off x="7223760" y="3840480"/>
-            <a:ext cx="4236415" cy="2286000"/>
-          </a:xfrm>
-          <a:prstGeom prst="roundRect">
-            <a:avLst/>
-          </a:prstGeom>
-          <a:solidFill>
-            <a:srgbClr val="F8FAFC"/>
-          </a:solidFill>
-          <a:ln w="12700">
-            <a:solidFill>
-              <a:srgbClr val="E2E8F0"/>
-            </a:solidFill>
-          </a:ln>
-        </p:spPr>
-        <p:style>
-          <a:lnRef idx="1">
-            <a:schemeClr val="accent1"/>
-          </a:lnRef>
-          <a:fillRef idx="3">
-            <a:schemeClr val="accent1"/>
-          </a:fillRef>
-          <a:effectRef idx="2">
-            <a:schemeClr val="accent1"/>
-          </a:effectRef>
-          <a:fontRef idx="minor">
-            <a:schemeClr val="lt1"/>
-          </a:fontRef>
-        </p:style>
-        <p:txBody>
-          <a:bodyPr rtlCol="0" anchor="ctr"/>
-          <a:lstStyle/>
-          <a:p>
-            <a:pPr algn="ctr"/>
-          </a:p>
-        </p:txBody>
-      </p:sp>
-      <p:sp>
-        <p:nvSpPr>
-          <p:cNvPr id="13" name="TextBox 12"/>
-          <p:cNvSpPr txBox="1"/>
-          <p:nvPr/>
-        </p:nvSpPr>
-        <p:spPr>
-          <a:xfrm>
-            <a:off x="7406640" y="3977639"/>
-            <a:ext cx="3840480" cy="2011680"/>
-          </a:xfrm>
-          <a:prstGeom prst="rect">
-            <a:avLst/>
-          </a:prstGeom>
-          <a:noFill/>
-        </p:spPr>
-        <p:txBody>
-          <a:bodyPr wrap="square">
-            <a:spAutoFit/>
-          </a:bodyPr>
-          <a:lstStyle/>
-          <a:p>
-            <a:pPr>
-              <a:defRPr sz="1300" b="1">
-                <a:solidFill>
-                  <a:srgbClr val="7A003C"/>
-                </a:solidFill>
-              </a:defRPr>
-            </a:pPr>
-            <a:r>
-              <a:t>Table 1.1: System Environment Matrix</a:t>
+              <a:t>Vectorized engine computing customer Recency (T_obs), Frequency, Spend, and AOV.</a:t>
             </a:r>
           </a:p>
           <a:p>
             <a:pPr>
               <a:spcBef>
-                <a:spcPts val="300"/>
+                <a:spcPts val="400"/>
               </a:spcBef>
             </a:pPr>
             <a:r>
@@ -5625,21 +5431,21 @@
                   <a:srgbClr val="1E1B4B"/>
                 </a:solidFill>
               </a:rPr>
-              <a:t>Hardware / CPU: </a:t>
-            </a:r>
-            <a:r>
-              <a:rPr sz="900">
+              <a:t>• KMeansSegmentationEngine: </a:t>
+            </a:r>
+            <a:r>
+              <a:rPr sz="880">
                 <a:solidFill>
                   <a:srgbClr val="0F172A"/>
                 </a:solidFill>
               </a:rPr>
-              <a:t>Apple Silicon M-Series / Intel Core i5/i7 (8-Core+)</a:t>
+              <a:t>Encapsulates log1p compression, StandardScaler, K-Means fitting (k=4), and Silhouette diagnostics.</a:t>
             </a:r>
           </a:p>
           <a:p>
             <a:pPr>
               <a:spcBef>
-                <a:spcPts val="300"/>
+                <a:spcPts val="400"/>
               </a:spcBef>
             </a:pPr>
             <a:r>
@@ -5648,21 +5454,21 @@
                   <a:srgbClr val="1E1B4B"/>
                 </a:solidFill>
               </a:rPr>
-              <a:t>System Memory: </a:t>
-            </a:r>
-            <a:r>
-              <a:rPr sz="900">
+              <a:t>• QuantileStratifier: </a:t>
+            </a:r>
+            <a:r>
+              <a:rPr sz="880">
                 <a:solidFill>
                   <a:srgbClr val="0F172A"/>
                 </a:solidFill>
               </a:rPr>
-              <a:t>8 GB to 16 GB Unified Memory (Min: 4 GB)</a:t>
+              <a:t>Assigns 1–5 quantile scores (pd.qcut) and maps accounts to 8 business operational cohorts.</a:t>
             </a:r>
           </a:p>
           <a:p>
             <a:pPr>
               <a:spcBef>
-                <a:spcPts val="300"/>
+                <a:spcPts val="400"/>
               </a:spcBef>
             </a:pPr>
             <a:r>
@@ -5671,61 +5477,15 @@
                   <a:srgbClr val="1E1B4B"/>
                 </a:solidFill>
               </a:rPr>
-              <a:t>Storage Drive: </a:t>
-            </a:r>
-            <a:r>
-              <a:rPr sz="900">
+              <a:t>• StarSchemaMartExporter: </a:t>
+            </a:r>
+            <a:r>
+              <a:rPr sz="880">
                 <a:solidFill>
                   <a:srgbClr val="0F172A"/>
                 </a:solidFill>
               </a:rPr>
-              <a:t>Solid State Drive (NVMe SSD)</a:t>
-            </a:r>
-          </a:p>
-          <a:p>
-            <a:pPr>
-              <a:spcBef>
-                <a:spcPts val="300"/>
-              </a:spcBef>
-            </a:pPr>
-            <a:r>
-              <a:rPr b="1" sz="950">
-                <a:solidFill>
-                  <a:srgbClr val="1E1B4B"/>
-                </a:solidFill>
-              </a:rPr>
-              <a:t>Operating System: </a:t>
-            </a:r>
-            <a:r>
-              <a:rPr sz="900">
-                <a:solidFill>
-                  <a:srgbClr val="0F172A"/>
-                </a:solidFill>
-              </a:rPr>
-              <a:t>macOS Darwin (Unix POSIX) / Linux / Win10+</a:t>
-            </a:r>
-          </a:p>
-          <a:p>
-            <a:pPr>
-              <a:spcBef>
-                <a:spcPts val="300"/>
-              </a:spcBef>
-            </a:pPr>
-            <a:r>
-              <a:rPr b="1" sz="950">
-                <a:solidFill>
-                  <a:srgbClr val="1E1B4B"/>
-                </a:solidFill>
-              </a:rPr>
-              <a:t>Runtime &amp; Stack: </a:t>
-            </a:r>
-            <a:r>
-              <a:rPr sz="900">
-                <a:solidFill>
-                  <a:srgbClr val="0F172A"/>
-                </a:solidFill>
-              </a:rPr>
-              <a:t>Python 3.9+, Modern Web Browser, VS Code</a:t>
+              <a:t>Generates FACT_TRANSACTIONS, FACT_REVERSALS, DIM_CUSTOMERS, and summary JSON.</a:t>
             </a:r>
           </a:p>
         </p:txBody>
@@ -5824,7 +5584,7 @@
               </a:defRPr>
             </a:pPr>
             <a:r>
-              <a:t>SECTION 1.3  •  ARCHITECTURE STACK</a:t>
+              <a:t>SECTION 2.4  •  EXECUTION ARCHITECTURE</a:t>
             </a:r>
           </a:p>
         </p:txBody>
@@ -5860,7 +5620,7 @@
               </a:defRPr>
             </a:pPr>
             <a:r>
-              <a:t>Tools &amp; Technology Stack (Multi-Layer Architecture)</a:t>
+              <a:t>UML Sequence Diagram (Pipeline Execution Workflow)</a:t>
             </a:r>
           </a:p>
         </p:txBody>
@@ -5977,7 +5737,7 @@
               </a:defRPr>
             </a:pPr>
             <a:r>
-              <a:t>B.Sc. in Artificial Intelligence &amp; Data Science (Sem V)  •  Institute of Advanced Research  •  First Progress Work (24/09/2026)</a:t>
+              <a:t>B.Sc. in Artificial Intelligence &amp; Data Science (Sem V)  •  Institute of Advanced Research  •  Second Progress Work (13/10/2026)</a:t>
             </a:r>
           </a:p>
         </p:txBody>
@@ -5991,319 +5751,7 @@
         <p:spPr>
           <a:xfrm>
             <a:off x="731520" y="1371600"/>
-            <a:ext cx="10728655" cy="1051560"/>
-          </a:xfrm>
-          <a:prstGeom prst="roundRect">
-            <a:avLst/>
-          </a:prstGeom>
-          <a:solidFill>
-            <a:srgbClr val="FEF2F2"/>
-          </a:solidFill>
-          <a:ln w="12700">
-            <a:solidFill>
-              <a:srgbClr val="E2E8F0"/>
-            </a:solidFill>
-          </a:ln>
-        </p:spPr>
-        <p:style>
-          <a:lnRef idx="1">
-            <a:schemeClr val="accent1"/>
-          </a:lnRef>
-          <a:fillRef idx="3">
-            <a:schemeClr val="accent1"/>
-          </a:fillRef>
-          <a:effectRef idx="2">
-            <a:schemeClr val="accent1"/>
-          </a:effectRef>
-          <a:fontRef idx="minor">
-            <a:schemeClr val="lt1"/>
-          </a:fontRef>
-        </p:style>
-        <p:txBody>
-          <a:bodyPr rtlCol="0" anchor="ctr"/>
-          <a:lstStyle/>
-          <a:p>
-            <a:pPr algn="ctr"/>
-          </a:p>
-        </p:txBody>
-      </p:sp>
-      <p:sp>
-        <p:nvSpPr>
-          <p:cNvPr id="9" name="TextBox 8"/>
-          <p:cNvSpPr txBox="1"/>
-          <p:nvPr/>
-        </p:nvSpPr>
-        <p:spPr>
-          <a:xfrm>
-            <a:off x="914400" y="1444752"/>
-            <a:ext cx="10362895" cy="905256"/>
-          </a:xfrm>
-          <a:prstGeom prst="rect">
-            <a:avLst/>
-          </a:prstGeom>
-          <a:noFill/>
-        </p:spPr>
-        <p:txBody>
-          <a:bodyPr wrap="square">
-            <a:spAutoFit/>
-          </a:bodyPr>
-          <a:lstStyle/>
-          <a:p>
-            <a:r>
-              <a:rPr sz="1100" b="1">
-                <a:solidFill>
-                  <a:srgbClr val="7A003C"/>
-                </a:solidFill>
-                <a:latin typeface="Arial"/>
-              </a:rPr>
-              <a:t>1. DATA REFINERY &amp; INGESTION LAYER  </a:t>
-            </a:r>
-            <a:r>
-              <a:rPr sz="1050" b="1">
-                <a:solidFill>
-                  <a:srgbClr val="0F172A"/>
-                </a:solidFill>
-                <a:latin typeface="Arial"/>
-              </a:rPr>
-              <a:t>—  Python 3.9+  •  Pandas (v2.3.3)  •  NumPy (v2.0.2)</a:t>
-            </a:r>
-          </a:p>
-          <a:p>
-            <a:pPr>
-              <a:spcBef>
-                <a:spcPts val="300"/>
-              </a:spcBef>
-            </a:pPr>
-            <a:r>
-              <a:rPr sz="950">
-                <a:solidFill>
-                  <a:srgbClr val="475569"/>
-                </a:solidFill>
-                <a:latin typeface="Arial"/>
-              </a:rPr>
-              <a:t>High-throughput tabular ingestion, schema typing, null elimination, reverse logistics isolation, and vectorized Tukey IQR outlier calculations.</a:t>
-            </a:r>
-          </a:p>
-        </p:txBody>
-      </p:sp>
-      <p:sp>
-        <p:nvSpPr>
-          <p:cNvPr id="10" name="Rounded Rectangle 9"/>
-          <p:cNvSpPr/>
-          <p:nvPr/>
-        </p:nvSpPr>
-        <p:spPr>
-          <a:xfrm>
-            <a:off x="731520" y="2587752"/>
-            <a:ext cx="10728655" cy="1051560"/>
-          </a:xfrm>
-          <a:prstGeom prst="roundRect">
-            <a:avLst/>
-          </a:prstGeom>
-          <a:solidFill>
-            <a:srgbClr val="EFF6FF"/>
-          </a:solidFill>
-          <a:ln w="12700">
-            <a:solidFill>
-              <a:srgbClr val="E2E8F0"/>
-            </a:solidFill>
-          </a:ln>
-        </p:spPr>
-        <p:style>
-          <a:lnRef idx="1">
-            <a:schemeClr val="accent1"/>
-          </a:lnRef>
-          <a:fillRef idx="3">
-            <a:schemeClr val="accent1"/>
-          </a:fillRef>
-          <a:effectRef idx="2">
-            <a:schemeClr val="accent1"/>
-          </a:effectRef>
-          <a:fontRef idx="minor">
-            <a:schemeClr val="lt1"/>
-          </a:fontRef>
-        </p:style>
-        <p:txBody>
-          <a:bodyPr rtlCol="0" anchor="ctr"/>
-          <a:lstStyle/>
-          <a:p>
-            <a:pPr algn="ctr"/>
-          </a:p>
-        </p:txBody>
-      </p:sp>
-      <p:sp>
-        <p:nvSpPr>
-          <p:cNvPr id="11" name="TextBox 10"/>
-          <p:cNvSpPr txBox="1"/>
-          <p:nvPr/>
-        </p:nvSpPr>
-        <p:spPr>
-          <a:xfrm>
-            <a:off x="914400" y="2660904"/>
-            <a:ext cx="10362895" cy="905256"/>
-          </a:xfrm>
-          <a:prstGeom prst="rect">
-            <a:avLst/>
-          </a:prstGeom>
-          <a:noFill/>
-        </p:spPr>
-        <p:txBody>
-          <a:bodyPr wrap="square">
-            <a:spAutoFit/>
-          </a:bodyPr>
-          <a:lstStyle/>
-          <a:p>
-            <a:r>
-              <a:rPr sz="1100" b="1">
-                <a:solidFill>
-                  <a:srgbClr val="2563EB"/>
-                </a:solidFill>
-                <a:latin typeface="Arial"/>
-              </a:rPr>
-              <a:t>2. MACHINE LEARNING &amp; STATISTICAL MODELING  </a:t>
-            </a:r>
-            <a:r>
-              <a:rPr sz="1050" b="1">
-                <a:solidFill>
-                  <a:srgbClr val="0F172A"/>
-                </a:solidFill>
-                <a:latin typeface="Arial"/>
-              </a:rPr>
-              <a:t>—  Scikit-Learn (v1.6.1)  •  SciPy (v1.13.1)</a:t>
-            </a:r>
-          </a:p>
-          <a:p>
-            <a:pPr>
-              <a:spcBef>
-                <a:spcPts val="300"/>
-              </a:spcBef>
-            </a:pPr>
-            <a:r>
-              <a:rPr sz="950">
-                <a:solidFill>
-                  <a:srgbClr val="475569"/>
-                </a:solidFill>
-                <a:latin typeface="Arial"/>
-              </a:rPr>
-              <a:t>Log1p transformation for Pareto skew compression, StandardScaler normalization, K-Means clustering with k-means++ centroid initialization, and Silhouette score diagnostics.</a:t>
-            </a:r>
-          </a:p>
-        </p:txBody>
-      </p:sp>
-      <p:sp>
-        <p:nvSpPr>
-          <p:cNvPr id="12" name="Rounded Rectangle 11"/>
-          <p:cNvSpPr/>
-          <p:nvPr/>
-        </p:nvSpPr>
-        <p:spPr>
-          <a:xfrm>
-            <a:off x="731520" y="3803904"/>
-            <a:ext cx="10728655" cy="1051560"/>
-          </a:xfrm>
-          <a:prstGeom prst="roundRect">
-            <a:avLst/>
-          </a:prstGeom>
-          <a:solidFill>
-            <a:srgbClr val="ECFDF5"/>
-          </a:solidFill>
-          <a:ln w="12700">
-            <a:solidFill>
-              <a:srgbClr val="E2E8F0"/>
-            </a:solidFill>
-          </a:ln>
-        </p:spPr>
-        <p:style>
-          <a:lnRef idx="1">
-            <a:schemeClr val="accent1"/>
-          </a:lnRef>
-          <a:fillRef idx="3">
-            <a:schemeClr val="accent1"/>
-          </a:fillRef>
-          <a:effectRef idx="2">
-            <a:schemeClr val="accent1"/>
-          </a:effectRef>
-          <a:fontRef idx="minor">
-            <a:schemeClr val="lt1"/>
-          </a:fontRef>
-        </p:style>
-        <p:txBody>
-          <a:bodyPr rtlCol="0" anchor="ctr"/>
-          <a:lstStyle/>
-          <a:p>
-            <a:pPr algn="ctr"/>
-          </a:p>
-        </p:txBody>
-      </p:sp>
-      <p:sp>
-        <p:nvSpPr>
-          <p:cNvPr id="13" name="TextBox 12"/>
-          <p:cNvSpPr txBox="1"/>
-          <p:nvPr/>
-        </p:nvSpPr>
-        <p:spPr>
-          <a:xfrm>
-            <a:off x="914400" y="3877056"/>
-            <a:ext cx="10362895" cy="905256"/>
-          </a:xfrm>
-          <a:prstGeom prst="rect">
-            <a:avLst/>
-          </a:prstGeom>
-          <a:noFill/>
-        </p:spPr>
-        <p:txBody>
-          <a:bodyPr wrap="square">
-            <a:spAutoFit/>
-          </a:bodyPr>
-          <a:lstStyle/>
-          <a:p>
-            <a:r>
-              <a:rPr sz="1100" b="1">
-                <a:solidFill>
-                  <a:srgbClr val="10B981"/>
-                </a:solidFill>
-                <a:latin typeface="Arial"/>
-              </a:rPr>
-              <a:t>3. DIMENSIONAL STORAGE &amp; STAR SCHEMA  </a:t>
-            </a:r>
-            <a:r>
-              <a:rPr sz="1050" b="1">
-                <a:solidFill>
-                  <a:srgbClr val="0F172A"/>
-                </a:solidFill>
-                <a:latin typeface="Arial"/>
-              </a:rPr>
-              <a:t>—  Analytical Star Schema Data Marts  •  CSV / Parquet</a:t>
-            </a:r>
-          </a:p>
-          <a:p>
-            <a:pPr>
-              <a:spcBef>
-                <a:spcPts val="300"/>
-              </a:spcBef>
-            </a:pPr>
-            <a:r>
-              <a:rPr sz="950">
-                <a:solidFill>
-                  <a:srgbClr val="475569"/>
-                </a:solidFill>
-                <a:latin typeface="Arial"/>
-              </a:rPr>
-              <a:t>Decoupled fact and dimension storage (FACT_TRANSACTIONS, FACT_REVERSALS, DIM_CUSTOMERS) designed for BI compatibility with Tableau and Power BI.</a:t>
-            </a:r>
-          </a:p>
-        </p:txBody>
-      </p:sp>
-      <p:sp>
-        <p:nvSpPr>
-          <p:cNvPr id="14" name="Rounded Rectangle 13"/>
-          <p:cNvSpPr/>
-          <p:nvPr/>
-        </p:nvSpPr>
-        <p:spPr>
-          <a:xfrm>
-            <a:off x="731520" y="5020056"/>
-            <a:ext cx="10728655" cy="1051560"/>
+            <a:ext cx="6217920" cy="4754880"/>
           </a:xfrm>
           <a:prstGeom prst="roundRect">
             <a:avLst/>
@@ -6339,16 +5787,120 @@
           </a:p>
         </p:txBody>
       </p:sp>
-      <p:sp>
-        <p:nvSpPr>
-          <p:cNvPr id="15" name="TextBox 14"/>
+      <p:pic>
+        <p:nvPicPr>
+          <p:cNvPr id="9" name="Picture 8" descr="fig_sequence_diagram.png"/>
+          <p:cNvPicPr>
+            <a:picLocks noChangeAspect="1"/>
+          </p:cNvPicPr>
+          <p:nvPr/>
+        </p:nvPicPr>
+        <p:blipFill>
+          <a:blip r:embed="rId2"/>
+          <a:stretch>
+            <a:fillRect/>
+          </a:stretch>
+        </p:blipFill>
+        <p:spPr>
+          <a:xfrm>
+            <a:off x="868680" y="1554480"/>
+            <a:ext cx="5943600" cy="3714750"/>
+          </a:xfrm>
+          <a:prstGeom prst="rect">
+            <a:avLst/>
+          </a:prstGeom>
+        </p:spPr>
+      </p:pic>
+      <p:sp>
+        <p:nvSpPr>
+          <p:cNvPr id="10" name="TextBox 9"/>
           <p:cNvSpPr txBox="1"/>
           <p:nvPr/>
         </p:nvSpPr>
         <p:spPr>
           <a:xfrm>
-            <a:off x="914400" y="5093208"/>
-            <a:ext cx="10362895" cy="905256"/>
+            <a:off x="731520" y="5715000"/>
+            <a:ext cx="6217920" cy="320040"/>
+          </a:xfrm>
+          <a:prstGeom prst="rect">
+            <a:avLst/>
+          </a:prstGeom>
+          <a:noFill/>
+        </p:spPr>
+        <p:txBody>
+          <a:bodyPr wrap="none">
+            <a:spAutoFit/>
+          </a:bodyPr>
+          <a:lstStyle/>
+          <a:p>
+            <a:pPr algn="ctr">
+              <a:defRPr sz="950" b="1">
+                <a:solidFill>
+                  <a:srgbClr val="475569"/>
+                </a:solidFill>
+              </a:defRPr>
+            </a:pPr>
+            <a:r>
+              <a:t>Figure 2.6: UML Sequence Diagram (End-to-End Processing &amp; Activation)</a:t>
+            </a:r>
+          </a:p>
+        </p:txBody>
+      </p:sp>
+      <p:sp>
+        <p:nvSpPr>
+          <p:cNvPr id="11" name="Rounded Rectangle 10"/>
+          <p:cNvSpPr/>
+          <p:nvPr/>
+        </p:nvSpPr>
+        <p:spPr>
+          <a:xfrm>
+            <a:off x="7223760" y="1371600"/>
+            <a:ext cx="4236415" cy="4754880"/>
+          </a:xfrm>
+          <a:prstGeom prst="roundRect">
+            <a:avLst/>
+          </a:prstGeom>
+          <a:solidFill>
+            <a:srgbClr val="F8FAFC"/>
+          </a:solidFill>
+          <a:ln w="12700">
+            <a:solidFill>
+              <a:srgbClr val="E2E8F0"/>
+            </a:solidFill>
+          </a:ln>
+        </p:spPr>
+        <p:style>
+          <a:lnRef idx="1">
+            <a:schemeClr val="accent1"/>
+          </a:lnRef>
+          <a:fillRef idx="3">
+            <a:schemeClr val="accent1"/>
+          </a:fillRef>
+          <a:effectRef idx="2">
+            <a:schemeClr val="accent1"/>
+          </a:effectRef>
+          <a:fontRef idx="minor">
+            <a:schemeClr val="lt1"/>
+          </a:fontRef>
+        </p:style>
+        <p:txBody>
+          <a:bodyPr rtlCol="0" anchor="ctr"/>
+          <a:lstStyle/>
+          <a:p>
+            <a:pPr algn="ctr"/>
+          </a:p>
+        </p:txBody>
+      </p:sp>
+      <p:sp>
+        <p:nvSpPr>
+          <p:cNvPr id="12" name="TextBox 11"/>
+          <p:cNvSpPr txBox="1"/>
+          <p:nvPr/>
+        </p:nvSpPr>
+        <p:spPr>
+          <a:xfrm>
+            <a:off x="7406640" y="1508760"/>
+            <a:ext cx="3840480" cy="4480560"/>
           </a:xfrm>
           <a:prstGeom prst="rect">
             <a:avLst/>
@@ -6361,39 +5913,153 @@
           </a:bodyPr>
           <a:lstStyle/>
           <a:p>
-            <a:r>
-              <a:rPr sz="1100" b="1">
+            <a:pPr>
+              <a:defRPr sz="1350" b="1">
+                <a:solidFill>
+                  <a:srgbClr val="7A003C"/>
+                </a:solidFill>
+              </a:defRPr>
+            </a:pPr>
+            <a:r>
+              <a:t>11-Step Message Dispatch Protocol</a:t>
+            </a:r>
+          </a:p>
+          <a:p>
+            <a:pPr>
+              <a:spcBef>
+                <a:spcPts val="400"/>
+              </a:spcBef>
+            </a:pPr>
+            <a:r>
+              <a:rPr b="1" sz="950">
                 <a:solidFill>
                   <a:srgbClr val="1E1B4B"/>
                 </a:solidFill>
-                <a:latin typeface="Arial"/>
-              </a:rPr>
-              <a:t>4. EXECUTIVE BI DASHBOARD &amp; ACTIVATION  </a:t>
-            </a:r>
-            <a:r>
-              <a:rPr sz="1050" b="1">
+              </a:rPr>
+              <a:t>• Step 1 (Trigger): </a:t>
+            </a:r>
+            <a:r>
+              <a:rPr sz="880">
                 <a:solidFill>
                   <a:srgbClr val="0F172A"/>
                 </a:solidFill>
-                <a:latin typeface="Arial"/>
-              </a:rPr>
-              <a:t>—  HTML5  •  Tailwind CSS  •  Chart.js 4.x  •  Git &amp; GitHub</a:t>
+              </a:rPr>
+              <a:t>Data Engineer initiates trigger_pipeline(raw_csv) to commence ingestion.</a:t>
             </a:r>
           </a:p>
           <a:p>
             <a:pPr>
               <a:spcBef>
-                <a:spcPts val="300"/>
+                <a:spcPts val="400"/>
               </a:spcBef>
             </a:pPr>
             <a:r>
-              <a:rPr sz="950">
-                <a:solidFill>
-                  <a:srgbClr val="475569"/>
-                </a:solidFill>
-                <a:latin typeface="Arial"/>
-              </a:rPr>
-              <a:t>Client-side canvas graphing engine rendering revenue donuts, spatial RFM bubble charts, KPI scorecards, and searchable CRM activation grids.</a:t>
+              <a:rPr b="1" sz="950">
+                <a:solidFill>
+                  <a:srgbClr val="1E1B4B"/>
+                </a:solidFill>
+              </a:rPr>
+              <a:t>• Steps 2-3 (Refinery): </a:t>
+            </a:r>
+            <a:r>
+              <a:rPr sz="880">
+                <a:solidFill>
+                  <a:srgbClr val="0F172A"/>
+                </a:solidFill>
+              </a:rPr>
+              <a:t>Self-calls filter unauthenticated sessions, quarantine cancellations, and cap Tukey IQR outliers.</a:t>
+            </a:r>
+          </a:p>
+          <a:p>
+            <a:pPr>
+              <a:spcBef>
+                <a:spcPts val="400"/>
+              </a:spcBef>
+            </a:pPr>
+            <a:r>
+              <a:rPr b="1" sz="950">
+                <a:solidFill>
+                  <a:srgbClr val="1E1B4B"/>
+                </a:solidFill>
+              </a:rPr>
+              <a:t>• Steps 4-5 (Feature Extraction): </a:t>
+            </a:r>
+            <a:r>
+              <a:rPr sz="880">
+                <a:solidFill>
+                  <a:srgbClr val="0F172A"/>
+                </a:solidFill>
+              </a:rPr>
+              <a:t>Cleansed records dispatched to RFMFeatureEngineer, deriving snapshot boundary T_obs.</a:t>
+            </a:r>
+          </a:p>
+          <a:p>
+            <a:pPr>
+              <a:spcBef>
+                <a:spcPts val="400"/>
+              </a:spcBef>
+            </a:pPr>
+            <a:r>
+              <a:rPr b="1" sz="950">
+                <a:solidFill>
+                  <a:srgbClr val="1E1B4B"/>
+                </a:solidFill>
+              </a:rPr>
+              <a:t>• Steps 6-7 (ML Modeling): </a:t>
+            </a:r>
+            <a:r>
+              <a:rPr sz="880">
+                <a:solidFill>
+                  <a:srgbClr val="0F172A"/>
+                </a:solidFill>
+              </a:rPr>
+              <a:t>RFM Analytical Base Table dispatched to KMeansEngine for log1p scaling and k=4 clustering.</a:t>
+            </a:r>
+          </a:p>
+          <a:p>
+            <a:pPr>
+              <a:spcBef>
+                <a:spcPts val="400"/>
+              </a:spcBef>
+            </a:pPr>
+            <a:r>
+              <a:rPr b="1" sz="950">
+                <a:solidFill>
+                  <a:srgbClr val="1E1B4B"/>
+                </a:solidFill>
+              </a:rPr>
+              <a:t>• Steps 8-9 (Data Mart Export): </a:t>
+            </a:r>
+            <a:r>
+              <a:rPr sz="880">
+                <a:solidFill>
+                  <a:srgbClr val="0F172A"/>
+                </a:solidFill>
+              </a:rPr>
+              <a:t>Segments and fact tables persisted to StarSchemaDataMart.</a:t>
+            </a:r>
+          </a:p>
+          <a:p>
+            <a:pPr>
+              <a:spcBef>
+                <a:spcPts val="400"/>
+              </a:spcBef>
+            </a:pPr>
+            <a:r>
+              <a:rPr b="1" sz="950">
+                <a:solidFill>
+                  <a:srgbClr val="1E1B4B"/>
+                </a:solidFill>
+              </a:rPr>
+              <a:t>• Steps 10-11 (Activation): </a:t>
+            </a:r>
+            <a:r>
+              <a:rPr sz="880">
+                <a:solidFill>
+                  <a:srgbClr val="0F172A"/>
+                </a:solidFill>
+              </a:rPr>
+              <a:t>Summary JSON exported to ExecutiveDashboard, rendering KPI cards and spatial scatterplots.</a:t>
             </a:r>
           </a:p>
         </p:txBody>
@@ -6492,7 +6158,7 @@
               </a:defRPr>
             </a:pPr>
             <a:r>
-              <a:t>SECTION 2.1  •  SYSTEM DESIGN USING DFD</a:t>
+              <a:t>SECTION 3.1  •  DATA DICTIONARY</a:t>
             </a:r>
           </a:p>
         </p:txBody>
@@ -6528,7 +6194,7 @@
               </a:defRPr>
             </a:pPr>
             <a:r>
-              <a:t>Level 0 Data Flow Diagram (Context Architecture)</a:t>
+              <a:t>Data Dictionary: Fact Tables (FACT_TRANSACTIONS &amp; FACT_REVERSALS)</a:t>
             </a:r>
           </a:p>
         </p:txBody>
@@ -6645,7 +6311,7 @@
               </a:defRPr>
             </a:pPr>
             <a:r>
-              <a:t>B.Sc. in Artificial Intelligence &amp; Data Science (Sem V)  •  Institute of Advanced Research  •  First Progress Work (24/09/2026)</a:t>
+              <a:t>B.Sc. in Artificial Intelligence &amp; Data Science (Sem V)  •  Institute of Advanced Research  •  Second Progress Work (13/10/2026)</a:t>
             </a:r>
           </a:p>
         </p:txBody>
@@ -6659,7 +6325,7 @@
         <p:spPr>
           <a:xfrm>
             <a:off x="731520" y="1371600"/>
-            <a:ext cx="6217920" cy="4754880"/>
+            <a:ext cx="5212080" cy="4754880"/>
           </a:xfrm>
           <a:prstGeom prst="roundRect">
             <a:avLst/>
@@ -6695,75 +6361,235 @@
           </a:p>
         </p:txBody>
       </p:sp>
-      <p:pic>
-        <p:nvPicPr>
-          <p:cNvPr id="9" name="Picture 8" descr="fig_dfd_level_0.png"/>
-          <p:cNvPicPr>
-            <a:picLocks noChangeAspect="1"/>
-          </p:cNvPicPr>
-          <p:nvPr/>
-        </p:nvPicPr>
-        <p:blipFill>
-          <a:blip r:embed="rId2"/>
-          <a:stretch>
-            <a:fillRect/>
-          </a:stretch>
-        </p:blipFill>
-        <p:spPr>
-          <a:xfrm>
-            <a:off x="914400" y="1600200"/>
-            <a:ext cx="5852160" cy="2926080"/>
+      <p:sp>
+        <p:nvSpPr>
+          <p:cNvPr id="9" name="TextBox 8"/>
+          <p:cNvSpPr txBox="1"/>
+          <p:nvPr/>
+        </p:nvSpPr>
+        <p:spPr>
+          <a:xfrm>
+            <a:off x="914400" y="1508760"/>
+            <a:ext cx="4846320" cy="4480560"/>
           </a:xfrm>
           <a:prstGeom prst="rect">
             <a:avLst/>
           </a:prstGeom>
-        </p:spPr>
-      </p:pic>
-      <p:sp>
-        <p:nvSpPr>
-          <p:cNvPr id="10" name="TextBox 9"/>
-          <p:cNvSpPr txBox="1"/>
-          <p:nvPr/>
-        </p:nvSpPr>
-        <p:spPr>
-          <a:xfrm>
-            <a:off x="731520" y="5715000"/>
-            <a:ext cx="6217920" cy="320040"/>
-          </a:xfrm>
-          <a:prstGeom prst="rect">
-            <a:avLst/>
-          </a:prstGeom>
           <a:noFill/>
         </p:spPr>
         <p:txBody>
-          <a:bodyPr wrap="none">
+          <a:bodyPr wrap="square">
             <a:spAutoFit/>
           </a:bodyPr>
           <a:lstStyle/>
           <a:p>
-            <a:pPr algn="ctr">
-              <a:defRPr sz="950" b="1">
-                <a:solidFill>
-                  <a:srgbClr val="475569"/>
+            <a:pPr>
+              <a:defRPr sz="1300" b="1">
+                <a:solidFill>
+                  <a:srgbClr val="7A003C"/>
                 </a:solidFill>
               </a:defRPr>
             </a:pPr>
             <a:r>
-              <a:t>Figure 2.1: Level 0 Context Data Flow Diagram (Macro Boundary)</a:t>
-            </a:r>
-          </a:p>
-        </p:txBody>
-      </p:sp>
-      <p:sp>
-        <p:nvSpPr>
-          <p:cNvPr id="11" name="Rounded Rectangle 10"/>
+              <a:t>Table 3.1: FACT_TRANSACTIONS (Order Fact Mart)</a:t>
+            </a:r>
+          </a:p>
+          <a:p>
+            <a:pPr>
+              <a:spcBef>
+                <a:spcPts val="300"/>
+              </a:spcBef>
+            </a:pPr>
+            <a:r>
+              <a:rPr b="1" sz="900">
+                <a:solidFill>
+                  <a:srgbClr val="1E1B4B"/>
+                </a:solidFill>
+              </a:rPr>
+              <a:t>• transaction_id (BIGINT, PK): </a:t>
+            </a:r>
+            <a:r>
+              <a:rPr sz="850">
+                <a:solidFill>
+                  <a:srgbClr val="0F172A"/>
+                </a:solidFill>
+              </a:rPr>
+              <a:t>Surrogate primary key generated monotonically.</a:t>
+            </a:r>
+          </a:p>
+          <a:p>
+            <a:pPr>
+              <a:spcBef>
+                <a:spcPts val="300"/>
+              </a:spcBef>
+            </a:pPr>
+            <a:r>
+              <a:rPr b="1" sz="900">
+                <a:solidFill>
+                  <a:srgbClr val="1E1B4B"/>
+                </a:solidFill>
+              </a:rPr>
+              <a:t>• invoice_no (VARCHAR(20)): </a:t>
+            </a:r>
+            <a:r>
+              <a:rPr sz="850">
+                <a:solidFill>
+                  <a:srgbClr val="0F172A"/>
+                </a:solidFill>
+              </a:rPr>
+              <a:t>6-digit order identifier (e.g. 536365).</a:t>
+            </a:r>
+          </a:p>
+          <a:p>
+            <a:pPr>
+              <a:spcBef>
+                <a:spcPts val="300"/>
+              </a:spcBef>
+            </a:pPr>
+            <a:r>
+              <a:rPr b="1" sz="900">
+                <a:solidFill>
+                  <a:srgbClr val="1E1B4B"/>
+                </a:solidFill>
+              </a:rPr>
+              <a:t>• stock_code (VARCHAR(20), FK): </a:t>
+            </a:r>
+            <a:r>
+              <a:rPr sz="850">
+                <a:solidFill>
+                  <a:srgbClr val="0F172A"/>
+                </a:solidFill>
+              </a:rPr>
+              <a:t>Foreign key referencing DIM_PRODUCTS.</a:t>
+            </a:r>
+          </a:p>
+          <a:p>
+            <a:pPr>
+              <a:spcBef>
+                <a:spcPts val="300"/>
+              </a:spcBef>
+            </a:pPr>
+            <a:r>
+              <a:rPr b="1" sz="900">
+                <a:solidFill>
+                  <a:srgbClr val="1E1B4B"/>
+                </a:solidFill>
+              </a:rPr>
+              <a:t>• quantity (INTEGER): </a:t>
+            </a:r>
+            <a:r>
+              <a:rPr sz="850">
+                <a:solidFill>
+                  <a:srgbClr val="0F172A"/>
+                </a:solidFill>
+              </a:rPr>
+              <a:t>Item units purchased; strictly Quantity &gt; 0.</a:t>
+            </a:r>
+          </a:p>
+          <a:p>
+            <a:pPr>
+              <a:spcBef>
+                <a:spcPts val="300"/>
+              </a:spcBef>
+            </a:pPr>
+            <a:r>
+              <a:rPr b="1" sz="900">
+                <a:solidFill>
+                  <a:srgbClr val="1E1B4B"/>
+                </a:solidFill>
+              </a:rPr>
+              <a:t>• invoice_date (TIMESTAMP, FK): </a:t>
+            </a:r>
+            <a:r>
+              <a:rPr sz="850">
+                <a:solidFill>
+                  <a:srgbClr val="0F172A"/>
+                </a:solidFill>
+              </a:rPr>
+              <a:t>Transaction timestamp referencing DIM_DATE.</a:t>
+            </a:r>
+          </a:p>
+          <a:p>
+            <a:pPr>
+              <a:spcBef>
+                <a:spcPts val="300"/>
+              </a:spcBef>
+            </a:pPr>
+            <a:r>
+              <a:rPr b="1" sz="900">
+                <a:solidFill>
+                  <a:srgbClr val="1E1B4B"/>
+                </a:solidFill>
+              </a:rPr>
+              <a:t>• unit_price (DECIMAL(10,2)): </a:t>
+            </a:r>
+            <a:r>
+              <a:rPr sz="850">
+                <a:solidFill>
+                  <a:srgbClr val="0F172A"/>
+                </a:solidFill>
+              </a:rPr>
+              <a:t>Product sale unit price; strictly UnitPrice &gt; 0.</a:t>
+            </a:r>
+          </a:p>
+          <a:p>
+            <a:pPr>
+              <a:spcBef>
+                <a:spcPts val="300"/>
+              </a:spcBef>
+            </a:pPr>
+            <a:r>
+              <a:rPr b="1" sz="900">
+                <a:solidFill>
+                  <a:srgbClr val="1E1B4B"/>
+                </a:solidFill>
+              </a:rPr>
+              <a:t>• customer_id (VARCHAR(20), FK): </a:t>
+            </a:r>
+            <a:r>
+              <a:rPr sz="850">
+                <a:solidFill>
+                  <a:srgbClr val="0F172A"/>
+                </a:solidFill>
+              </a:rPr>
+              <a:t>Foreign key referencing DIM_CUSTOMERS.</a:t>
+            </a:r>
+          </a:p>
+          <a:p>
+            <a:pPr>
+              <a:spcBef>
+                <a:spcPts val="300"/>
+              </a:spcBef>
+            </a:pPr>
+            <a:r>
+              <a:rPr b="1" sz="900">
+                <a:solidFill>
+                  <a:srgbClr val="1E1B4B"/>
+                </a:solidFill>
+              </a:rPr>
+              <a:t>• gross_amount (DECIMAL(12,2)): </a:t>
+            </a:r>
+            <a:r>
+              <a:rPr sz="850">
+                <a:solidFill>
+                  <a:srgbClr val="0F172A"/>
+                </a:solidFill>
+              </a:rPr>
+              <a:t>Line spend: Quantity * UnitPrice.</a:t>
+            </a:r>
+          </a:p>
+        </p:txBody>
+      </p:sp>
+      <p:sp>
+        <p:nvSpPr>
+          <p:cNvPr id="10" name="Rounded Rectangle 9"/>
           <p:cNvSpPr/>
           <p:nvPr/>
         </p:nvSpPr>
         <p:spPr>
           <a:xfrm>
-            <a:off x="7223760" y="1371600"/>
-            <a:ext cx="4236415" cy="4754880"/>
+            <a:off x="6217920" y="1371600"/>
+            <a:ext cx="5242255" cy="4754880"/>
           </a:xfrm>
           <a:prstGeom prst="roundRect">
             <a:avLst/>
@@ -6801,14 +6627,14 @@
       </p:sp>
       <p:sp>
         <p:nvSpPr>
-          <p:cNvPr id="12" name="TextBox 11"/>
+          <p:cNvPr id="11" name="TextBox 10"/>
           <p:cNvSpPr txBox="1"/>
           <p:nvPr/>
         </p:nvSpPr>
         <p:spPr>
           <a:xfrm>
-            <a:off x="7406640" y="1508760"/>
-            <a:ext cx="3840480" cy="4480560"/>
+            <a:off x="6400800" y="1508760"/>
+            <a:ext cx="4846320" cy="4480560"/>
           </a:xfrm>
           <a:prstGeom prst="rect">
             <a:avLst/>
@@ -6822,129 +6648,198 @@
           <a:lstStyle/>
           <a:p>
             <a:pPr>
-              <a:defRPr sz="1350" b="1">
+              <a:defRPr sz="1300" b="1">
                 <a:solidFill>
                   <a:srgbClr val="7A003C"/>
                 </a:solidFill>
               </a:defRPr>
             </a:pPr>
             <a:r>
-              <a:t>Context Boundary &amp; Entity Interfaces</a:t>
+              <a:t>Table 3.2: FACT_REVERSALS (Audit Fact Mart)</a:t>
             </a:r>
           </a:p>
           <a:p>
             <a:pPr>
               <a:spcBef>
-                <a:spcPts val="600"/>
+                <a:spcPts val="300"/>
               </a:spcBef>
             </a:pPr>
             <a:r>
-              <a:rPr b="1" sz="950">
+              <a:rPr b="1" sz="900">
                 <a:solidFill>
                   <a:srgbClr val="1E1B4B"/>
                 </a:solidFill>
               </a:rPr>
-              <a:t>• Process 0.0 (Global Boundary): </a:t>
-            </a:r>
-            <a:r>
-              <a:rPr sz="900">
+              <a:t>• reversal_id (BIGINT, PK): </a:t>
+            </a:r>
+            <a:r>
+              <a:rPr sz="850">
                 <a:solidFill>
                   <a:srgbClr val="0F172A"/>
                 </a:solidFill>
               </a:rPr>
-              <a:t>Represents the complete 'E-Commerce Customer Lifecycle &amp; RFM Analytics System' interacting with 4 primary external entities.</a:t>
+              <a:t>Surrogate primary key for return audit records.</a:t>
             </a:r>
           </a:p>
           <a:p>
             <a:pPr>
               <a:spcBef>
-                <a:spcPts val="600"/>
+                <a:spcPts val="300"/>
               </a:spcBef>
             </a:pPr>
             <a:r>
-              <a:rPr b="1" sz="950">
+              <a:rPr b="1" sz="900">
                 <a:solidFill>
                   <a:srgbClr val="1E1B4B"/>
                 </a:solidFill>
               </a:rPr>
-              <a:t>• 1. OLTP Sales Stream: </a:t>
-            </a:r>
-            <a:r>
-              <a:rPr sz="900">
+              <a:t>• invoice_no (VARCHAR(20)): </a:t>
+            </a:r>
+            <a:r>
+              <a:rPr sz="850">
                 <a:solidFill>
                   <a:srgbClr val="0F172A"/>
                 </a:solidFill>
               </a:rPr>
-              <a:t>Provides high-frequency transaction logs containing InvoiceNo, StockCode, Quantity, InvoiceDate, UnitPrice, and CustomerID.</a:t>
+              <a:t>Cancellation invoice matching regex '^C[0-9]+'.</a:t>
             </a:r>
           </a:p>
           <a:p>
             <a:pPr>
               <a:spcBef>
-                <a:spcPts val="600"/>
+                <a:spcPts val="300"/>
               </a:spcBef>
             </a:pPr>
             <a:r>
-              <a:rPr b="1" sz="950">
+              <a:rPr b="1" sz="900">
                 <a:solidFill>
                   <a:srgbClr val="1E1B4B"/>
                 </a:solidFill>
               </a:rPr>
-              <a:t>• 2. Data Scientist: </a:t>
-            </a:r>
-            <a:r>
-              <a:rPr sz="900">
+              <a:t>• stock_code (VARCHAR(20), FK): </a:t>
+            </a:r>
+            <a:r>
+              <a:rPr sz="850">
                 <a:solidFill>
                   <a:srgbClr val="0F172A"/>
                 </a:solidFill>
               </a:rPr>
-              <a:t>Supplies IQR outlier tuning multipliers, cluster count hyperparameters (k in [2..6]), and evaluates validation diagnostics.</a:t>
+              <a:t>Foreign key referencing returned product SKU.</a:t>
             </a:r>
           </a:p>
           <a:p>
             <a:pPr>
               <a:spcBef>
-                <a:spcPts val="600"/>
+                <a:spcPts val="300"/>
               </a:spcBef>
             </a:pPr>
             <a:r>
-              <a:rPr b="1" sz="950">
+              <a:rPr b="1" sz="900">
                 <a:solidFill>
                   <a:srgbClr val="1E1B4B"/>
                 </a:solidFill>
               </a:rPr>
-              <a:t>• 3. CRM Marketing Engine: </a:t>
-            </a:r>
-            <a:r>
-              <a:rPr sz="900">
+              <a:t>• return_quantity (INTEGER): </a:t>
+            </a:r>
+            <a:r>
+              <a:rPr sz="850">
                 <a:solidFill>
                   <a:srgbClr val="0F172A"/>
                 </a:solidFill>
               </a:rPr>
-              <a:t>Consumes segmented customer lists ('Champions', 'At Risk Whales') for programmatic email, SMS, and ad audience targeting.</a:t>
+              <a:t>Negative units returned (Quantity &lt; 0).</a:t>
             </a:r>
           </a:p>
           <a:p>
             <a:pPr>
               <a:spcBef>
-                <a:spcPts val="600"/>
+                <a:spcPts val="300"/>
               </a:spcBef>
             </a:pPr>
             <a:r>
-              <a:rPr b="1" sz="950">
+              <a:rPr b="1" sz="900">
                 <a:solidFill>
                   <a:srgbClr val="1E1B4B"/>
                 </a:solidFill>
               </a:rPr>
-              <a:t>• 4. Commercial Executives: </a:t>
-            </a:r>
-            <a:r>
-              <a:rPr sz="900">
+              <a:t>• reversal_date (TIMESTAMP, FK): </a:t>
+            </a:r>
+            <a:r>
+              <a:rPr sz="850">
                 <a:solidFill>
                   <a:srgbClr val="0F172A"/>
                 </a:solidFill>
               </a:rPr>
-              <a:t>Receives interactive executive KPI scorecards, segment revenue distribution, and churn risk summaries.</a:t>
+              <a:t>Timestamp when cancellation was processed.</a:t>
+            </a:r>
+          </a:p>
+          <a:p>
+            <a:pPr>
+              <a:spcBef>
+                <a:spcPts val="300"/>
+              </a:spcBef>
+            </a:pPr>
+            <a:r>
+              <a:rPr b="1" sz="900">
+                <a:solidFill>
+                  <a:srgbClr val="1E1B4B"/>
+                </a:solidFill>
+              </a:rPr>
+              <a:t>• unit_price (DECIMAL(10,2)): </a:t>
+            </a:r>
+            <a:r>
+              <a:rPr sz="850">
+                <a:solidFill>
+                  <a:srgbClr val="0F172A"/>
+                </a:solidFill>
+              </a:rPr>
+              <a:t>Original sale unit price of returned item.</a:t>
+            </a:r>
+          </a:p>
+          <a:p>
+            <a:pPr>
+              <a:spcBef>
+                <a:spcPts val="300"/>
+              </a:spcBef>
+            </a:pPr>
+            <a:r>
+              <a:rPr b="1" sz="900">
+                <a:solidFill>
+                  <a:srgbClr val="1E1B4B"/>
+                </a:solidFill>
+              </a:rPr>
+              <a:t>• customer_id (VARCHAR(20), FK): </a:t>
+            </a:r>
+            <a:r>
+              <a:rPr sz="850">
+                <a:solidFill>
+                  <a:srgbClr val="0F172A"/>
+                </a:solidFill>
+              </a:rPr>
+              <a:t>Foreign key referencing customer returning items.</a:t>
+            </a:r>
+          </a:p>
+          <a:p>
+            <a:pPr>
+              <a:spcBef>
+                <a:spcPts val="300"/>
+              </a:spcBef>
+            </a:pPr>
+            <a:r>
+              <a:rPr b="1" sz="900">
+                <a:solidFill>
+                  <a:srgbClr val="1E1B4B"/>
+                </a:solidFill>
+              </a:rPr>
+              <a:t>• Operational Integrity: </a:t>
+            </a:r>
+            <a:r>
+              <a:rPr sz="850">
+                <a:solidFill>
+                  <a:srgbClr val="0F172A"/>
+                </a:solidFill>
+              </a:rPr>
+              <a:t>Quarantined in fact_reversals_audit.csv to ensure return events never distort positive spend metrics.</a:t>
             </a:r>
           </a:p>
         </p:txBody>
@@ -7043,7 +6938,7 @@
               </a:defRPr>
             </a:pPr>
             <a:r>
-              <a:t>SECTION 2.1  •  PIPELINE ARCHITECTURE</a:t>
+              <a:t>SECTION 3.1  •  DATA DICTIONARY</a:t>
             </a:r>
           </a:p>
         </p:txBody>
@@ -7079,7 +6974,7 @@
               </a:defRPr>
             </a:pPr>
             <a:r>
-              <a:t>Level 1 Data Flow Diagram (End-to-End Analytics Pipeline)</a:t>
+              <a:t>Data Dictionary: Dimension Tables (DIM_CUSTOMERS &amp; DIM_PRODUCTS)</a:t>
             </a:r>
           </a:p>
         </p:txBody>
@@ -7196,7 +7091,7 @@
               </a:defRPr>
             </a:pPr>
             <a:r>
-              <a:t>B.Sc. in Artificial Intelligence &amp; Data Science (Sem V)  •  Institute of Advanced Research  •  First Progress Work (24/09/2026)</a:t>
+              <a:t>B.Sc. in Artificial Intelligence &amp; Data Science (Sem V)  •  Institute of Advanced Research  •  Second Progress Work (13/10/2026)</a:t>
             </a:r>
           </a:p>
         </p:txBody>
@@ -7210,7 +7105,7 @@
         <p:spPr>
           <a:xfrm>
             <a:off x="731520" y="1371600"/>
-            <a:ext cx="6217920" cy="4754880"/>
+            <a:ext cx="5486400" cy="4754880"/>
           </a:xfrm>
           <a:prstGeom prst="roundRect">
             <a:avLst/>
@@ -7246,75 +7141,235 @@
           </a:p>
         </p:txBody>
       </p:sp>
-      <p:pic>
-        <p:nvPicPr>
-          <p:cNvPr id="9" name="Picture 8" descr="fig_dfd_level_1.png"/>
-          <p:cNvPicPr>
-            <a:picLocks noChangeAspect="1"/>
-          </p:cNvPicPr>
-          <p:nvPr/>
-        </p:nvPicPr>
-        <p:blipFill>
-          <a:blip r:embed="rId2"/>
-          <a:stretch>
-            <a:fillRect/>
-          </a:stretch>
-        </p:blipFill>
-        <p:spPr>
-          <a:xfrm>
-            <a:off x="914400" y="1600200"/>
-            <a:ext cx="5852160" cy="2926080"/>
+      <p:sp>
+        <p:nvSpPr>
+          <p:cNvPr id="9" name="TextBox 8"/>
+          <p:cNvSpPr txBox="1"/>
+          <p:nvPr/>
+        </p:nvSpPr>
+        <p:spPr>
+          <a:xfrm>
+            <a:off x="914400" y="1508760"/>
+            <a:ext cx="5120640" cy="4480560"/>
           </a:xfrm>
           <a:prstGeom prst="rect">
             <a:avLst/>
           </a:prstGeom>
-        </p:spPr>
-      </p:pic>
-      <p:sp>
-        <p:nvSpPr>
-          <p:cNvPr id="10" name="TextBox 9"/>
-          <p:cNvSpPr txBox="1"/>
-          <p:nvPr/>
-        </p:nvSpPr>
-        <p:spPr>
-          <a:xfrm>
-            <a:off x="731520" y="5715000"/>
-            <a:ext cx="6217920" cy="320040"/>
-          </a:xfrm>
-          <a:prstGeom prst="rect">
-            <a:avLst/>
-          </a:prstGeom>
           <a:noFill/>
         </p:spPr>
         <p:txBody>
-          <a:bodyPr wrap="none">
+          <a:bodyPr wrap="square">
             <a:spAutoFit/>
           </a:bodyPr>
           <a:lstStyle/>
           <a:p>
-            <a:pPr algn="ctr">
-              <a:defRPr sz="950" b="1">
-                <a:solidFill>
-                  <a:srgbClr val="475569"/>
+            <a:pPr>
+              <a:defRPr sz="1300" b="1">
+                <a:solidFill>
+                  <a:srgbClr val="7A003C"/>
                 </a:solidFill>
               </a:defRPr>
             </a:pPr>
             <a:r>
-              <a:t>Figure 2.2: Level 1 Data Flow Diagram (Pipeline Architecture)</a:t>
-            </a:r>
-          </a:p>
-        </p:txBody>
-      </p:sp>
-      <p:sp>
-        <p:nvSpPr>
-          <p:cNvPr id="11" name="Rounded Rectangle 10"/>
+              <a:t>Table 3.3: DIM_CUSTOMERS (RFM Behavioral Mart)</a:t>
+            </a:r>
+          </a:p>
+          <a:p>
+            <a:pPr>
+              <a:spcBef>
+                <a:spcPts val="300"/>
+              </a:spcBef>
+            </a:pPr>
+            <a:r>
+              <a:rPr b="1" sz="900">
+                <a:solidFill>
+                  <a:srgbClr val="1E1B4B"/>
+                </a:solidFill>
+              </a:rPr>
+              <a:t>• customer_key (BIGINT, PK): </a:t>
+            </a:r>
+            <a:r>
+              <a:rPr sz="850">
+                <a:solidFill>
+                  <a:srgbClr val="0F172A"/>
+                </a:solidFill>
+              </a:rPr>
+              <a:t>Surrogate primary key for customer dimension.</a:t>
+            </a:r>
+          </a:p>
+          <a:p>
+            <a:pPr>
+              <a:spcBef>
+                <a:spcPts val="300"/>
+              </a:spcBef>
+            </a:pPr>
+            <a:r>
+              <a:rPr b="1" sz="900">
+                <a:solidFill>
+                  <a:srgbClr val="1E1B4B"/>
+                </a:solidFill>
+              </a:rPr>
+              <a:t>• customer_id (VARCHAR(20)): </a:t>
+            </a:r>
+            <a:r>
+              <a:rPr sz="850">
+                <a:solidFill>
+                  <a:srgbClr val="0F172A"/>
+                </a:solidFill>
+              </a:rPr>
+              <a:t>Unique authenticated natural customer ID.</a:t>
+            </a:r>
+          </a:p>
+          <a:p>
+            <a:pPr>
+              <a:spcBef>
+                <a:spcPts val="300"/>
+              </a:spcBef>
+            </a:pPr>
+            <a:r>
+              <a:rPr b="1" sz="900">
+                <a:solidFill>
+                  <a:srgbClr val="1E1B4B"/>
+                </a:solidFill>
+              </a:rPr>
+              <a:t>• recency_days (INTEGER): </a:t>
+            </a:r>
+            <a:r>
+              <a:rPr sz="850">
+                <a:solidFill>
+                  <a:srgbClr val="0F172A"/>
+                </a:solidFill>
+              </a:rPr>
+              <a:t>Days elapsed since last order relative to T_obs.</a:t>
+            </a:r>
+          </a:p>
+          <a:p>
+            <a:pPr>
+              <a:spcBef>
+                <a:spcPts val="300"/>
+              </a:spcBef>
+            </a:pPr>
+            <a:r>
+              <a:rPr b="1" sz="900">
+                <a:solidFill>
+                  <a:srgbClr val="1E1B4B"/>
+                </a:solidFill>
+              </a:rPr>
+              <a:t>• frequency_orders (INTEGER): </a:t>
+            </a:r>
+            <a:r>
+              <a:rPr sz="850">
+                <a:solidFill>
+                  <a:srgbClr val="0F172A"/>
+                </a:solidFill>
+              </a:rPr>
+              <a:t>Count of distinct checkout trips (unique orders).</a:t>
+            </a:r>
+          </a:p>
+          <a:p>
+            <a:pPr>
+              <a:spcBef>
+                <a:spcPts val="300"/>
+              </a:spcBef>
+            </a:pPr>
+            <a:r>
+              <a:rPr b="1" sz="900">
+                <a:solidFill>
+                  <a:srgbClr val="1E1B4B"/>
+                </a:solidFill>
+              </a:rPr>
+              <a:t>• monetary_total (DECIMAL(12,2)): </a:t>
+            </a:r>
+            <a:r>
+              <a:rPr sz="850">
+                <a:solidFill>
+                  <a:srgbClr val="0F172A"/>
+                </a:solidFill>
+              </a:rPr>
+              <a:t>Cumulative net customer spend across all valid orders.</a:t>
+            </a:r>
+          </a:p>
+          <a:p>
+            <a:pPr>
+              <a:spcBef>
+                <a:spcPts val="300"/>
+              </a:spcBef>
+            </a:pPr>
+            <a:r>
+              <a:rPr b="1" sz="900">
+                <a:solidFill>
+                  <a:srgbClr val="1E1B4B"/>
+                </a:solidFill>
+              </a:rPr>
+              <a:t>• avg_order_value (DECIMAL(10,2)): </a:t>
+            </a:r>
+            <a:r>
+              <a:rPr sz="850">
+                <a:solidFill>
+                  <a:srgbClr val="0F172A"/>
+                </a:solidFill>
+              </a:rPr>
+              <a:t>Average Order Value: Monetary / Frequency.</a:t>
+            </a:r>
+          </a:p>
+          <a:p>
+            <a:pPr>
+              <a:spcBef>
+                <a:spcPts val="300"/>
+              </a:spcBef>
+            </a:pPr>
+            <a:r>
+              <a:rPr b="1" sz="900">
+                <a:solidFill>
+                  <a:srgbClr val="1E1B4B"/>
+                </a:solidFill>
+              </a:rPr>
+              <a:t>• r_score, f_score, m_score (SMALLINT): </a:t>
+            </a:r>
+            <a:r>
+              <a:rPr sz="850">
+                <a:solidFill>
+                  <a:srgbClr val="0F172A"/>
+                </a:solidFill>
+              </a:rPr>
+              <a:t>Deterministic 1 to 5 quantile rank scores (pd.qcut).</a:t>
+            </a:r>
+          </a:p>
+          <a:p>
+            <a:pPr>
+              <a:spcBef>
+                <a:spcPts val="300"/>
+              </a:spcBef>
+            </a:pPr>
+            <a:r>
+              <a:rPr b="1" sz="900">
+                <a:solidFill>
+                  <a:srgbClr val="1E1B4B"/>
+                </a:solidFill>
+              </a:rPr>
+              <a:t>• segment_tier (VARCHAR(40)): </a:t>
+            </a:r>
+            <a:r>
+              <a:rPr sz="850">
+                <a:solidFill>
+                  <a:srgbClr val="0F172A"/>
+                </a:solidFill>
+              </a:rPr>
+              <a:t>Mapped business cohort ('Champions', 'At Risk Whales').</a:t>
+            </a:r>
+          </a:p>
+        </p:txBody>
+      </p:sp>
+      <p:sp>
+        <p:nvSpPr>
+          <p:cNvPr id="10" name="Rounded Rectangle 9"/>
           <p:cNvSpPr/>
           <p:nvPr/>
         </p:nvSpPr>
         <p:spPr>
           <a:xfrm>
-            <a:off x="7223760" y="1371600"/>
-            <a:ext cx="4236415" cy="4754880"/>
+            <a:off x="6492240" y="1371600"/>
+            <a:ext cx="4967935" cy="4754880"/>
           </a:xfrm>
           <a:prstGeom prst="roundRect">
             <a:avLst/>
@@ -7352,14 +7407,14 @@
       </p:sp>
       <p:sp>
         <p:nvSpPr>
-          <p:cNvPr id="12" name="TextBox 11"/>
+          <p:cNvPr id="11" name="TextBox 10"/>
           <p:cNvSpPr txBox="1"/>
           <p:nvPr/>
         </p:nvSpPr>
         <p:spPr>
           <a:xfrm>
-            <a:off x="7406640" y="1508760"/>
-            <a:ext cx="3840480" cy="4480560"/>
+            <a:off x="6675120" y="1508760"/>
+            <a:ext cx="4572000" cy="4480560"/>
           </a:xfrm>
           <a:prstGeom prst="rect">
             <a:avLst/>
@@ -7373,129 +7428,244 @@
           <a:lstStyle/>
           <a:p>
             <a:pPr>
-              <a:defRPr sz="1350" b="1">
+              <a:defRPr sz="1300" b="1">
                 <a:solidFill>
                   <a:srgbClr val="7A003C"/>
                 </a:solidFill>
               </a:defRPr>
             </a:pPr>
             <a:r>
-              <a:t>5 Sequential Pipeline Transformations</a:t>
+              <a:t>Table 3.4 &amp; 3.5: DIM_PRODUCTS &amp; DIM_DATE</a:t>
             </a:r>
           </a:p>
           <a:p>
             <a:pPr>
               <a:spcBef>
-                <a:spcPts val="500"/>
+                <a:spcPts val="200"/>
               </a:spcBef>
             </a:pPr>
             <a:r>
-              <a:rPr b="1" sz="950">
+              <a:rPr b="1" sz="900">
                 <a:solidFill>
                   <a:srgbClr val="1E1B4B"/>
                 </a:solidFill>
               </a:rPr>
-              <a:t>• Process 1.0 (Ingestion &amp; Schema Typing): </a:t>
-            </a:r>
-            <a:r>
-              <a:rPr sz="900">
+              <a:t>DIM_PRODUCTS Catalog Mart: </a:t>
+            </a:r>
+            <a:r>
+              <a:rPr sz="850">
                 <a:solidFill>
                   <a:srgbClr val="0F172A"/>
                 </a:solidFill>
               </a:rPr>
-              <a:t>Parses raw streams, validates typing, and logs records to D1 (Raw Transaction Log).</a:t>
+              <a:t/>
             </a:r>
           </a:p>
           <a:p>
             <a:pPr>
               <a:spcBef>
-                <a:spcPts val="500"/>
+                <a:spcPts val="200"/>
               </a:spcBef>
             </a:pPr>
             <a:r>
-              <a:rPr b="1" sz="950">
+              <a:rPr b="1" sz="900">
                 <a:solidFill>
                   <a:srgbClr val="1E1B4B"/>
                 </a:solidFill>
               </a:rPr>
-              <a:t>• Process 2.0 (Data Quality &amp; Refinery): </a:t>
-            </a:r>
-            <a:r>
-              <a:rPr sz="900">
+              <a:t>  • product_key (BIGINT, PK): </a:t>
+            </a:r>
+            <a:r>
+              <a:rPr sz="850">
                 <a:solidFill>
                   <a:srgbClr val="0F172A"/>
                 </a:solidFill>
               </a:rPr>
-              <a:t>Drops guest IDs, routes returns to D2 (Reversals Audit Ledger), and applies Tukey IQR fences.</a:t>
+              <a:t>Surrogate primary key for product catalog.</a:t>
             </a:r>
           </a:p>
           <a:p>
             <a:pPr>
               <a:spcBef>
-                <a:spcPts val="500"/>
+                <a:spcPts val="200"/>
               </a:spcBef>
             </a:pPr>
             <a:r>
-              <a:rPr b="1" sz="950">
+              <a:rPr b="1" sz="900">
                 <a:solidFill>
                   <a:srgbClr val="1E1B4B"/>
                 </a:solidFill>
               </a:rPr>
-              <a:t>• Process 3.0 (Vectorized RFM Feature Extraction): </a:t>
-            </a:r>
-            <a:r>
-              <a:rPr sz="900">
+              <a:t>  • stock_code (VARCHAR(20)): </a:t>
+            </a:r>
+            <a:r>
+              <a:rPr sz="850">
                 <a:solidFill>
                   <a:srgbClr val="0F172A"/>
                 </a:solidFill>
               </a:rPr>
-              <a:t>Computes Recency, Frequency, Spend, and AOV, writing to D3 (RFM Analytical Base Table).</a:t>
+              <a:t>Unique SKU inventory identifier.</a:t>
             </a:r>
           </a:p>
           <a:p>
             <a:pPr>
               <a:spcBef>
-                <a:spcPts val="500"/>
+                <a:spcPts val="200"/>
               </a:spcBef>
             </a:pPr>
             <a:r>
-              <a:rPr b="1" sz="950">
+              <a:rPr b="1" sz="900">
                 <a:solidFill>
                   <a:srgbClr val="1E1B4B"/>
                 </a:solidFill>
               </a:rPr>
-              <a:t>• Process 4.0 (ML Clustering &amp; Quantile Scoring): </a:t>
-            </a:r>
-            <a:r>
-              <a:rPr sz="900">
+              <a:t>  • description (VARCHAR(255)): </a:t>
+            </a:r>
+            <a:r>
+              <a:rPr sz="850">
                 <a:solidFill>
                   <a:srgbClr val="0F172A"/>
                 </a:solidFill>
               </a:rPr>
-              <a:t>Executes log1p scaling, StandardScaler, K-Means, and 1–5 scoring into D4 (Segmented Customer Mart).</a:t>
+              <a:t>Cleaned, sanitized item description text.</a:t>
             </a:r>
           </a:p>
           <a:p>
             <a:pPr>
               <a:spcBef>
-                <a:spcPts val="500"/>
+                <a:spcPts val="200"/>
               </a:spcBef>
             </a:pPr>
             <a:r>
-              <a:rPr b="1" sz="950">
+              <a:rPr b="1" sz="900">
                 <a:solidFill>
                   <a:srgbClr val="1E1B4B"/>
                 </a:solidFill>
               </a:rPr>
-              <a:t>• Process 5.0 (Star Schema &amp; Dashboard): </a:t>
-            </a:r>
-            <a:r>
-              <a:rPr sz="900">
+              <a:t>  • unit_price_ref (DECIMAL): </a:t>
+            </a:r>
+            <a:r>
+              <a:rPr sz="850">
                 <a:solidFill>
                   <a:srgbClr val="0F172A"/>
                 </a:solidFill>
               </a:rPr>
-              <a:t>Publishes BI data marts and powers the interactive executive web dashboard.</a:t>
+              <a:t>Baseline catalog reference price.</a:t>
+            </a:r>
+          </a:p>
+          <a:p>
+            <a:pPr>
+              <a:spcBef>
+                <a:spcPts val="200"/>
+              </a:spcBef>
+            </a:pPr>
+            <a:r>
+              <a:rPr b="1" sz="900">
+                <a:solidFill>
+                  <a:srgbClr val="1E1B4B"/>
+                </a:solidFill>
+              </a:rPr>
+              <a:t>DIM_DATE Temporal Mart: </a:t>
+            </a:r>
+            <a:r>
+              <a:rPr sz="850">
+                <a:solidFill>
+                  <a:srgbClr val="0F172A"/>
+                </a:solidFill>
+              </a:rPr>
+              <a:t/>
+            </a:r>
+          </a:p>
+          <a:p>
+            <a:pPr>
+              <a:spcBef>
+                <a:spcPts val="200"/>
+              </a:spcBef>
+            </a:pPr>
+            <a:r>
+              <a:rPr b="1" sz="900">
+                <a:solidFill>
+                  <a:srgbClr val="1E1B4B"/>
+                </a:solidFill>
+              </a:rPr>
+              <a:t>  • date_key (INTEGER, PK): </a:t>
+            </a:r>
+            <a:r>
+              <a:rPr sz="850">
+                <a:solidFill>
+                  <a:srgbClr val="0F172A"/>
+                </a:solidFill>
+              </a:rPr>
+              <a:t>YYYYMMDD formatted integer key (e.g. 20261013).</a:t>
+            </a:r>
+          </a:p>
+          <a:p>
+            <a:pPr>
+              <a:spcBef>
+                <a:spcPts val="200"/>
+              </a:spcBef>
+            </a:pPr>
+            <a:r>
+              <a:rPr b="1" sz="900">
+                <a:solidFill>
+                  <a:srgbClr val="1E1B4B"/>
+                </a:solidFill>
+              </a:rPr>
+              <a:t>  • full_date (DATE): </a:t>
+            </a:r>
+            <a:r>
+              <a:rPr sz="850">
+                <a:solidFill>
+                  <a:srgbClr val="0F172A"/>
+                </a:solidFill>
+              </a:rPr>
+              <a:t>Standard ISO-8601 calendar date.</a:t>
+            </a:r>
+          </a:p>
+          <a:p>
+            <a:pPr>
+              <a:spcBef>
+                <a:spcPts val="200"/>
+              </a:spcBef>
+            </a:pPr>
+            <a:r>
+              <a:rPr b="1" sz="900">
+                <a:solidFill>
+                  <a:srgbClr val="1E1B4B"/>
+                </a:solidFill>
+              </a:rPr>
+              <a:t>  • day_of_week, month, quarter: </a:t>
+            </a:r>
+            <a:r>
+              <a:rPr sz="850">
+                <a:solidFill>
+                  <a:srgbClr val="0F172A"/>
+                </a:solidFill>
+              </a:rPr>
+              <a:t>Calendar attributes for cohort time-series.</a:t>
+            </a:r>
+          </a:p>
+          <a:p>
+            <a:pPr>
+              <a:spcBef>
+                <a:spcPts val="200"/>
+              </a:spcBef>
+            </a:pPr>
+            <a:r>
+              <a:rPr b="1" sz="900">
+                <a:solidFill>
+                  <a:srgbClr val="1E1B4B"/>
+                </a:solidFill>
+              </a:rPr>
+              <a:t>  • is_weekend (BOOLEAN): </a:t>
+            </a:r>
+            <a:r>
+              <a:rPr sz="850">
+                <a:solidFill>
+                  <a:srgbClr val="0F172A"/>
+                </a:solidFill>
+              </a:rPr>
+              <a:t>Flag isolating weekend purchasing behavioral shifts.</a:t>
             </a:r>
           </a:p>
         </p:txBody>
@@ -7594,7 +7764,7 @@
               </a:defRPr>
             </a:pPr>
             <a:r>
-              <a:t>SECTION 2.1  •  PROCESS DECOMPOSITION</a:t>
+              <a:t>SECTION 4.1  •  IMPLEMENTATION</a:t>
             </a:r>
           </a:p>
         </p:txBody>
@@ -7630,7 +7800,7 @@
               </a:defRPr>
             </a:pPr>
             <a:r>
-              <a:t>Level 2 Data Flow Diagram (Refinery &amp; ML Decomposition)</a:t>
+              <a:t>Screen Layouts: Executive BI Dashboard Architecture</a:t>
             </a:r>
           </a:p>
         </p:txBody>
@@ -7747,7 +7917,7 @@
               </a:defRPr>
             </a:pPr>
             <a:r>
-              <a:t>B.Sc. in Artificial Intelligence &amp; Data Science (Sem V)  •  Institute of Advanced Research  •  First Progress Work (24/09/2026)</a:t>
+              <a:t>B.Sc. in Artificial Intelligence &amp; Data Science (Sem V)  •  Institute of Advanced Research  •  Second Progress Work (13/10/2026)</a:t>
             </a:r>
           </a:p>
         </p:txBody>
@@ -7799,7 +7969,7 @@
       </p:sp>
       <p:pic>
         <p:nvPicPr>
-          <p:cNvPr id="9" name="Picture 8" descr="fig_dfd_level_2.png"/>
+          <p:cNvPr id="9" name="Picture 8" descr="fig_screen_layouts.png"/>
           <p:cNvPicPr>
             <a:picLocks noChangeAspect="1"/>
           </p:cNvPicPr>
@@ -7813,8 +7983,8 @@
         </p:blipFill>
         <p:spPr>
           <a:xfrm>
-            <a:off x="914400" y="1645920"/>
-            <a:ext cx="5852160" cy="2438400"/>
+            <a:off x="868680" y="1554480"/>
+            <a:ext cx="5943600" cy="3962400"/>
           </a:xfrm>
           <a:prstGeom prst="rect">
             <a:avLst/>
@@ -7851,7 +8021,7 @@
               </a:defRPr>
             </a:pPr>
             <a:r>
-              <a:t>Figure 2.3: Level 2 Data Flow Diagram (Detailed Decomposition)</a:t>
+              <a:t>Figure 4.1: Implementation Screen Layouts (4 Synchronized Views)</a:t>
             </a:r>
           </a:p>
         </p:txBody>
@@ -7931,13 +8101,13 @@
               </a:defRPr>
             </a:pPr>
             <a:r>
-              <a:t>Algorithmic &amp; Mathematical Decomposition</a:t>
+              <a:t>4 Synchronized BI Dashboard Views</a:t>
             </a:r>
           </a:p>
           <a:p>
             <a:pPr>
               <a:spcBef>
-                <a:spcPts val="400"/>
+                <a:spcPts val="500"/>
               </a:spcBef>
             </a:pPr>
             <a:r>
@@ -7946,21 +8116,21 @@
                   <a:srgbClr val="1E1B4B"/>
                 </a:solidFill>
               </a:rPr>
-              <a:t>• Sub-Process 2.1 (Null ID Purge): </a:t>
-            </a:r>
-            <a:r>
-              <a:rPr sz="880">
+              <a:t>• Screen 1: Executive KPI Scorecards: </a:t>
+            </a:r>
+            <a:r>
+              <a:rPr sz="900">
                 <a:solidFill>
                   <a:srgbClr val="0F172A"/>
                 </a:solidFill>
               </a:rPr>
-              <a:t>Validates CustomerID existence; drops unauthenticated guest sessions.</a:t>
+              <a:t>High-level summary displaying gross spend ($65,049.20), active customer accounts (256), average order value ($254.10), and at-risk revenue share (7.3%).</a:t>
             </a:r>
           </a:p>
           <a:p>
             <a:pPr>
               <a:spcBef>
-                <a:spcPts val="400"/>
+                <a:spcPts val="500"/>
               </a:spcBef>
             </a:pPr>
             <a:r>
@@ -7969,21 +8139,21 @@
                   <a:srgbClr val="1E1B4B"/>
                 </a:solidFill>
               </a:rPr>
-              <a:t>• Sub-Process 2.2 (Reversals Filter): </a:t>
-            </a:r>
-            <a:r>
-              <a:rPr sz="880">
+              <a:t>• Screen 2: RFM Behavioral Scatterplot: </a:t>
+            </a:r>
+            <a:r>
+              <a:rPr sz="900">
                 <a:solidFill>
                   <a:srgbClr val="0F172A"/>
                 </a:solidFill>
               </a:rPr>
-              <a:t>Detects cancellation identifiers ('^C' or negative Quantity) and exports to fact_reversals_audit.csv.</a:t>
+              <a:t>Interactive 2D/3D canvas mapping Recency against Monetary Spend with bubble radii scaled to Frequency.</a:t>
             </a:r>
           </a:p>
           <a:p>
             <a:pPr>
               <a:spcBef>
-                <a:spcPts val="400"/>
+                <a:spcPts val="500"/>
               </a:spcBef>
             </a:pPr>
             <a:r>
@@ -7992,21 +8162,21 @@
                   <a:srgbClr val="1E1B4B"/>
                 </a:solidFill>
               </a:rPr>
-              <a:t>• Sub-Process 2.3 (Tukey IQR Capping): </a:t>
-            </a:r>
-            <a:r>
-              <a:rPr sz="880">
+              <a:t>• Screen 3: Customer Activation Ledger: </a:t>
+            </a:r>
+            <a:r>
+              <a:rPr sz="900">
                 <a:solidFill>
                   <a:srgbClr val="0F172A"/>
                 </a:solidFill>
               </a:rPr>
-              <a:t>Computes [Q1 - 1.5*IQR, Q3 + 1.5*IQR] to eliminate wholesale bulk distributor anomalies.</a:t>
+              <a:t>Filterable data table with instant search, pagination, and targeted CSV audience export controls.</a:t>
             </a:r>
           </a:p>
           <a:p>
             <a:pPr>
               <a:spcBef>
-                <a:spcPts val="400"/>
+                <a:spcPts val="500"/>
               </a:spcBef>
             </a:pPr>
             <a:r>
@@ -8015,61 +8185,15 @@
                   <a:srgbClr val="1E1B4B"/>
                 </a:solidFill>
               </a:rPr>
-              <a:t>• Sub-Process 4.1 (Log1p Scaling): </a:t>
-            </a:r>
-            <a:r>
-              <a:rPr sz="880">
+              <a:t>• Screen 4: Reverse Logistics Audit Ledger: </a:t>
+            </a:r>
+            <a:r>
+              <a:rPr sz="900">
                 <a:solidFill>
                   <a:srgbClr val="0F172A"/>
                 </a:solidFill>
               </a:rPr>
-              <a:t>Applies z = ln(1 + x) to compress severe right-skewed Pareto customer spending.</a:t>
-            </a:r>
-          </a:p>
-          <a:p>
-            <a:pPr>
-              <a:spcBef>
-                <a:spcPts val="400"/>
-              </a:spcBef>
-            </a:pPr>
-            <a:r>
-              <a:rPr b="1" sz="950">
-                <a:solidFill>
-                  <a:srgbClr val="1E1B4B"/>
-                </a:solidFill>
-              </a:rPr>
-              <a:t>• Sub-Process 4.2 (StandardScaler): </a:t>
-            </a:r>
-            <a:r>
-              <a:rPr sz="880">
-                <a:solidFill>
-                  <a:srgbClr val="0F172A"/>
-                </a:solidFill>
-              </a:rPr>
-              <a:t>Transforms features to zero mean and unit variance for distance-based clustering.</a:t>
-            </a:r>
-          </a:p>
-          <a:p>
-            <a:pPr>
-              <a:spcBef>
-                <a:spcPts val="400"/>
-              </a:spcBef>
-            </a:pPr>
-            <a:r>
-              <a:rPr b="1" sz="950">
-                <a:solidFill>
-                  <a:srgbClr val="1E1B4B"/>
-                </a:solidFill>
-              </a:rPr>
-              <a:t>• Sub-Process 4.3 (K-Means &amp; Silhouette): </a:t>
-            </a:r>
-            <a:r>
-              <a:rPr sz="880">
-                <a:solidFill>
-                  <a:srgbClr val="0F172A"/>
-                </a:solidFill>
-              </a:rPr>
-              <a:t>Fits K-Means across k in [2..6], diagnosing optimal clusters via Silhouette coefficient.</a:t>
+              <a:t>Isolated compliance table displaying quarantined cancellations and credit notes.</a:t>
             </a:r>
           </a:p>
         </p:txBody>
@@ -8168,7 +8292,7 @@
               </a:defRPr>
             </a:pPr>
             <a:r>
-              <a:t>SECTION 2.2  •  SYSTEM CAPABILITIES</a:t>
+              <a:t>SECTION 4.1  •  DATA INTEGRITY</a:t>
             </a:r>
           </a:p>
         </p:txBody>
@@ -8204,7 +8328,7 @@
               </a:defRPr>
             </a:pPr>
             <a:r>
-              <a:t>UML Use Case Diagram &amp; Actor Responsibilities</a:t>
+              <a:t>Implementation: Operational Input Validations (VAL-01 to VAL-04)</a:t>
             </a:r>
           </a:p>
         </p:txBody>
@@ -8321,7 +8445,7 @@
               </a:defRPr>
             </a:pPr>
             <a:r>
-              <a:t>B.Sc. in Artificial Intelligence &amp; Data Science (Sem V)  •  Institute of Advanced Research  •  First Progress Work (24/09/2026)</a:t>
+              <a:t>B.Sc. in Artificial Intelligence &amp; Data Science (Sem V)  •  Institute of Advanced Research  •  Second Progress Work (13/10/2026)</a:t>
             </a:r>
           </a:p>
         </p:txBody>
@@ -8335,7 +8459,292 @@
         <p:spPr>
           <a:xfrm>
             <a:off x="731520" y="1371600"/>
-            <a:ext cx="5029200" cy="4754880"/>
+            <a:ext cx="10728655" cy="1051560"/>
+          </a:xfrm>
+          <a:prstGeom prst="roundRect">
+            <a:avLst/>
+          </a:prstGeom>
+          <a:solidFill>
+            <a:srgbClr val="FEF2F2"/>
+          </a:solidFill>
+          <a:ln w="12700">
+            <a:solidFill>
+              <a:srgbClr val="E2E8F0"/>
+            </a:solidFill>
+          </a:ln>
+        </p:spPr>
+        <p:style>
+          <a:lnRef idx="1">
+            <a:schemeClr val="accent1"/>
+          </a:lnRef>
+          <a:fillRef idx="3">
+            <a:schemeClr val="accent1"/>
+          </a:fillRef>
+          <a:effectRef idx="2">
+            <a:schemeClr val="accent1"/>
+          </a:effectRef>
+          <a:fontRef idx="minor">
+            <a:schemeClr val="lt1"/>
+          </a:fontRef>
+        </p:style>
+        <p:txBody>
+          <a:bodyPr rtlCol="0" anchor="ctr"/>
+          <a:lstStyle/>
+          <a:p>
+            <a:pPr algn="ctr"/>
+          </a:p>
+        </p:txBody>
+      </p:sp>
+      <p:sp>
+        <p:nvSpPr>
+          <p:cNvPr id="9" name="TextBox 8"/>
+          <p:cNvSpPr txBox="1"/>
+          <p:nvPr/>
+        </p:nvSpPr>
+        <p:spPr>
+          <a:xfrm>
+            <a:off x="914400" y="1444752"/>
+            <a:ext cx="10362895" cy="905256"/>
+          </a:xfrm>
+          <a:prstGeom prst="rect">
+            <a:avLst/>
+          </a:prstGeom>
+          <a:noFill/>
+        </p:spPr>
+        <p:txBody>
+          <a:bodyPr wrap="square">
+            <a:spAutoFit/>
+          </a:bodyPr>
+          <a:lstStyle/>
+          <a:p>
+            <a:r>
+              <a:rPr sz="1100" b="1">
+                <a:solidFill>
+                  <a:srgbClr val="7A003C"/>
+                </a:solidFill>
+                <a:latin typeface="Arial"/>
+              </a:rPr>
+              <a:t>VAL-01: Scorecard Numerical Integrity Validation</a:t>
+            </a:r>
+          </a:p>
+          <a:p>
+            <a:pPr>
+              <a:spcBef>
+                <a:spcPts val="300"/>
+              </a:spcBef>
+            </a:pPr>
+            <a:r>
+              <a:rPr sz="950">
+                <a:solidFill>
+                  <a:srgbClr val="0F172A"/>
+                </a:solidFill>
+                <a:latin typeface="Arial"/>
+              </a:rPr>
+              <a:t>Enforces non-negative monetary constraints (Spend &gt;= 0.00). Active customer counts strictly verify unique authenticated non-null CustomerIDs. At-risk percentages are evaluated as: (Sum(Spend_AtRisk) / Total_Spend) * 100.</a:t>
+            </a:r>
+          </a:p>
+        </p:txBody>
+      </p:sp>
+      <p:sp>
+        <p:nvSpPr>
+          <p:cNvPr id="10" name="Rounded Rectangle 9"/>
+          <p:cNvSpPr/>
+          <p:nvPr/>
+        </p:nvSpPr>
+        <p:spPr>
+          <a:xfrm>
+            <a:off x="731520" y="2587752"/>
+            <a:ext cx="10728655" cy="1051560"/>
+          </a:xfrm>
+          <a:prstGeom prst="roundRect">
+            <a:avLst/>
+          </a:prstGeom>
+          <a:solidFill>
+            <a:srgbClr val="EFF6FF"/>
+          </a:solidFill>
+          <a:ln w="12700">
+            <a:solidFill>
+              <a:srgbClr val="E2E8F0"/>
+            </a:solidFill>
+          </a:ln>
+        </p:spPr>
+        <p:style>
+          <a:lnRef idx="1">
+            <a:schemeClr val="accent1"/>
+          </a:lnRef>
+          <a:fillRef idx="3">
+            <a:schemeClr val="accent1"/>
+          </a:fillRef>
+          <a:effectRef idx="2">
+            <a:schemeClr val="accent1"/>
+          </a:effectRef>
+          <a:fontRef idx="minor">
+            <a:schemeClr val="lt1"/>
+          </a:fontRef>
+        </p:style>
+        <p:txBody>
+          <a:bodyPr rtlCol="0" anchor="ctr"/>
+          <a:lstStyle/>
+          <a:p>
+            <a:pPr algn="ctr"/>
+          </a:p>
+        </p:txBody>
+      </p:sp>
+      <p:sp>
+        <p:nvSpPr>
+          <p:cNvPr id="11" name="TextBox 10"/>
+          <p:cNvSpPr txBox="1"/>
+          <p:nvPr/>
+        </p:nvSpPr>
+        <p:spPr>
+          <a:xfrm>
+            <a:off x="914400" y="2660904"/>
+            <a:ext cx="10362895" cy="905256"/>
+          </a:xfrm>
+          <a:prstGeom prst="rect">
+            <a:avLst/>
+          </a:prstGeom>
+          <a:noFill/>
+        </p:spPr>
+        <p:txBody>
+          <a:bodyPr wrap="square">
+            <a:spAutoFit/>
+          </a:bodyPr>
+          <a:lstStyle/>
+          <a:p>
+            <a:r>
+              <a:rPr sz="1100" b="1">
+                <a:solidFill>
+                  <a:srgbClr val="2563EB"/>
+                </a:solidFill>
+                <a:latin typeface="Arial"/>
+              </a:rPr>
+              <a:t>VAL-02: Spatial Canvas Coordinate &amp; Boundary Constraints</a:t>
+            </a:r>
+          </a:p>
+          <a:p>
+            <a:pPr>
+              <a:spcBef>
+                <a:spcPts val="300"/>
+              </a:spcBef>
+            </a:pPr>
+            <a:r>
+              <a:rPr sz="950">
+                <a:solidFill>
+                  <a:srgbClr val="0F172A"/>
+                </a:solidFill>
+                <a:latin typeface="Arial"/>
+              </a:rPr>
+              <a:t>Interactive scatterplot coordinates enforce strict domain bounds: Recency in [1..365], Frequency in [1..50], Spend in [0..10,000]. Hover tooltips execute null-safety checks before canvas event firing.</a:t>
+            </a:r>
+          </a:p>
+        </p:txBody>
+      </p:sp>
+      <p:sp>
+        <p:nvSpPr>
+          <p:cNvPr id="12" name="Rounded Rectangle 11"/>
+          <p:cNvSpPr/>
+          <p:nvPr/>
+        </p:nvSpPr>
+        <p:spPr>
+          <a:xfrm>
+            <a:off x="731520" y="3803904"/>
+            <a:ext cx="10728655" cy="1051560"/>
+          </a:xfrm>
+          <a:prstGeom prst="roundRect">
+            <a:avLst/>
+          </a:prstGeom>
+          <a:solidFill>
+            <a:srgbClr val="ECFDF5"/>
+          </a:solidFill>
+          <a:ln w="12700">
+            <a:solidFill>
+              <a:srgbClr val="E2E8F0"/>
+            </a:solidFill>
+          </a:ln>
+        </p:spPr>
+        <p:style>
+          <a:lnRef idx="1">
+            <a:schemeClr val="accent1"/>
+          </a:lnRef>
+          <a:fillRef idx="3">
+            <a:schemeClr val="accent1"/>
+          </a:fillRef>
+          <a:effectRef idx="2">
+            <a:schemeClr val="accent1"/>
+          </a:effectRef>
+          <a:fontRef idx="minor">
+            <a:schemeClr val="lt1"/>
+          </a:fontRef>
+        </p:style>
+        <p:txBody>
+          <a:bodyPr rtlCol="0" anchor="ctr"/>
+          <a:lstStyle/>
+          <a:p>
+            <a:pPr algn="ctr"/>
+          </a:p>
+        </p:txBody>
+      </p:sp>
+      <p:sp>
+        <p:nvSpPr>
+          <p:cNvPr id="13" name="TextBox 12"/>
+          <p:cNvSpPr txBox="1"/>
+          <p:nvPr/>
+        </p:nvSpPr>
+        <p:spPr>
+          <a:xfrm>
+            <a:off x="914400" y="3877056"/>
+            <a:ext cx="10362895" cy="905256"/>
+          </a:xfrm>
+          <a:prstGeom prst="rect">
+            <a:avLst/>
+          </a:prstGeom>
+          <a:noFill/>
+        </p:spPr>
+        <p:txBody>
+          <a:bodyPr wrap="square">
+            <a:spAutoFit/>
+          </a:bodyPr>
+          <a:lstStyle/>
+          <a:p>
+            <a:r>
+              <a:rPr sz="1100" b="1">
+                <a:solidFill>
+                  <a:srgbClr val="10B981"/>
+                </a:solidFill>
+                <a:latin typeface="Arial"/>
+              </a:rPr>
+              <a:t>VAL-03: Search Query Sanitization &amp; Pagination Bounds</a:t>
+            </a:r>
+          </a:p>
+          <a:p>
+            <a:pPr>
+              <a:spcBef>
+                <a:spcPts val="300"/>
+              </a:spcBef>
+            </a:pPr>
+            <a:r>
+              <a:rPr sz="950">
+                <a:solidFill>
+                  <a:srgbClr val="0F172A"/>
+                </a:solidFill>
+                <a:latin typeface="Arial"/>
+              </a:rPr>
+              <a:t>Client-side search input is sanitized against cross-site scripting (XSS) and SQL injection. Table pagination enforces bounded integer intervals (1 &lt;= Page &lt;= MaxPage).</a:t>
+            </a:r>
+          </a:p>
+        </p:txBody>
+      </p:sp>
+      <p:sp>
+        <p:nvSpPr>
+          <p:cNvPr id="14" name="Rounded Rectangle 13"/>
+          <p:cNvSpPr/>
+          <p:nvPr/>
+        </p:nvSpPr>
+        <p:spPr>
+          <a:xfrm>
+            <a:off x="731520" y="5020056"/>
+            <a:ext cx="10728655" cy="1051560"/>
           </a:xfrm>
           <a:prstGeom prst="roundRect">
             <a:avLst/>
@@ -8371,120 +8780,16 @@
           </a:p>
         </p:txBody>
       </p:sp>
-      <p:pic>
-        <p:nvPicPr>
-          <p:cNvPr id="9" name="Picture 8" descr="fig_use_case_diagram.png"/>
-          <p:cNvPicPr>
-            <a:picLocks noChangeAspect="1"/>
-          </p:cNvPicPr>
-          <p:nvPr/>
-        </p:nvPicPr>
-        <p:blipFill>
-          <a:blip r:embed="rId2"/>
-          <a:stretch>
-            <a:fillRect/>
-          </a:stretch>
-        </p:blipFill>
-        <p:spPr>
-          <a:xfrm>
-            <a:off x="960120" y="1600200"/>
-            <a:ext cx="4572000" cy="2971800"/>
-          </a:xfrm>
-          <a:prstGeom prst="rect">
-            <a:avLst/>
-          </a:prstGeom>
-        </p:spPr>
-      </p:pic>
-      <p:sp>
-        <p:nvSpPr>
-          <p:cNvPr id="10" name="TextBox 9"/>
+      <p:sp>
+        <p:nvSpPr>
+          <p:cNvPr id="15" name="TextBox 14"/>
           <p:cNvSpPr txBox="1"/>
           <p:nvPr/>
         </p:nvSpPr>
         <p:spPr>
           <a:xfrm>
-            <a:off x="731520" y="5715000"/>
-            <a:ext cx="5029200" cy="320040"/>
-          </a:xfrm>
-          <a:prstGeom prst="rect">
-            <a:avLst/>
-          </a:prstGeom>
-          <a:noFill/>
-        </p:spPr>
-        <p:txBody>
-          <a:bodyPr wrap="none">
-            <a:spAutoFit/>
-          </a:bodyPr>
-          <a:lstStyle/>
-          <a:p>
-            <a:pPr algn="ctr">
-              <a:defRPr sz="950" b="1">
-                <a:solidFill>
-                  <a:srgbClr val="475569"/>
-                </a:solidFill>
-              </a:defRPr>
-            </a:pPr>
-            <a:r>
-              <a:t>Figure 2.4: UML Use Case Diagram (Actors &amp; Capabilities)</a:t>
-            </a:r>
-          </a:p>
-        </p:txBody>
-      </p:sp>
-      <p:sp>
-        <p:nvSpPr>
-          <p:cNvPr id="11" name="Rounded Rectangle 10"/>
-          <p:cNvSpPr/>
-          <p:nvPr/>
-        </p:nvSpPr>
-        <p:spPr>
-          <a:xfrm>
-            <a:off x="6035040" y="1371600"/>
-            <a:ext cx="5425135" cy="4754880"/>
-          </a:xfrm>
-          <a:prstGeom prst="roundRect">
-            <a:avLst/>
-          </a:prstGeom>
-          <a:solidFill>
-            <a:srgbClr val="F8FAFC"/>
-          </a:solidFill>
-          <a:ln w="12700">
-            <a:solidFill>
-              <a:srgbClr val="E2E8F0"/>
-            </a:solidFill>
-          </a:ln>
-        </p:spPr>
-        <p:style>
-          <a:lnRef idx="1">
-            <a:schemeClr val="accent1"/>
-          </a:lnRef>
-          <a:fillRef idx="3">
-            <a:schemeClr val="accent1"/>
-          </a:fillRef>
-          <a:effectRef idx="2">
-            <a:schemeClr val="accent1"/>
-          </a:effectRef>
-          <a:fontRef idx="minor">
-            <a:schemeClr val="lt1"/>
-          </a:fontRef>
-        </p:style>
-        <p:txBody>
-          <a:bodyPr rtlCol="0" anchor="ctr"/>
-          <a:lstStyle/>
-          <a:p>
-            <a:pPr algn="ctr"/>
-          </a:p>
-        </p:txBody>
-      </p:sp>
-      <p:sp>
-        <p:nvSpPr>
-          <p:cNvPr id="12" name="TextBox 11"/>
-          <p:cNvSpPr txBox="1"/>
-          <p:nvPr/>
-        </p:nvSpPr>
-        <p:spPr>
-          <a:xfrm>
-            <a:off x="6217920" y="1508760"/>
-            <a:ext cx="5029200" cy="4480560"/>
+            <a:off x="914400" y="5093208"/>
+            <a:ext cx="10362895" cy="905256"/>
           </a:xfrm>
           <a:prstGeom prst="rect">
             <a:avLst/>
@@ -8497,153 +8802,30 @@
           </a:bodyPr>
           <a:lstStyle/>
           <a:p>
-            <a:pPr>
-              <a:defRPr sz="1350" b="1">
-                <a:solidFill>
-                  <a:srgbClr val="7A003C"/>
-                </a:solidFill>
-              </a:defRPr>
-            </a:pPr>
-            <a:r>
-              <a:t>Table 2.1: Use Case Specification Matrix (UC-01 to UC-06)</a:t>
+            <a:r>
+              <a:rPr sz="1100" b="1">
+                <a:solidFill>
+                  <a:srgbClr val="1E1B4B"/>
+                </a:solidFill>
+                <a:latin typeface="Arial"/>
+              </a:rPr>
+              <a:t>VAL-04: Reverse Logistics Quarantine Constraint</a:t>
             </a:r>
           </a:p>
           <a:p>
             <a:pPr>
               <a:spcBef>
-                <a:spcPts val="400"/>
+                <a:spcPts val="300"/>
               </a:spcBef>
             </a:pPr>
             <a:r>
-              <a:rPr b="1" sz="950">
-                <a:solidFill>
-                  <a:srgbClr val="1E1B4B"/>
-                </a:solidFill>
-              </a:rPr>
-              <a:t>UC-01: Ingest Transaction Stream [Data Engineer / Admin]: </a:t>
-            </a:r>
-            <a:r>
-              <a:rPr sz="880">
+              <a:rPr sz="950">
                 <a:solidFill>
                   <a:srgbClr val="0F172A"/>
                 </a:solidFill>
-              </a:rPr>
-              <a:t>Ingests raw event logs, enforces schema typing, verifies datatypes.</a:t>
-            </a:r>
-          </a:p>
-          <a:p>
-            <a:pPr>
-              <a:spcBef>
-                <a:spcPts val="400"/>
-              </a:spcBef>
-            </a:pPr>
-            <a:r>
-              <a:rPr b="1" sz="950">
-                <a:solidFill>
-                  <a:srgbClr val="1E1B4B"/>
-                </a:solidFill>
-              </a:rPr>
-              <a:t>UC-02: Isolate Reversals &amp; IQR Filter [Data Engineer / Admin]: </a:t>
-            </a:r>
-            <a:r>
-              <a:rPr sz="880">
-                <a:solidFill>
-                  <a:srgbClr val="0F172A"/>
-                </a:solidFill>
-              </a:rPr>
-              <a:t>Purges null IDs, isolates returns (^C), caps Tukey bulk outliers.</a:t>
-            </a:r>
-          </a:p>
-          <a:p>
-            <a:pPr>
-              <a:spcBef>
-                <a:spcPts val="400"/>
-              </a:spcBef>
-            </a:pPr>
-            <a:r>
-              <a:rPr b="1" sz="950">
-                <a:solidFill>
-                  <a:srgbClr val="1E1B4B"/>
-                </a:solidFill>
-              </a:rPr>
-              <a:t>UC-03: Compute Vectorized RFM [Analytics Engineer]: </a:t>
-            </a:r>
-            <a:r>
-              <a:rPr sz="880">
-                <a:solidFill>
-                  <a:srgbClr val="0F172A"/>
-                </a:solidFill>
-              </a:rPr>
-              <a:t>Aggregates transactions into customer Recency, Frequency, and Spend.</a:t>
-            </a:r>
-          </a:p>
-          <a:p>
-            <a:pPr>
-              <a:spcBef>
-                <a:spcPts val="400"/>
-              </a:spcBef>
-            </a:pPr>
-            <a:r>
-              <a:rPr b="1" sz="950">
-                <a:solidFill>
-                  <a:srgbClr val="1E1B4B"/>
-                </a:solidFill>
-              </a:rPr>
-              <a:t>UC-04: Train &amp; Tune K-Means Model [Data Scientist]: </a:t>
-            </a:r>
-            <a:r>
-              <a:rPr sz="880">
-                <a:solidFill>
-                  <a:srgbClr val="0F172A"/>
-                </a:solidFill>
-              </a:rPr>
-              <a:t>Applies log1p + StandardScaler, evaluates Elbow/Silhouette, fits k=4.</a:t>
-            </a:r>
-          </a:p>
-          <a:p>
-            <a:pPr>
-              <a:spcBef>
-                <a:spcPts val="400"/>
-              </a:spcBef>
-            </a:pPr>
-            <a:r>
-              <a:rPr b="1" sz="950">
-                <a:solidFill>
-                  <a:srgbClr val="1E1B4B"/>
-                </a:solidFill>
-              </a:rPr>
-              <a:t>UC-05: Inspect Executive KPI Metrics [Commercial Executive]: </a:t>
-            </a:r>
-            <a:r>
-              <a:rPr sz="880">
-                <a:solidFill>
-                  <a:srgbClr val="0F172A"/>
-                </a:solidFill>
-              </a:rPr>
-              <a:t>Monitors portfolio health ($65k spend), Champions share (72.5%), at-risk capital.</a:t>
-            </a:r>
-          </a:p>
-          <a:p>
-            <a:pPr>
-              <a:spcBef>
-                <a:spcPts val="400"/>
-              </a:spcBef>
-            </a:pPr>
-            <a:r>
-              <a:rPr b="1" sz="950">
-                <a:solidFill>
-                  <a:srgbClr val="1E1B4B"/>
-                </a:solidFill>
-              </a:rPr>
-              <a:t>UC-06: Export Targeted CRM Audiences [Marketing Manager]: </a:t>
-            </a:r>
-            <a:r>
-              <a:rPr sz="880">
-                <a:solidFill>
-                  <a:srgbClr val="0F172A"/>
-                </a:solidFill>
-              </a:rPr>
-              <a:t>Filters segments in activation ledger and exports audience lists for campaigns.</a:t>
+                <a:latin typeface="Arial"/>
+              </a:rPr>
+              <a:t>Cancellation transactions strictly enforce regex constraint (InvoiceNo.startswith('C')) and negative quantities (Quantity &lt; 0) before insertion into audit stores.</a:t>
             </a:r>
           </a:p>
         </p:txBody>
@@ -8778,7 +8960,7 @@
               </a:defRPr>
             </a:pPr>
             <a:r>
-              <a:t>Milestone Evaluation Schedule &amp; Project Roadmap</a:t>
+              <a:t>Project Evaluation Schedule &amp; Milestone Status (Mid-Term)</a:t>
             </a:r>
           </a:p>
         </p:txBody>
@@ -8895,7 +9077,7 @@
               </a:defRPr>
             </a:pPr>
             <a:r>
-              <a:t>B.Sc. in Artificial Intelligence &amp; Data Science (Sem V)  •  Institute of Advanced Research  •  First Progress Work (24/09/2026)</a:t>
+              <a:t>B.Sc. in Artificial Intelligence &amp; Data Science (Sem V)  •  Institute of Advanced Research  •  Second Progress Work (13/10/2026)</a:t>
             </a:r>
           </a:p>
         </p:txBody>
@@ -8975,7 +9157,7 @@
               </a:defRPr>
             </a:pPr>
             <a:r>
-              <a:t>Formal Assessment Schedule &amp; Deliverable Tracking</a:t>
+              <a:t>Table 4.1: Comprehensive Project Progress Work Schedule</a:t>
             </a:r>
           </a:p>
           <a:p>
@@ -8987,7 +9169,7 @@
             <a:r>
               <a:rPr b="1" sz="1100">
                 <a:solidFill>
-                  <a:srgbClr val="10B981"/>
+                  <a:srgbClr val="475569"/>
                 </a:solidFill>
               </a:rPr>
               <a:t>• [24/09/2026]  First Progress Work Evaluation (10 Marks) — </a:t>
@@ -8995,10 +9177,10 @@
             <a:r>
               <a:rPr b="1" sz="1050">
                 <a:solidFill>
-                  <a:srgbClr val="10B981"/>
-                </a:solidFill>
-              </a:rPr>
-              <a:t>COMPLETED (Current Submission)
+                  <a:srgbClr val="475569"/>
+                </a:solidFill>
+              </a:rPr>
+              <a:t>COMPLETED &amp; VERIFIED
 </a:t>
             </a:r>
             <a:r>
@@ -9007,7 +9189,7 @@
                   <a:srgbClr val="0F172A"/>
                 </a:solidFill>
               </a:rPr>
-              <a:t>   Scope: Sections 1.1, 1.2, 1.3, 2.1, 2.2</a:t>
+              <a:t>   Curriculum Scope: Sections 1.1, 1.2, 1.3, 2.1, 2.2</a:t>
             </a:r>
           </a:p>
           <a:p>
@@ -9019,7 +9201,7 @@
             <a:r>
               <a:rPr b="1" sz="1100">
                 <a:solidFill>
-                  <a:srgbClr val="2563EB"/>
+                  <a:srgbClr val="10B981"/>
                 </a:solidFill>
               </a:rPr>
               <a:t>• [13/10/2026]  Mid-Term Examination (Second Progress) (20 Marks) — </a:t>
@@ -9027,10 +9209,10 @@
             <a:r>
               <a:rPr b="1" sz="1050">
                 <a:solidFill>
-                  <a:srgbClr val="2563EB"/>
-                </a:solidFill>
-              </a:rPr>
-              <a:t>Scheduled for Next Milestone
+                  <a:srgbClr val="10B981"/>
+                </a:solidFill>
+              </a:rPr>
+              <a:t>DEMONSTRATED (Current Submission)
 </a:t>
             </a:r>
             <a:r>
@@ -9039,7 +9221,7 @@
                   <a:srgbClr val="0F172A"/>
                 </a:solidFill>
               </a:rPr>
-              <a:t>   Scope: 2.3 (Class Diagram), 2.4 (Sequence Diagrams), 3.1 (Data Dictionary), 4.1 (UI Layouts)</a:t>
+              <a:t>   Curriculum Scope: Sections 2.3, 2.4, 3.1, 4.1</a:t>
             </a:r>
           </a:p>
           <a:p>
@@ -9051,7 +9233,7 @@
             <a:r>
               <a:rPr b="1" sz="1100">
                 <a:solidFill>
-                  <a:srgbClr val="475569"/>
+                  <a:srgbClr val="2563EB"/>
                 </a:solidFill>
               </a:rPr>
               <a:t>• [27/10/2026]  Third Progress Work Evaluation (10 Marks) — </a:t>
@@ -9059,7 +9241,7 @@
             <a:r>
               <a:rPr b="1" sz="1050">
                 <a:solidFill>
-                  <a:srgbClr val="475569"/>
+                  <a:srgbClr val="2563EB"/>
                 </a:solidFill>
               </a:rPr>
               <a:t>Scheduled for Third Milestone
@@ -9071,7 +9253,7 @@
                   <a:srgbClr val="0F172A"/>
                 </a:solidFill>
               </a:rPr>
-              <a:t>   Scope: 4.2 (Sample Coding), 4.3 (Navigation), 5.1-5.2 (Conclusion), 6.1 (References)</a:t>
+              <a:t>   Curriculum Scope: Sections 4.2 (Sample Code), 4.3 (Navigation), 5.1-5.2, 6.1</a:t>
             </a:r>
           </a:p>
           <a:p>
@@ -9103,7 +9285,7 @@
                   <a:srgbClr val="0F172A"/>
                 </a:solidFill>
               </a:rPr>
-              <a:t>   Scope: Final Signed Spiral Copy &amp; Project Media</a:t>
+              <a:t>   Curriculum Scope: Final Signed Spiral Copy &amp; Media</a:t>
             </a:r>
           </a:p>
           <a:p>
@@ -9135,7 +9317,7 @@
                   <a:srgbClr val="0F172A"/>
                 </a:solidFill>
               </a:rPr>
-              <a:t>   Scope: Project Execution Demonstration &amp; Viva Voce</a:t>
+              <a:t>   Curriculum Scope: Project Execution Demonstration &amp; Viva Voce</a:t>
             </a:r>
           </a:p>
         </p:txBody>
@@ -9213,7 +9395,7 @@
                   <a:srgbClr val="10B981"/>
                 </a:solidFill>
               </a:rPr>
-              <a:t>MILESTONE STATUS SUMMARY (24/09/2026): </a:t>
+              <a:t>MID-TERM MILESTONE STATUS (13/10/2026): </a:t>
             </a:r>
             <a:r>
               <a:rPr sz="950">
@@ -9221,7 +9403,7 @@
                   <a:srgbClr val="0F172A"/>
                 </a:solidFill>
               </a:rPr>
-              <a:t>All deliverables for the First Progress Work milestone (10 Marks) have been successfully engineered, verified, and compiled into the 10-page report and interactive demonstration dashboard.</a:t>
+              <a:t>Cumulative completion of 30 Marks (First Progress 10 Marks + Mid-Term 20 Marks). All Class, Sequence, Data Dictionary, and UI Validation specifications fully implemented.</a:t>
             </a:r>
           </a:p>
         </p:txBody>

</xml_diff>

<commit_message>
feat(phase3): deliver complete Third Progress Work (27/10/2026 - 10 Marks) report and presentation
</commit_message>
<xml_diff>
--- a/Deep_Koshiya_ProjectPresentation.pptx
+++ b/Deep_Koshiya_ProjectPresentation.pptx
@@ -3268,8 +3268,8 @@
         </p:nvSpPr>
         <p:spPr>
           <a:xfrm>
-            <a:off x="2743200" y="2148840"/>
-            <a:ext cx="6705295" cy="384048"/>
+            <a:off x="2651760" y="2148840"/>
+            <a:ext cx="6888175" cy="384048"/>
           </a:xfrm>
           <a:prstGeom prst="roundRect">
             <a:avLst/>
@@ -3313,8 +3313,8 @@
         </p:nvSpPr>
         <p:spPr>
           <a:xfrm>
-            <a:off x="2743200" y="2148840"/>
-            <a:ext cx="6705295" cy="384048"/>
+            <a:off x="2651760" y="2148840"/>
+            <a:ext cx="6888175" cy="384048"/>
           </a:xfrm>
           <a:prstGeom prst="rect">
             <a:avLst/>
@@ -3336,7 +3336,7 @@
               </a:defRPr>
             </a:pPr>
             <a:r>
-              <a:t>SECOND PROGRESS WORK (MID-TERM EXAM)  •  13TH OCTOBER 2026  •  20 MARKS</a:t>
+              <a:t>THIRD PROGRESS WORK EVALUATION  •  27TH OCTOBER 2026  •  40 MARKS CUMULATIVE</a:t>
             </a:r>
           </a:p>
         </p:txBody>
@@ -3389,7 +3389,7 @@
               </a:defRPr>
             </a:pPr>
             <a:r>
-              <a:t>Second Phase Technical Report: UML Class &amp; Sequence Models, Data Dictionary &amp; UI Layout Validations</a:t>
+              <a:t>Third Phase Technical Presentation: Sample Coding, Cybersecurity Controls, Execution &amp; Navigation</a:t>
             </a:r>
           </a:p>
         </p:txBody>
@@ -3641,7 +3641,7 @@
               </a:defRPr>
             </a:pPr>
             <a:r>
-              <a:t>EVALUATION &amp; DELIVERABLE SCOPE</a:t>
+              <a:t>EVALUATION &amp; MILESTONE SCOPE</a:t>
             </a:r>
           </a:p>
           <a:p>
@@ -3659,7 +3659,7 @@
                   <a:srgbClr val="0F172A"/>
                 </a:solidFill>
               </a:rPr>
-              <a:t>Second Progress Work (Mid-Term)</a:t>
+              <a:t>Third Progress Work Evaluation</a:t>
             </a:r>
           </a:p>
           <a:p>
@@ -3677,7 +3677,7 @@
                   <a:srgbClr val="0F172A"/>
                 </a:solidFill>
               </a:rPr>
-              <a:t>13th October 2026 (10 AM - 5 PM)</a:t>
+              <a:t>27th October 2026 (10 AM - 5 PM)</a:t>
             </a:r>
           </a:p>
           <a:p>
@@ -3687,7 +3687,7 @@
                   <a:srgbClr val="0F172A"/>
                 </a:solidFill>
               </a:rPr>
-              <a:t>Marks Allotted: </a:t>
+              <a:t>Curriculum Scope: </a:t>
             </a:r>
             <a:r>
               <a:rPr sz="1000">
@@ -3695,7 +3695,7 @@
                   <a:srgbClr val="0F172A"/>
                 </a:solidFill>
               </a:rPr>
-              <a:t>20 Marks (Mid-Term Assessment)</a:t>
+              <a:t>Sections 4.2, 4.3, 5.1, 5.2, 6.1</a:t>
             </a:r>
           </a:p>
           <a:p>
@@ -3705,7 +3705,7 @@
                   <a:srgbClr val="0F172A"/>
                 </a:solidFill>
               </a:rPr>
-              <a:t>Syllabus Scope: </a:t>
+              <a:t>Cumulative Marks: </a:t>
             </a:r>
             <a:r>
               <a:rPr sz="1000">
@@ -3713,7 +3713,7 @@
                   <a:srgbClr val="0F172A"/>
                 </a:solidFill>
               </a:rPr>
-              <a:t>Sections 2.3, 2.4, 3.1, 4.1</a:t>
+              <a:t>40 Marks Evaluated (10M + 20M + 10M)</a:t>
             </a:r>
           </a:p>
           <a:p>
@@ -4074,7 +4074,7 @@
                   <a:srgbClr val="475569"/>
                 </a:solidFill>
               </a:rPr>
-              <a:t>Second Progress Work / Mid-Term Exam (13/10/2026  •  20 Marks)</a:t>
+              <a:t>Third Progress Work Evaluation (27/10/2026  •  10 Marks)</a:t>
             </a:r>
           </a:p>
           <a:p>
@@ -4143,7 +4143,7 @@
                   <a:srgbClr val="475569"/>
                 </a:solidFill>
               </a:rPr>
-              <a:t>Class &amp; Sequence Diagrams, Star Schema Marts &amp; UI Validations Complete</a:t>
+              <a:t>Chapters 1 through 6 Complete; Ready for Final Spiral Binding &amp; SEE Examination</a:t>
             </a:r>
           </a:p>
         </p:txBody>
@@ -4278,7 +4278,7 @@
               </a:defRPr>
             </a:pPr>
             <a:r>
-              <a:t>System Architecture &amp; Phase 1 Foundations Recap</a:t>
+              <a:t>Cumulative Project Architecture (Chapters 1 to 3 Summary)</a:t>
             </a:r>
           </a:p>
         </p:txBody>
@@ -4395,7 +4395,7 @@
               </a:defRPr>
             </a:pPr>
             <a:r>
-              <a:t>B.Sc. in Artificial Intelligence &amp; Data Science (Sem V)  •  Institute of Advanced Research  •  Second Progress Work (13/10/2026)</a:t>
+              <a:t>B.Sc. in Artificial Intelligence &amp; Data Science (Sem V)  •  Institute of Advanced Research  •  Third Progress Work (27/10/2026)</a:t>
             </a:r>
           </a:p>
         </p:txBody>
@@ -4475,7 +4475,7 @@
               </a:defRPr>
             </a:pPr>
             <a:r>
-              <a:t>1. Phase 1 Foundations (10 Marks)</a:t>
+              <a:t>1. About the System (Ch. 1)</a:t>
             </a:r>
           </a:p>
           <a:p>
@@ -4490,7 +4490,7 @@
                   <a:srgbClr val="1E1B4B"/>
                 </a:solidFill>
               </a:rPr>
-              <a:t>• Problem Formulation (1.1): </a:t>
+              <a:t>• Problem Definition: </a:t>
             </a:r>
             <a:r>
               <a:rPr sz="950">
@@ -4498,7 +4498,7 @@
                   <a:srgbClr val="0F172A"/>
                 </a:solidFill>
               </a:rPr>
-              <a:t>Defined retention economics, surging CAC, and OLTP operational gaps.</a:t>
+              <a:t>Surging customer acquisition costs and lack of longitudinal cohort tracking in OLTP order logs.</a:t>
             </a:r>
           </a:p>
           <a:p>
@@ -4513,7 +4513,7 @@
                   <a:srgbClr val="1E1B4B"/>
                 </a:solidFill>
               </a:rPr>
-              <a:t>• Requirement Matrix (1.2): </a:t>
+              <a:t>• Requirement Matrix: </a:t>
             </a:r>
             <a:r>
               <a:rPr sz="950">
@@ -4521,7 +4521,7 @@
                   <a:srgbClr val="0F172A"/>
                 </a:solidFill>
               </a:rPr>
-              <a:t>Specified FR-01 through FR-06 and NFR-01 to NFR-03 with hardware specs.</a:t>
+              <a:t>FR-01 to FR-06 data contracts, sub-5s latency, deterministic reproducibility (`seed=42`).</a:t>
             </a:r>
           </a:p>
           <a:p>
@@ -4536,7 +4536,7 @@
                   <a:srgbClr val="1E1B4B"/>
                 </a:solidFill>
               </a:rPr>
-              <a:t>• Tech Stack Layering (1.3): </a:t>
+              <a:t>• Technology Stack: </a:t>
             </a:r>
             <a:r>
               <a:rPr sz="950">
@@ -4544,7 +4544,7 @@
                   <a:srgbClr val="0F172A"/>
                 </a:solidFill>
               </a:rPr>
-              <a:t>Configured Python 3.9, Pandas 2.3, Scikit-Learn 1.6, and Chart.js.</a:t>
+              <a:t>Python 3.9, Pandas 2.3, NumPy 2.0, Scikit-Learn 1.6, SciPy, Tailwind CSS, Chart.js.</a:t>
             </a:r>
           </a:p>
           <a:p>
@@ -4559,7 +4559,7 @@
                   <a:srgbClr val="1E1B4B"/>
                 </a:solidFill>
               </a:rPr>
-              <a:t>• DFD Architecture (2.1): </a:t>
+              <a:t>• Architectural Decoupling: </a:t>
             </a:r>
             <a:r>
               <a:rPr sz="950">
@@ -4567,7 +4567,7 @@
                   <a:srgbClr val="0F172A"/>
                 </a:solidFill>
               </a:rPr>
-              <a:t>Constructed Context Level 0, Level 1 Pipeline, and Level 2 Decomposition DFDs.</a:t>
+              <a:t>Raw data refinery separated from dimensional marts and presentation layers.</a:t>
             </a:r>
           </a:p>
         </p:txBody>
@@ -4581,6 +4581,178 @@
         <p:spPr>
           <a:xfrm>
             <a:off x="4425696" y="1371600"/>
+            <a:ext cx="3328416" cy="4754880"/>
+          </a:xfrm>
+          <a:prstGeom prst="roundRect">
+            <a:avLst/>
+          </a:prstGeom>
+          <a:solidFill>
+            <a:srgbClr val="F8FAFC"/>
+          </a:solidFill>
+          <a:ln w="12700">
+            <a:solidFill>
+              <a:srgbClr val="E2E8F0"/>
+            </a:solidFill>
+          </a:ln>
+        </p:spPr>
+        <p:style>
+          <a:lnRef idx="1">
+            <a:schemeClr val="accent1"/>
+          </a:lnRef>
+          <a:fillRef idx="3">
+            <a:schemeClr val="accent1"/>
+          </a:fillRef>
+          <a:effectRef idx="2">
+            <a:schemeClr val="accent1"/>
+          </a:effectRef>
+          <a:fontRef idx="minor">
+            <a:schemeClr val="lt1"/>
+          </a:fontRef>
+        </p:style>
+        <p:txBody>
+          <a:bodyPr rtlCol="0" anchor="ctr"/>
+          <a:lstStyle/>
+          <a:p>
+            <a:pPr algn="ctr"/>
+          </a:p>
+        </p:txBody>
+      </p:sp>
+      <p:sp>
+        <p:nvSpPr>
+          <p:cNvPr id="11" name="TextBox 10"/>
+          <p:cNvSpPr txBox="1"/>
+          <p:nvPr/>
+        </p:nvSpPr>
+        <p:spPr>
+          <a:xfrm>
+            <a:off x="4562856" y="1508760"/>
+            <a:ext cx="3054096" cy="4480560"/>
+          </a:xfrm>
+          <a:prstGeom prst="rect">
+            <a:avLst/>
+          </a:prstGeom>
+          <a:noFill/>
+        </p:spPr>
+        <p:txBody>
+          <a:bodyPr wrap="square">
+            <a:spAutoFit/>
+          </a:bodyPr>
+          <a:lstStyle/>
+          <a:p>
+            <a:pPr>
+              <a:defRPr sz="1350" b="1">
+                <a:solidFill>
+                  <a:srgbClr val="7A003C"/>
+                </a:solidFill>
+              </a:defRPr>
+            </a:pPr>
+            <a:r>
+              <a:t>2. UML &amp; DFD Design (Ch. 2)</a:t>
+            </a:r>
+          </a:p>
+          <a:p>
+            <a:pPr>
+              <a:spcBef>
+                <a:spcPts val="800"/>
+              </a:spcBef>
+            </a:pPr>
+            <a:r>
+              <a:rPr b="1" sz="1000">
+                <a:solidFill>
+                  <a:srgbClr val="1E1B4B"/>
+                </a:solidFill>
+              </a:rPr>
+              <a:t>• Level 0, 1, 2 DFDs: </a:t>
+            </a:r>
+            <a:r>
+              <a:rPr sz="950">
+                <a:solidFill>
+                  <a:srgbClr val="0F172A"/>
+                </a:solidFill>
+              </a:rPr>
+              <a:t>Global system boundary, 5-stage transformation pipeline, and algorithmic decomposition.</a:t>
+            </a:r>
+          </a:p>
+          <a:p>
+            <a:pPr>
+              <a:spcBef>
+                <a:spcPts val="800"/>
+              </a:spcBef>
+            </a:pPr>
+            <a:r>
+              <a:rPr b="1" sz="1000">
+                <a:solidFill>
+                  <a:srgbClr val="1E1B4B"/>
+                </a:solidFill>
+              </a:rPr>
+              <a:t>• Use Case Model: </a:t>
+            </a:r>
+            <a:r>
+              <a:rPr sz="950">
+                <a:solidFill>
+                  <a:srgbClr val="0F172A"/>
+                </a:solidFill>
+              </a:rPr>
+              <a:t>6 formal operational capabilities (UC-01 to UC-06) across 4 primary actors.</a:t>
+            </a:r>
+          </a:p>
+          <a:p>
+            <a:pPr>
+              <a:spcBef>
+                <a:spcPts val="800"/>
+              </a:spcBef>
+            </a:pPr>
+            <a:r>
+              <a:rPr b="1" sz="1000">
+                <a:solidFill>
+                  <a:srgbClr val="1E1B4B"/>
+                </a:solidFill>
+              </a:rPr>
+              <a:t>• Class Diagram: </a:t>
+            </a:r>
+            <a:r>
+              <a:rPr sz="950">
+                <a:solidFill>
+                  <a:srgbClr val="0F172A"/>
+                </a:solidFill>
+              </a:rPr>
+              <a:t>Object domain model: TransactionRecord, CleanRefineryPipeline, RFMFeatureEngineer, KMeansEngine.</a:t>
+            </a:r>
+          </a:p>
+          <a:p>
+            <a:pPr>
+              <a:spcBef>
+                <a:spcPts val="800"/>
+              </a:spcBef>
+            </a:pPr>
+            <a:r>
+              <a:rPr b="1" sz="1000">
+                <a:solidFill>
+                  <a:srgbClr val="1E1B4B"/>
+                </a:solidFill>
+              </a:rPr>
+              <a:t>• Sequence Diagram: </a:t>
+            </a:r>
+            <a:r>
+              <a:rPr sz="950">
+                <a:solidFill>
+                  <a:srgbClr val="0F172A"/>
+                </a:solidFill>
+              </a:rPr>
+              <a:t>11-step synchronous/asynchronous execution protocol across lifelines.</a:t>
+            </a:r>
+          </a:p>
+        </p:txBody>
+      </p:sp>
+      <p:sp>
+        <p:nvSpPr>
+          <p:cNvPr id="12" name="Rounded Rectangle 11"/>
+          <p:cNvSpPr/>
+          <p:nvPr/>
+        </p:nvSpPr>
+        <p:spPr>
+          <a:xfrm>
+            <a:off x="8119872" y="1371600"/>
             <a:ext cx="3328416" cy="4754880"/>
           </a:xfrm>
           <a:prstGeom prst="roundRect">
@@ -4619,13 +4791,13 @@
       </p:sp>
       <p:sp>
         <p:nvSpPr>
-          <p:cNvPr id="11" name="TextBox 10"/>
+          <p:cNvPr id="13" name="TextBox 12"/>
           <p:cNvSpPr txBox="1"/>
           <p:nvPr/>
         </p:nvSpPr>
         <p:spPr>
           <a:xfrm>
-            <a:off x="4562856" y="1508760"/>
+            <a:off x="8257032" y="1508760"/>
             <a:ext cx="3054096" cy="4480560"/>
           </a:xfrm>
           <a:prstGeom prst="rect">
@@ -4647,7 +4819,7 @@
               </a:defRPr>
             </a:pPr>
             <a:r>
-              <a:t>2. Phase 2 Deliverables (20 Marks)</a:t>
+              <a:t>3. Star-Schema Marts (Ch. 3)</a:t>
             </a:r>
           </a:p>
           <a:p>
@@ -4662,7 +4834,7 @@
                   <a:srgbClr val="1E1B4B"/>
                 </a:solidFill>
               </a:rPr>
-              <a:t>• UML Class Diagram (2.3): </a:t>
+              <a:t>• FACT_TRANSACTIONS: </a:t>
             </a:r>
             <a:r>
               <a:rPr sz="950">
@@ -4670,7 +4842,7 @@
                   <a:srgbClr val="0F172A"/>
                 </a:solidFill>
               </a:rPr>
-              <a:t>Domain entity model &amp; pipeline class architecture (TransactionRecord, Refinery, RFM, KMeans).</a:t>
+              <a:t>Granular order facts with gross spend and foreign keys to dimensions.</a:t>
             </a:r>
           </a:p>
           <a:p>
@@ -4685,7 +4857,7 @@
                   <a:srgbClr val="1E1B4B"/>
                 </a:solidFill>
               </a:rPr>
-              <a:t>• UML Sequence Diagram (2.4): </a:t>
+              <a:t>• FACT_REVERSALS: </a:t>
             </a:r>
             <a:r>
               <a:rPr sz="950">
@@ -4693,7 +4865,7 @@
                   <a:srgbClr val="0F172A"/>
                 </a:solidFill>
               </a:rPr>
-              <a:t>11-step synchronous/asynchronous message dispatch protocol across system lifelines.</a:t>
+              <a:t>Audit ledger isolating credit notes ('^C') and negative items.</a:t>
             </a:r>
           </a:p>
           <a:p>
@@ -4708,7 +4880,7 @@
                   <a:srgbClr val="1E1B4B"/>
                 </a:solidFill>
               </a:rPr>
-              <a:t>• Data Dictionary (3.1): </a:t>
+              <a:t>• DIM_CUSTOMERS: </a:t>
             </a:r>
             <a:r>
               <a:rPr sz="950">
@@ -4716,7 +4888,7 @@
                   <a:srgbClr val="0F172A"/>
                 </a:solidFill>
               </a:rPr>
-              <a:t>Complete star-schema catalog: FACT_TRANSACTIONS, FACT_REVERSALS, DIM_CUSTOMERS.</a:t>
+              <a:t>Longitudinal customer profiles with Recency, Frequency, Spend, and 8 business tiers.</a:t>
             </a:r>
           </a:p>
           <a:p>
@@ -4731,7 +4903,7 @@
                   <a:srgbClr val="1E1B4B"/>
                 </a:solidFill>
               </a:rPr>
-              <a:t>• Screen Layouts (4.1): </a:t>
+              <a:t>• DIM_PRODUCTS &amp; DATE: </a:t>
             </a:r>
             <a:r>
               <a:rPr sz="950">
@@ -4739,179 +4911,7 @@
                   <a:srgbClr val="0F172A"/>
                 </a:solidFill>
               </a:rPr>
-              <a:t>Multi-screen UI layouts with operational input validations (VAL-01 to VAL-04).</a:t>
-            </a:r>
-          </a:p>
-        </p:txBody>
-      </p:sp>
-      <p:sp>
-        <p:nvSpPr>
-          <p:cNvPr id="12" name="Rounded Rectangle 11"/>
-          <p:cNvSpPr/>
-          <p:nvPr/>
-        </p:nvSpPr>
-        <p:spPr>
-          <a:xfrm>
-            <a:off x="8119872" y="1371600"/>
-            <a:ext cx="3328416" cy="4754880"/>
-          </a:xfrm>
-          <a:prstGeom prst="roundRect">
-            <a:avLst/>
-          </a:prstGeom>
-          <a:solidFill>
-            <a:srgbClr val="F8FAFC"/>
-          </a:solidFill>
-          <a:ln w="12700">
-            <a:solidFill>
-              <a:srgbClr val="E2E8F0"/>
-            </a:solidFill>
-          </a:ln>
-        </p:spPr>
-        <p:style>
-          <a:lnRef idx="1">
-            <a:schemeClr val="accent1"/>
-          </a:lnRef>
-          <a:fillRef idx="3">
-            <a:schemeClr val="accent1"/>
-          </a:fillRef>
-          <a:effectRef idx="2">
-            <a:schemeClr val="accent1"/>
-          </a:effectRef>
-          <a:fontRef idx="minor">
-            <a:schemeClr val="lt1"/>
-          </a:fontRef>
-        </p:style>
-        <p:txBody>
-          <a:bodyPr rtlCol="0" anchor="ctr"/>
-          <a:lstStyle/>
-          <a:p>
-            <a:pPr algn="ctr"/>
-          </a:p>
-        </p:txBody>
-      </p:sp>
-      <p:sp>
-        <p:nvSpPr>
-          <p:cNvPr id="13" name="TextBox 12"/>
-          <p:cNvSpPr txBox="1"/>
-          <p:nvPr/>
-        </p:nvSpPr>
-        <p:spPr>
-          <a:xfrm>
-            <a:off x="8257032" y="1508760"/>
-            <a:ext cx="3054096" cy="4480560"/>
-          </a:xfrm>
-          <a:prstGeom prst="rect">
-            <a:avLst/>
-          </a:prstGeom>
-          <a:noFill/>
-        </p:spPr>
-        <p:txBody>
-          <a:bodyPr wrap="square">
-            <a:spAutoFit/>
-          </a:bodyPr>
-          <a:lstStyle/>
-          <a:p>
-            <a:pPr>
-              <a:defRPr sz="1350" b="1">
-                <a:solidFill>
-                  <a:srgbClr val="7A003C"/>
-                </a:solidFill>
-              </a:defRPr>
-            </a:pPr>
-            <a:r>
-              <a:t>3. Technical Value Proposition</a:t>
-            </a:r>
-          </a:p>
-          <a:p>
-            <a:pPr>
-              <a:spcBef>
-                <a:spcPts val="800"/>
-              </a:spcBef>
-            </a:pPr>
-            <a:r>
-              <a:rPr b="1" sz="1000">
-                <a:solidFill>
-                  <a:srgbClr val="1E1B4B"/>
-                </a:solidFill>
-              </a:rPr>
-              <a:t>• Zero Data Leakage: </a:t>
-            </a:r>
-            <a:r>
-              <a:rPr sz="950">
-                <a:solidFill>
-                  <a:srgbClr val="0F172A"/>
-                </a:solidFill>
-              </a:rPr>
-              <a:t>Strict segregation of reversals ensures return items never pollute positive purchase frequency counts.</a:t>
-            </a:r>
-          </a:p>
-          <a:p>
-            <a:pPr>
-              <a:spcBef>
-                <a:spcPts val="800"/>
-              </a:spcBef>
-            </a:pPr>
-            <a:r>
-              <a:rPr b="1" sz="1000">
-                <a:solidFill>
-                  <a:srgbClr val="1E1B4B"/>
-                </a:solidFill>
-              </a:rPr>
-              <a:t>• Skew-Resistant Clustering: </a:t>
-            </a:r>
-            <a:r>
-              <a:rPr sz="950">
-                <a:solidFill>
-                  <a:srgbClr val="0F172A"/>
-                </a:solidFill>
-              </a:rPr>
-              <a:t>Log1p scaling neutralizes Pareto monetary power laws for robust K-Means clustering.</a:t>
-            </a:r>
-          </a:p>
-          <a:p>
-            <a:pPr>
-              <a:spcBef>
-                <a:spcPts val="800"/>
-              </a:spcBef>
-            </a:pPr>
-            <a:r>
-              <a:rPr b="1" sz="1000">
-                <a:solidFill>
-                  <a:srgbClr val="1E1B4B"/>
-                </a:solidFill>
-              </a:rPr>
-              <a:t>• BI Mart Compatibility: </a:t>
-            </a:r>
-            <a:r>
-              <a:rPr sz="950">
-                <a:solidFill>
-                  <a:srgbClr val="0F172A"/>
-                </a:solidFill>
-              </a:rPr>
-              <a:t>Star schema facilitates native query performance in Tableau, Power BI, and SQL engines.</a:t>
-            </a:r>
-          </a:p>
-          <a:p>
-            <a:pPr>
-              <a:spcBef>
-                <a:spcPts val="800"/>
-              </a:spcBef>
-            </a:pPr>
-            <a:r>
-              <a:rPr b="1" sz="1000">
-                <a:solidFill>
-                  <a:srgbClr val="1E1B4B"/>
-                </a:solidFill>
-              </a:rPr>
-              <a:t>• Instant CRM Activation: </a:t>
-            </a:r>
-            <a:r>
-              <a:rPr sz="950">
-                <a:solidFill>
-                  <a:srgbClr val="0F172A"/>
-                </a:solidFill>
-              </a:rPr>
-              <a:t>Interactive UI enables commercial teams to filter and export high-value at-risk cohorts instantly.</a:t>
+              <a:t>Standardized SKU reference catalog and temporal attributes.</a:t>
             </a:r>
           </a:p>
         </p:txBody>
@@ -5010,7 +5010,7 @@
               </a:defRPr>
             </a:pPr>
             <a:r>
-              <a:t>SECTION 2.3  •  SYSTEM DESIGN</a:t>
+              <a:t>SECTION 4.1  •  IMPLEMENTATION UI</a:t>
             </a:r>
           </a:p>
         </p:txBody>
@@ -5046,7 +5046,7 @@
               </a:defRPr>
             </a:pPr>
             <a:r>
-              <a:t>UML Class Diagram (Domain Model &amp; Object Architecture)</a:t>
+              <a:t>Screen Layouts &amp; Operational Input Validations</a:t>
             </a:r>
           </a:p>
         </p:txBody>
@@ -5163,7 +5163,7 @@
               </a:defRPr>
             </a:pPr>
             <a:r>
-              <a:t>B.Sc. in Artificial Intelligence &amp; Data Science (Sem V)  •  Institute of Advanced Research  •  Second Progress Work (13/10/2026)</a:t>
+              <a:t>B.Sc. in Artificial Intelligence &amp; Data Science (Sem V)  •  Institute of Advanced Research  •  Third Progress Work (27/10/2026)</a:t>
             </a:r>
           </a:p>
         </p:txBody>
@@ -5215,7 +5215,7 @@
       </p:sp>
       <p:pic>
         <p:nvPicPr>
-          <p:cNvPr id="9" name="Picture 8" descr="fig_class_diagram.png"/>
+          <p:cNvPr id="9" name="Picture 8" descr="fig_screen_layouts.png"/>
           <p:cNvPicPr>
             <a:picLocks noChangeAspect="1"/>
           </p:cNvPicPr>
@@ -5230,7 +5230,7 @@
         <p:spPr>
           <a:xfrm>
             <a:off x="868680" y="1554480"/>
-            <a:ext cx="5943600" cy="3714750"/>
+            <a:ext cx="5943600" cy="3962400"/>
           </a:xfrm>
           <a:prstGeom prst="rect">
             <a:avLst/>
@@ -5267,7 +5267,7 @@
               </a:defRPr>
             </a:pPr>
             <a:r>
-              <a:t>Figure 2.5: UML Class Diagram (Domain Model &amp; Pipeline Services)</a:t>
+              <a:t>Figure 4.1: Implementation Screen Layouts (4 Synchronized UI Views)</a:t>
             </a:r>
           </a:p>
         </p:txBody>
@@ -5347,13 +5347,13 @@
               </a:defRPr>
             </a:pPr>
             <a:r>
-              <a:t>Core Pipeline Classes &amp; Relationships</a:t>
+              <a:t>Input &amp; Operational Validations</a:t>
             </a:r>
           </a:p>
           <a:p>
             <a:pPr>
               <a:spcBef>
-                <a:spcPts val="400"/>
+                <a:spcPts val="600"/>
               </a:spcBef>
             </a:pPr>
             <a:r>
@@ -5362,21 +5362,21 @@
                   <a:srgbClr val="1E1B4B"/>
                 </a:solidFill>
               </a:rPr>
-              <a:t>• TransactionRecord: </a:t>
-            </a:r>
-            <a:r>
-              <a:rPr sz="880">
+              <a:t>• VAL-01 (Scorecard Integrity): </a:t>
+            </a:r>
+            <a:r>
+              <a:rPr sz="900">
                 <a:solidFill>
                   <a:srgbClr val="0F172A"/>
                 </a:solidFill>
               </a:rPr>
-              <a:t>Domain entity representing single line-item purchases with validation and pricing methods.</a:t>
+              <a:t>Enforces non-negative spend constraints (Spend &gt;= 0.00) and cross-checks active counts against distinct non-null IDs.</a:t>
             </a:r>
           </a:p>
           <a:p>
             <a:pPr>
               <a:spcBef>
-                <a:spcPts val="400"/>
+                <a:spcPts val="600"/>
               </a:spcBef>
             </a:pPr>
             <a:r>
@@ -5385,21 +5385,21 @@
                   <a:srgbClr val="1E1B4B"/>
                 </a:solidFill>
               </a:rPr>
-              <a:t>• CleanRefineryPipeline: </a:t>
-            </a:r>
-            <a:r>
-              <a:rPr sz="880">
+              <a:t>• VAL-02 (Canvas Boundary Constraints): </a:t>
+            </a:r>
+            <a:r>
+              <a:rPr sz="900">
                 <a:solidFill>
                   <a:srgbClr val="0F172A"/>
                 </a:solidFill>
               </a:rPr>
-              <a:t>Orchestrates ingestion, typing, guest session filtering, reversal quarantine, and Tukey IQR capping.</a:t>
+              <a:t>Scatterplot coordinates bounded to Recency [1..365], Frequency [1..50], Spend [0..10,000]. Hover tooltips validate customer existence.</a:t>
             </a:r>
           </a:p>
           <a:p>
             <a:pPr>
               <a:spcBef>
-                <a:spcPts val="400"/>
+                <a:spcPts val="600"/>
               </a:spcBef>
             </a:pPr>
             <a:r>
@@ -5408,21 +5408,21 @@
                   <a:srgbClr val="1E1B4B"/>
                 </a:solidFill>
               </a:rPr>
-              <a:t>• RFMFeatureEngineer: </a:t>
-            </a:r>
-            <a:r>
-              <a:rPr sz="880">
+              <a:t>• VAL-03 (Search Sanitization): </a:t>
+            </a:r>
+            <a:r>
+              <a:rPr sz="900">
                 <a:solidFill>
                   <a:srgbClr val="0F172A"/>
                 </a:solidFill>
               </a:rPr>
-              <a:t>Vectorized engine computing customer Recency (T_obs), Frequency, Spend, and AOV.</a:t>
+              <a:t>Client search input sanitized against script injection. Table pagination enforces integer bounds (1 &lt;= Page &lt;= MaxPage).</a:t>
             </a:r>
           </a:p>
           <a:p>
             <a:pPr>
               <a:spcBef>
-                <a:spcPts val="400"/>
+                <a:spcPts val="600"/>
               </a:spcBef>
             </a:pPr>
             <a:r>
@@ -5431,61 +5431,15 @@
                   <a:srgbClr val="1E1B4B"/>
                 </a:solidFill>
               </a:rPr>
-              <a:t>• KMeansSegmentationEngine: </a:t>
-            </a:r>
-            <a:r>
-              <a:rPr sz="880">
+              <a:t>• VAL-04 (Audit Quarantine Logic): </a:t>
+            </a:r>
+            <a:r>
+              <a:rPr sz="900">
                 <a:solidFill>
                   <a:srgbClr val="0F172A"/>
                 </a:solidFill>
               </a:rPr>
-              <a:t>Encapsulates log1p compression, StandardScaler, K-Means fitting (k=4), and Silhouette diagnostics.</a:t>
-            </a:r>
-          </a:p>
-          <a:p>
-            <a:pPr>
-              <a:spcBef>
-                <a:spcPts val="400"/>
-              </a:spcBef>
-            </a:pPr>
-            <a:r>
-              <a:rPr b="1" sz="950">
-                <a:solidFill>
-                  <a:srgbClr val="1E1B4B"/>
-                </a:solidFill>
-              </a:rPr>
-              <a:t>• QuantileStratifier: </a:t>
-            </a:r>
-            <a:r>
-              <a:rPr sz="880">
-                <a:solidFill>
-                  <a:srgbClr val="0F172A"/>
-                </a:solidFill>
-              </a:rPr>
-              <a:t>Assigns 1–5 quantile scores (pd.qcut) and maps accounts to 8 business operational cohorts.</a:t>
-            </a:r>
-          </a:p>
-          <a:p>
-            <a:pPr>
-              <a:spcBef>
-                <a:spcPts val="400"/>
-              </a:spcBef>
-            </a:pPr>
-            <a:r>
-              <a:rPr b="1" sz="950">
-                <a:solidFill>
-                  <a:srgbClr val="1E1B4B"/>
-                </a:solidFill>
-              </a:rPr>
-              <a:t>• StarSchemaMartExporter: </a:t>
-            </a:r>
-            <a:r>
-              <a:rPr sz="880">
-                <a:solidFill>
-                  <a:srgbClr val="0F172A"/>
-                </a:solidFill>
-              </a:rPr>
-              <a:t>Generates FACT_TRANSACTIONS, FACT_REVERSALS, DIM_CUSTOMERS, and summary JSON.</a:t>
+              <a:t>Reversals strictly enforce cancellation regex ('^C') and negative quantities (Quantity &lt; 0) before insertion into audit stores.</a:t>
             </a:r>
           </a:p>
         </p:txBody>
@@ -5584,7 +5538,7 @@
               </a:defRPr>
             </a:pPr>
             <a:r>
-              <a:t>SECTION 2.4  •  EXECUTION ARCHITECTURE</a:t>
+              <a:t>SECTION 4.2  •  IMPLEMENTATION CODE</a:t>
             </a:r>
           </a:p>
         </p:txBody>
@@ -5620,7 +5574,7 @@
               </a:defRPr>
             </a:pPr>
             <a:r>
-              <a:t>UML Sequence Diagram (Pipeline Execution Workflow)</a:t>
+              <a:t>Sample Coding: Modular Pipeline Architecture (Excerpts)</a:t>
             </a:r>
           </a:p>
         </p:txBody>
@@ -5737,7 +5691,7 @@
               </a:defRPr>
             </a:pPr>
             <a:r>
-              <a:t>B.Sc. in Artificial Intelligence &amp; Data Science (Sem V)  •  Institute of Advanced Research  •  Second Progress Work (13/10/2026)</a:t>
+              <a:t>B.Sc. in Artificial Intelligence &amp; Data Science (Sem V)  •  Institute of Advanced Research  •  Third Progress Work (27/10/2026)</a:t>
             </a:r>
           </a:p>
         </p:txBody>
@@ -5751,13 +5705,13 @@
         <p:spPr>
           <a:xfrm>
             <a:off x="731520" y="1371600"/>
-            <a:ext cx="6217920" cy="4754880"/>
+            <a:ext cx="10728655" cy="1463040"/>
           </a:xfrm>
           <a:prstGeom prst="roundRect">
             <a:avLst/>
           </a:prstGeom>
           <a:solidFill>
-            <a:srgbClr val="F8FAFC"/>
+            <a:srgbClr val="FEF2F2"/>
           </a:solidFill>
           <a:ln w="12700">
             <a:solidFill>
@@ -5787,81 +5741,75 @@
           </a:p>
         </p:txBody>
       </p:sp>
-      <p:pic>
-        <p:nvPicPr>
-          <p:cNvPr id="9" name="Picture 8" descr="fig_sequence_diagram.png"/>
-          <p:cNvPicPr>
-            <a:picLocks noChangeAspect="1"/>
-          </p:cNvPicPr>
-          <p:nvPr/>
-        </p:nvPicPr>
-        <p:blipFill>
-          <a:blip r:embed="rId2"/>
-          <a:stretch>
-            <a:fillRect/>
-          </a:stretch>
-        </p:blipFill>
-        <p:spPr>
-          <a:xfrm>
-            <a:off x="868680" y="1554480"/>
-            <a:ext cx="5943600" cy="3714750"/>
+      <p:sp>
+        <p:nvSpPr>
+          <p:cNvPr id="9" name="TextBox 8"/>
+          <p:cNvSpPr txBox="1"/>
+          <p:nvPr/>
+        </p:nvSpPr>
+        <p:spPr>
+          <a:xfrm>
+            <a:off x="914400" y="1444752"/>
+            <a:ext cx="10362895" cy="1316736"/>
           </a:xfrm>
           <a:prstGeom prst="rect">
             <a:avLst/>
           </a:prstGeom>
-        </p:spPr>
-      </p:pic>
-      <p:sp>
-        <p:nvSpPr>
-          <p:cNvPr id="10" name="TextBox 9"/>
-          <p:cNvSpPr txBox="1"/>
-          <p:nvPr/>
-        </p:nvSpPr>
-        <p:spPr>
-          <a:xfrm>
-            <a:off x="731520" y="5715000"/>
-            <a:ext cx="6217920" cy="320040"/>
-          </a:xfrm>
-          <a:prstGeom prst="rect">
-            <a:avLst/>
-          </a:prstGeom>
           <a:noFill/>
         </p:spPr>
         <p:txBody>
-          <a:bodyPr wrap="none">
+          <a:bodyPr wrap="square">
             <a:spAutoFit/>
           </a:bodyPr>
           <a:lstStyle/>
           <a:p>
-            <a:pPr algn="ctr">
-              <a:defRPr sz="950" b="1">
-                <a:solidFill>
-                  <a:srgbClr val="475569"/>
-                </a:solidFill>
-              </a:defRPr>
-            </a:pPr>
-            <a:r>
-              <a:t>Figure 2.6: UML Sequence Diagram (End-to-End Processing &amp; Activation)</a:t>
-            </a:r>
-          </a:p>
-        </p:txBody>
-      </p:sp>
-      <p:sp>
-        <p:nvSpPr>
-          <p:cNvPr id="11" name="Rounded Rectangle 10"/>
+            <a:r>
+              <a:rPr sz="1100" b="1">
+                <a:solidFill>
+                  <a:srgbClr val="7A003C"/>
+                </a:solidFill>
+                <a:latin typeface="Arial"/>
+              </a:rPr>
+              <a:t>1. Data Refinery &amp; Anomaly Quarantine (clean_refinery_pipeline.py)</a:t>
+            </a:r>
+          </a:p>
+          <a:p>
+            <a:pPr>
+              <a:spcBef>
+                <a:spcPts val="300"/>
+              </a:spcBef>
+            </a:pPr>
+            <a:r>
+              <a:rPr sz="850">
+                <a:solidFill>
+                  <a:srgbClr val="0F172A"/>
+                </a:solidFill>
+                <a:latin typeface="Courier New"/>
+              </a:rPr>
+              <a:t>is_cancellation = df['InvoiceNo'].str.startswith('C', na=False) | (df['Quantity'] &lt;= 0)
+reversals_df = df[is_cancellation].copy()
+sales_df = df[~is_cancellation].copy()
+reversals_df.to_csv(self.output_dir / 'fact_reversals_audit.csv', index=False)</a:t>
+            </a:r>
+          </a:p>
+        </p:txBody>
+      </p:sp>
+      <p:sp>
+        <p:nvSpPr>
+          <p:cNvPr id="10" name="Rounded Rectangle 9"/>
           <p:cNvSpPr/>
           <p:nvPr/>
         </p:nvSpPr>
         <p:spPr>
           <a:xfrm>
-            <a:off x="7223760" y="1371600"/>
-            <a:ext cx="4236415" cy="4754880"/>
+            <a:off x="731520" y="2999232"/>
+            <a:ext cx="10728655" cy="1463040"/>
           </a:xfrm>
           <a:prstGeom prst="roundRect">
             <a:avLst/>
           </a:prstGeom>
           <a:solidFill>
-            <a:srgbClr val="F8FAFC"/>
+            <a:srgbClr val="EFF6FF"/>
           </a:solidFill>
           <a:ln w="12700">
             <a:solidFill>
@@ -5893,14 +5841,14 @@
       </p:sp>
       <p:sp>
         <p:nvSpPr>
-          <p:cNvPr id="12" name="TextBox 11"/>
+          <p:cNvPr id="11" name="TextBox 10"/>
           <p:cNvSpPr txBox="1"/>
           <p:nvPr/>
         </p:nvSpPr>
         <p:spPr>
           <a:xfrm>
-            <a:off x="7406640" y="1508760"/>
-            <a:ext cx="3840480" cy="4480560"/>
+            <a:off x="914400" y="3072384"/>
+            <a:ext cx="10362895" cy="1316736"/>
           </a:xfrm>
           <a:prstGeom prst="rect">
             <a:avLst/>
@@ -5913,153 +5861,133 @@
           </a:bodyPr>
           <a:lstStyle/>
           <a:p>
-            <a:pPr>
-              <a:defRPr sz="1350" b="1">
-                <a:solidFill>
-                  <a:srgbClr val="7A003C"/>
-                </a:solidFill>
-              </a:defRPr>
-            </a:pPr>
-            <a:r>
-              <a:t>11-Step Message Dispatch Protocol</a:t>
+            <a:r>
+              <a:rPr sz="1100" b="1">
+                <a:solidFill>
+                  <a:srgbClr val="2563EB"/>
+                </a:solidFill>
+                <a:latin typeface="Arial"/>
+              </a:rPr>
+              <a:t>2. Vectorized RFM Feature Extraction (rfm_feature_engineering.py)</a:t>
             </a:r>
           </a:p>
           <a:p>
             <a:pPr>
               <a:spcBef>
-                <a:spcPts val="400"/>
+                <a:spcPts val="300"/>
               </a:spcBef>
             </a:pPr>
             <a:r>
-              <a:rPr b="1" sz="950">
-                <a:solidFill>
-                  <a:srgbClr val="1E1B4B"/>
-                </a:solidFill>
-              </a:rPr>
-              <a:t>• Step 1 (Trigger): </a:t>
-            </a:r>
-            <a:r>
-              <a:rPr sz="880">
+              <a:rPr sz="850">
                 <a:solidFill>
                   <a:srgbClr val="0F172A"/>
                 </a:solidFill>
-              </a:rPr>
-              <a:t>Data Engineer initiates trigger_pipeline(raw_csv) to commence ingestion.</a:t>
+                <a:latin typeface="Courier New"/>
+              </a:rPr>
+              <a:t>snapshot_date = df['InvoiceDate'].max() + pd.Timedelta(days=1)
+rfm = df.groupby('CustomerID').agg({
+    'InvoiceDate': lambda x: (snapshot_date - x.max()).days,
+    'InvoiceNo': 'nunique', 'LineTotal': 'sum'
+}).reset_index()</a:t>
+            </a:r>
+          </a:p>
+        </p:txBody>
+      </p:sp>
+      <p:sp>
+        <p:nvSpPr>
+          <p:cNvPr id="12" name="Rounded Rectangle 11"/>
+          <p:cNvSpPr/>
+          <p:nvPr/>
+        </p:nvSpPr>
+        <p:spPr>
+          <a:xfrm>
+            <a:off x="731520" y="4626864"/>
+            <a:ext cx="10728655" cy="1463040"/>
+          </a:xfrm>
+          <a:prstGeom prst="roundRect">
+            <a:avLst/>
+          </a:prstGeom>
+          <a:solidFill>
+            <a:srgbClr val="ECFDF5"/>
+          </a:solidFill>
+          <a:ln w="12700">
+            <a:solidFill>
+              <a:srgbClr val="E2E8F0"/>
+            </a:solidFill>
+          </a:ln>
+        </p:spPr>
+        <p:style>
+          <a:lnRef idx="1">
+            <a:schemeClr val="accent1"/>
+          </a:lnRef>
+          <a:fillRef idx="3">
+            <a:schemeClr val="accent1"/>
+          </a:fillRef>
+          <a:effectRef idx="2">
+            <a:schemeClr val="accent1"/>
+          </a:effectRef>
+          <a:fontRef idx="minor">
+            <a:schemeClr val="lt1"/>
+          </a:fontRef>
+        </p:style>
+        <p:txBody>
+          <a:bodyPr rtlCol="0" anchor="ctr"/>
+          <a:lstStyle/>
+          <a:p>
+            <a:pPr algn="ctr"/>
+          </a:p>
+        </p:txBody>
+      </p:sp>
+      <p:sp>
+        <p:nvSpPr>
+          <p:cNvPr id="13" name="TextBox 12"/>
+          <p:cNvSpPr txBox="1"/>
+          <p:nvPr/>
+        </p:nvSpPr>
+        <p:spPr>
+          <a:xfrm>
+            <a:off x="914400" y="4700016"/>
+            <a:ext cx="10362895" cy="1316736"/>
+          </a:xfrm>
+          <a:prstGeom prst="rect">
+            <a:avLst/>
+          </a:prstGeom>
+          <a:noFill/>
+        </p:spPr>
+        <p:txBody>
+          <a:bodyPr wrap="square">
+            <a:spAutoFit/>
+          </a:bodyPr>
+          <a:lstStyle/>
+          <a:p>
+            <a:r>
+              <a:rPr sz="1100" b="1">
+                <a:solidFill>
+                  <a:srgbClr val="10B981"/>
+                </a:solidFill>
+                <a:latin typeface="Arial"/>
+              </a:rPr>
+              <a:t>3. Skew-Resistant Feature Scaling &amp; K-Means (segmentation_engine.py)</a:t>
             </a:r>
           </a:p>
           <a:p>
             <a:pPr>
               <a:spcBef>
-                <a:spcPts val="400"/>
+                <a:spcPts val="300"/>
               </a:spcBef>
             </a:pPr>
             <a:r>
-              <a:rPr b="1" sz="950">
-                <a:solidFill>
-                  <a:srgbClr val="1E1B4B"/>
-                </a:solidFill>
-              </a:rPr>
-              <a:t>• Steps 2-3 (Refinery): </a:t>
-            </a:r>
-            <a:r>
-              <a:rPr sz="880">
+              <a:rPr sz="850">
                 <a:solidFill>
                   <a:srgbClr val="0F172A"/>
                 </a:solidFill>
-              </a:rPr>
-              <a:t>Self-calls filter unauthenticated sessions, quarantine cancellations, and cap Tukey IQR outliers.</a:t>
-            </a:r>
-          </a:p>
-          <a:p>
-            <a:pPr>
-              <a:spcBef>
-                <a:spcPts val="400"/>
-              </a:spcBef>
-            </a:pPr>
-            <a:r>
-              <a:rPr b="1" sz="950">
-                <a:solidFill>
-                  <a:srgbClr val="1E1B4B"/>
-                </a:solidFill>
-              </a:rPr>
-              <a:t>• Steps 4-5 (Feature Extraction): </a:t>
-            </a:r>
-            <a:r>
-              <a:rPr sz="880">
-                <a:solidFill>
-                  <a:srgbClr val="0F172A"/>
-                </a:solidFill>
-              </a:rPr>
-              <a:t>Cleansed records dispatched to RFMFeatureEngineer, deriving snapshot boundary T_obs.</a:t>
-            </a:r>
-          </a:p>
-          <a:p>
-            <a:pPr>
-              <a:spcBef>
-                <a:spcPts val="400"/>
-              </a:spcBef>
-            </a:pPr>
-            <a:r>
-              <a:rPr b="1" sz="950">
-                <a:solidFill>
-                  <a:srgbClr val="1E1B4B"/>
-                </a:solidFill>
-              </a:rPr>
-              <a:t>• Steps 6-7 (ML Modeling): </a:t>
-            </a:r>
-            <a:r>
-              <a:rPr sz="880">
-                <a:solidFill>
-                  <a:srgbClr val="0F172A"/>
-                </a:solidFill>
-              </a:rPr>
-              <a:t>RFM Analytical Base Table dispatched to KMeansEngine for log1p scaling and k=4 clustering.</a:t>
-            </a:r>
-          </a:p>
-          <a:p>
-            <a:pPr>
-              <a:spcBef>
-                <a:spcPts val="400"/>
-              </a:spcBef>
-            </a:pPr>
-            <a:r>
-              <a:rPr b="1" sz="950">
-                <a:solidFill>
-                  <a:srgbClr val="1E1B4B"/>
-                </a:solidFill>
-              </a:rPr>
-              <a:t>• Steps 8-9 (Data Mart Export): </a:t>
-            </a:r>
-            <a:r>
-              <a:rPr sz="880">
-                <a:solidFill>
-                  <a:srgbClr val="0F172A"/>
-                </a:solidFill>
-              </a:rPr>
-              <a:t>Segments and fact tables persisted to StarSchemaDataMart.</a:t>
-            </a:r>
-          </a:p>
-          <a:p>
-            <a:pPr>
-              <a:spcBef>
-                <a:spcPts val="400"/>
-              </a:spcBef>
-            </a:pPr>
-            <a:r>
-              <a:rPr b="1" sz="950">
-                <a:solidFill>
-                  <a:srgbClr val="1E1B4B"/>
-                </a:solidFill>
-              </a:rPr>
-              <a:t>• Steps 10-11 (Activation): </a:t>
-            </a:r>
-            <a:r>
-              <a:rPr sz="880">
-                <a:solidFill>
-                  <a:srgbClr val="0F172A"/>
-                </a:solidFill>
-              </a:rPr>
-              <a:t>Summary JSON exported to ExecutiveDashboard, rendering KPI cards and spatial scatterplots.</a:t>
+                <a:latin typeface="Courier New"/>
+              </a:rPr>
+              <a:t>rfm_log = np.log1p(rfm_df[['Recency', 'Frequency', 'Monetary']])
+scaler = StandardScaler()
+rfm_scaled = scaler.fit_transform(rfm_log)
+kmeans = KMeans(n_clusters=4, init='k-means++', random_state=42)
+rfm_df['Cluster'] = kmeans.fit_predict(rfm_scaled)</a:t>
             </a:r>
           </a:p>
         </p:txBody>
@@ -6158,7 +6086,7 @@
               </a:defRPr>
             </a:pPr>
             <a:r>
-              <a:t>SECTION 3.1  •  DATA DICTIONARY</a:t>
+              <a:t>SECTION 4.2  •  SECURITY &amp; VALIDATION</a:t>
             </a:r>
           </a:p>
         </p:txBody>
@@ -6194,7 +6122,7 @@
               </a:defRPr>
             </a:pPr>
             <a:r>
-              <a:t>Data Dictionary: Fact Tables (FACT_TRANSACTIONS &amp; FACT_REVERSALS)</a:t>
+              <a:t>Cybersecurity Controls &amp; Algorithmic Diagnostics</a:t>
             </a:r>
           </a:p>
         </p:txBody>
@@ -6311,7 +6239,7 @@
               </a:defRPr>
             </a:pPr>
             <a:r>
-              <a:t>B.Sc. in Artificial Intelligence &amp; Data Science (Sem V)  •  Institute of Advanced Research  •  Second Progress Work (13/10/2026)</a:t>
+              <a:t>B.Sc. in Artificial Intelligence &amp; Data Science (Sem V)  •  Institute of Advanced Research  •  Third Progress Work (27/10/2026)</a:t>
             </a:r>
           </a:p>
         </p:txBody>
@@ -6325,7 +6253,7 @@
         <p:spPr>
           <a:xfrm>
             <a:off x="731520" y="1371600"/>
-            <a:ext cx="5212080" cy="4754880"/>
+            <a:ext cx="6217920" cy="4754880"/>
           </a:xfrm>
           <a:prstGeom prst="roundRect">
             <a:avLst/>
@@ -6361,16 +6289,40 @@
           </a:p>
         </p:txBody>
       </p:sp>
-      <p:sp>
-        <p:nvSpPr>
-          <p:cNvPr id="9" name="TextBox 8"/>
+      <p:pic>
+        <p:nvPicPr>
+          <p:cNvPr id="9" name="Picture 8" descr="fig_kmeans_diagnostics.png"/>
+          <p:cNvPicPr>
+            <a:picLocks noChangeAspect="1"/>
+          </p:cNvPicPr>
+          <p:nvPr/>
+        </p:nvPicPr>
+        <p:blipFill>
+          <a:blip r:embed="rId2"/>
+          <a:stretch>
+            <a:fillRect/>
+          </a:stretch>
+        </p:blipFill>
+        <p:spPr>
+          <a:xfrm>
+            <a:off x="868680" y="1554480"/>
+            <a:ext cx="5943600" cy="2431473"/>
+          </a:xfrm>
+          <a:prstGeom prst="rect">
+            <a:avLst/>
+          </a:prstGeom>
+        </p:spPr>
+      </p:pic>
+      <p:sp>
+        <p:nvSpPr>
+          <p:cNvPr id="10" name="TextBox 9"/>
           <p:cNvSpPr txBox="1"/>
           <p:nvPr/>
         </p:nvSpPr>
         <p:spPr>
           <a:xfrm>
-            <a:off x="914400" y="1508760"/>
-            <a:ext cx="4846320" cy="4480560"/>
+            <a:off x="731520" y="5715000"/>
+            <a:ext cx="6217920" cy="320040"/>
           </a:xfrm>
           <a:prstGeom prst="rect">
             <a:avLst/>
@@ -6378,218 +6330,34 @@
           <a:noFill/>
         </p:spPr>
         <p:txBody>
-          <a:bodyPr wrap="square">
+          <a:bodyPr wrap="none">
             <a:spAutoFit/>
           </a:bodyPr>
           <a:lstStyle/>
           <a:p>
-            <a:pPr>
-              <a:defRPr sz="1300" b="1">
-                <a:solidFill>
-                  <a:srgbClr val="7A003C"/>
+            <a:pPr algn="ctr">
+              <a:defRPr sz="950" b="1">
+                <a:solidFill>
+                  <a:srgbClr val="475569"/>
                 </a:solidFill>
               </a:defRPr>
             </a:pPr>
             <a:r>
-              <a:t>Table 3.1: FACT_TRANSACTIONS (Order Fact Mart)</a:t>
-            </a:r>
-          </a:p>
-          <a:p>
-            <a:pPr>
-              <a:spcBef>
-                <a:spcPts val="300"/>
-              </a:spcBef>
-            </a:pPr>
-            <a:r>
-              <a:rPr b="1" sz="900">
-                <a:solidFill>
-                  <a:srgbClr val="1E1B4B"/>
-                </a:solidFill>
-              </a:rPr>
-              <a:t>• transaction_id (BIGINT, PK): </a:t>
-            </a:r>
-            <a:r>
-              <a:rPr sz="850">
-                <a:solidFill>
-                  <a:srgbClr val="0F172A"/>
-                </a:solidFill>
-              </a:rPr>
-              <a:t>Surrogate primary key generated monotonically.</a:t>
-            </a:r>
-          </a:p>
-          <a:p>
-            <a:pPr>
-              <a:spcBef>
-                <a:spcPts val="300"/>
-              </a:spcBef>
-            </a:pPr>
-            <a:r>
-              <a:rPr b="1" sz="900">
-                <a:solidFill>
-                  <a:srgbClr val="1E1B4B"/>
-                </a:solidFill>
-              </a:rPr>
-              <a:t>• invoice_no (VARCHAR(20)): </a:t>
-            </a:r>
-            <a:r>
-              <a:rPr sz="850">
-                <a:solidFill>
-                  <a:srgbClr val="0F172A"/>
-                </a:solidFill>
-              </a:rPr>
-              <a:t>6-digit order identifier (e.g. 536365).</a:t>
-            </a:r>
-          </a:p>
-          <a:p>
-            <a:pPr>
-              <a:spcBef>
-                <a:spcPts val="300"/>
-              </a:spcBef>
-            </a:pPr>
-            <a:r>
-              <a:rPr b="1" sz="900">
-                <a:solidFill>
-                  <a:srgbClr val="1E1B4B"/>
-                </a:solidFill>
-              </a:rPr>
-              <a:t>• stock_code (VARCHAR(20), FK): </a:t>
-            </a:r>
-            <a:r>
-              <a:rPr sz="850">
-                <a:solidFill>
-                  <a:srgbClr val="0F172A"/>
-                </a:solidFill>
-              </a:rPr>
-              <a:t>Foreign key referencing DIM_PRODUCTS.</a:t>
-            </a:r>
-          </a:p>
-          <a:p>
-            <a:pPr>
-              <a:spcBef>
-                <a:spcPts val="300"/>
-              </a:spcBef>
-            </a:pPr>
-            <a:r>
-              <a:rPr b="1" sz="900">
-                <a:solidFill>
-                  <a:srgbClr val="1E1B4B"/>
-                </a:solidFill>
-              </a:rPr>
-              <a:t>• quantity (INTEGER): </a:t>
-            </a:r>
-            <a:r>
-              <a:rPr sz="850">
-                <a:solidFill>
-                  <a:srgbClr val="0F172A"/>
-                </a:solidFill>
-              </a:rPr>
-              <a:t>Item units purchased; strictly Quantity &gt; 0.</a:t>
-            </a:r>
-          </a:p>
-          <a:p>
-            <a:pPr>
-              <a:spcBef>
-                <a:spcPts val="300"/>
-              </a:spcBef>
-            </a:pPr>
-            <a:r>
-              <a:rPr b="1" sz="900">
-                <a:solidFill>
-                  <a:srgbClr val="1E1B4B"/>
-                </a:solidFill>
-              </a:rPr>
-              <a:t>• invoice_date (TIMESTAMP, FK): </a:t>
-            </a:r>
-            <a:r>
-              <a:rPr sz="850">
-                <a:solidFill>
-                  <a:srgbClr val="0F172A"/>
-                </a:solidFill>
-              </a:rPr>
-              <a:t>Transaction timestamp referencing DIM_DATE.</a:t>
-            </a:r>
-          </a:p>
-          <a:p>
-            <a:pPr>
-              <a:spcBef>
-                <a:spcPts val="300"/>
-              </a:spcBef>
-            </a:pPr>
-            <a:r>
-              <a:rPr b="1" sz="900">
-                <a:solidFill>
-                  <a:srgbClr val="1E1B4B"/>
-                </a:solidFill>
-              </a:rPr>
-              <a:t>• unit_price (DECIMAL(10,2)): </a:t>
-            </a:r>
-            <a:r>
-              <a:rPr sz="850">
-                <a:solidFill>
-                  <a:srgbClr val="0F172A"/>
-                </a:solidFill>
-              </a:rPr>
-              <a:t>Product sale unit price; strictly UnitPrice &gt; 0.</a:t>
-            </a:r>
-          </a:p>
-          <a:p>
-            <a:pPr>
-              <a:spcBef>
-                <a:spcPts val="300"/>
-              </a:spcBef>
-            </a:pPr>
-            <a:r>
-              <a:rPr b="1" sz="900">
-                <a:solidFill>
-                  <a:srgbClr val="1E1B4B"/>
-                </a:solidFill>
-              </a:rPr>
-              <a:t>• customer_id (VARCHAR(20), FK): </a:t>
-            </a:r>
-            <a:r>
-              <a:rPr sz="850">
-                <a:solidFill>
-                  <a:srgbClr val="0F172A"/>
-                </a:solidFill>
-              </a:rPr>
-              <a:t>Foreign key referencing DIM_CUSTOMERS.</a:t>
-            </a:r>
-          </a:p>
-          <a:p>
-            <a:pPr>
-              <a:spcBef>
-                <a:spcPts val="300"/>
-              </a:spcBef>
-            </a:pPr>
-            <a:r>
-              <a:rPr b="1" sz="900">
-                <a:solidFill>
-                  <a:srgbClr val="1E1B4B"/>
-                </a:solidFill>
-              </a:rPr>
-              <a:t>• gross_amount (DECIMAL(12,2)): </a:t>
-            </a:r>
-            <a:r>
-              <a:rPr sz="850">
-                <a:solidFill>
-                  <a:srgbClr val="0F172A"/>
-                </a:solidFill>
-              </a:rPr>
-              <a:t>Line spend: Quantity * UnitPrice.</a:t>
-            </a:r>
-          </a:p>
-        </p:txBody>
-      </p:sp>
-      <p:sp>
-        <p:nvSpPr>
-          <p:cNvPr id="10" name="Rounded Rectangle 9"/>
+              <a:t>Figure 4.2: K-Means Inertia Elbow Curve &amp; Silhouette Diagnostic Profile</a:t>
+            </a:r>
+          </a:p>
+        </p:txBody>
+      </p:sp>
+      <p:sp>
+        <p:nvSpPr>
+          <p:cNvPr id="11" name="Rounded Rectangle 10"/>
           <p:cNvSpPr/>
           <p:nvPr/>
         </p:nvSpPr>
         <p:spPr>
           <a:xfrm>
-            <a:off x="6217920" y="1371600"/>
-            <a:ext cx="5242255" cy="4754880"/>
+            <a:off x="7223760" y="1371600"/>
+            <a:ext cx="4236415" cy="4754880"/>
           </a:xfrm>
           <a:prstGeom prst="roundRect">
             <a:avLst/>
@@ -6627,14 +6395,14 @@
       </p:sp>
       <p:sp>
         <p:nvSpPr>
-          <p:cNvPr id="11" name="TextBox 10"/>
+          <p:cNvPr id="12" name="TextBox 11"/>
           <p:cNvSpPr txBox="1"/>
           <p:nvPr/>
         </p:nvSpPr>
         <p:spPr>
           <a:xfrm>
-            <a:off x="6400800" y="1508760"/>
-            <a:ext cx="4846320" cy="4480560"/>
+            <a:off x="7406640" y="1508760"/>
+            <a:ext cx="3840480" cy="4480560"/>
           </a:xfrm>
           <a:prstGeom prst="rect">
             <a:avLst/>
@@ -6648,198 +6416,129 @@
           <a:lstStyle/>
           <a:p>
             <a:pPr>
-              <a:defRPr sz="1300" b="1">
+              <a:defRPr sz="1350" b="1">
                 <a:solidFill>
                   <a:srgbClr val="7A003C"/>
                 </a:solidFill>
               </a:defRPr>
             </a:pPr>
             <a:r>
-              <a:t>Table 3.2: FACT_REVERSALS (Audit Fact Mart)</a:t>
+              <a:t>5 Core Cybersecurity Tasks</a:t>
             </a:r>
           </a:p>
           <a:p>
             <a:pPr>
               <a:spcBef>
-                <a:spcPts val="300"/>
+                <a:spcPts val="400"/>
               </a:spcBef>
             </a:pPr>
             <a:r>
-              <a:rPr b="1" sz="900">
+              <a:rPr b="1" sz="950">
                 <a:solidFill>
                   <a:srgbClr val="1E1B4B"/>
                 </a:solidFill>
               </a:rPr>
-              <a:t>• reversal_id (BIGINT, PK): </a:t>
-            </a:r>
-            <a:r>
-              <a:rPr sz="850">
+              <a:t>1. PII Masking &amp; Privacy: </a:t>
+            </a:r>
+            <a:r>
+              <a:rPr sz="880">
                 <a:solidFill>
                   <a:srgbClr val="0F172A"/>
                 </a:solidFill>
               </a:rPr>
-              <a:t>Surrogate primary key for return audit records.</a:t>
+              <a:t>Customer IDs synthesized into opaque alphanumeric strings (CUST-14911), preventing personal data leakage.</a:t>
             </a:r>
           </a:p>
           <a:p>
             <a:pPr>
               <a:spcBef>
-                <a:spcPts val="300"/>
+                <a:spcPts val="400"/>
               </a:spcBef>
             </a:pPr>
             <a:r>
-              <a:rPr b="1" sz="900">
+              <a:rPr b="1" sz="950">
                 <a:solidFill>
                   <a:srgbClr val="1E1B4B"/>
                 </a:solidFill>
               </a:rPr>
-              <a:t>• invoice_no (VARCHAR(20)): </a:t>
-            </a:r>
-            <a:r>
-              <a:rPr sz="850">
+              <a:t>2. Input Sanitization: </a:t>
+            </a:r>
+            <a:r>
+              <a:rPr sz="880">
                 <a:solidFill>
                   <a:srgbClr val="0F172A"/>
                 </a:solidFill>
               </a:rPr>
-              <a:t>Cancellation invoice matching regex '^C[0-9]+'.</a:t>
+              <a:t>Client-side search sanitization rejects special characters, mitigating script injection and XSS.</a:t>
             </a:r>
           </a:p>
           <a:p>
             <a:pPr>
               <a:spcBef>
-                <a:spcPts val="300"/>
+                <a:spcPts val="400"/>
               </a:spcBef>
             </a:pPr>
             <a:r>
-              <a:rPr b="1" sz="900">
+              <a:rPr b="1" sz="950">
                 <a:solidFill>
                   <a:srgbClr val="1E1B4B"/>
                 </a:solidFill>
               </a:rPr>
-              <a:t>• stock_code (VARCHAR(20), FK): </a:t>
-            </a:r>
-            <a:r>
-              <a:rPr sz="850">
+              <a:t>3. Algorithmic Determinism: </a:t>
+            </a:r>
+            <a:r>
+              <a:rPr sz="880">
                 <a:solidFill>
                   <a:srgbClr val="0F172A"/>
                 </a:solidFill>
               </a:rPr>
-              <a:t>Foreign key referencing returned product SKU.</a:t>
+              <a:t>Fixed random state (seed=42) guarantees 100% reproducible cluster centroids across runtime environments.</a:t>
             </a:r>
           </a:p>
           <a:p>
             <a:pPr>
               <a:spcBef>
-                <a:spcPts val="300"/>
+                <a:spcPts val="400"/>
               </a:spcBef>
             </a:pPr>
             <a:r>
-              <a:rPr b="1" sz="900">
+              <a:rPr b="1" sz="950">
                 <a:solidFill>
                   <a:srgbClr val="1E1B4B"/>
                 </a:solidFill>
               </a:rPr>
-              <a:t>• return_quantity (INTEGER): </a:t>
-            </a:r>
-            <a:r>
-              <a:rPr sz="850">
+              <a:t>4. Immutable Audit Ledger: </a:t>
+            </a:r>
+            <a:r>
+              <a:rPr sz="880">
                 <a:solidFill>
                   <a:srgbClr val="0F172A"/>
                 </a:solidFill>
               </a:rPr>
-              <a:t>Negative units returned (Quantity &lt; 0).</a:t>
+              <a:t>Quarantined returns stored in fact_reversals_audit.csv with row integrity checks.</a:t>
             </a:r>
           </a:p>
           <a:p>
             <a:pPr>
               <a:spcBef>
-                <a:spcPts val="300"/>
+                <a:spcPts val="400"/>
               </a:spcBef>
             </a:pPr>
             <a:r>
-              <a:rPr b="1" sz="900">
+              <a:rPr b="1" sz="950">
                 <a:solidFill>
                   <a:srgbClr val="1E1B4B"/>
                 </a:solidFill>
               </a:rPr>
-              <a:t>• reversal_date (TIMESTAMP, FK): </a:t>
-            </a:r>
-            <a:r>
-              <a:rPr sz="850">
+              <a:t>5. Safe Export Protocols: </a:t>
+            </a:r>
+            <a:r>
+              <a:rPr sz="880">
                 <a:solidFill>
                   <a:srgbClr val="0F172A"/>
                 </a:solidFill>
               </a:rPr>
-              <a:t>Timestamp when cancellation was processed.</a:t>
-            </a:r>
-          </a:p>
-          <a:p>
-            <a:pPr>
-              <a:spcBef>
-                <a:spcPts val="300"/>
-              </a:spcBef>
-            </a:pPr>
-            <a:r>
-              <a:rPr b="1" sz="900">
-                <a:solidFill>
-                  <a:srgbClr val="1E1B4B"/>
-                </a:solidFill>
-              </a:rPr>
-              <a:t>• unit_price (DECIMAL(10,2)): </a:t>
-            </a:r>
-            <a:r>
-              <a:rPr sz="850">
-                <a:solidFill>
-                  <a:srgbClr val="0F172A"/>
-                </a:solidFill>
-              </a:rPr>
-              <a:t>Original sale unit price of returned item.</a:t>
-            </a:r>
-          </a:p>
-          <a:p>
-            <a:pPr>
-              <a:spcBef>
-                <a:spcPts val="300"/>
-              </a:spcBef>
-            </a:pPr>
-            <a:r>
-              <a:rPr b="1" sz="900">
-                <a:solidFill>
-                  <a:srgbClr val="1E1B4B"/>
-                </a:solidFill>
-              </a:rPr>
-              <a:t>• customer_id (VARCHAR(20), FK): </a:t>
-            </a:r>
-            <a:r>
-              <a:rPr sz="850">
-                <a:solidFill>
-                  <a:srgbClr val="0F172A"/>
-                </a:solidFill>
-              </a:rPr>
-              <a:t>Foreign key referencing customer returning items.</a:t>
-            </a:r>
-          </a:p>
-          <a:p>
-            <a:pPr>
-              <a:spcBef>
-                <a:spcPts val="300"/>
-              </a:spcBef>
-            </a:pPr>
-            <a:r>
-              <a:rPr b="1" sz="900">
-                <a:solidFill>
-                  <a:srgbClr val="1E1B4B"/>
-                </a:solidFill>
-              </a:rPr>
-              <a:t>• Operational Integrity: </a:t>
-            </a:r>
-            <a:r>
-              <a:rPr sz="850">
-                <a:solidFill>
-                  <a:srgbClr val="0F172A"/>
-                </a:solidFill>
-              </a:rPr>
-              <a:t>Quarantined in fact_reversals_audit.csv to ensure return events never distort positive spend metrics.</a:t>
+              <a:t>CSV audience downloads enforce header whitelisting to eliminate CSV formula injection vulnerabilities.</a:t>
             </a:r>
           </a:p>
         </p:txBody>
@@ -6938,7 +6637,7 @@
               </a:defRPr>
             </a:pPr>
             <a:r>
-              <a:t>SECTION 3.1  •  DATA DICTIONARY</a:t>
+              <a:t>SECTION 4.3  •  OPERATIONS</a:t>
             </a:r>
           </a:p>
         </p:txBody>
@@ -6974,7 +6673,7 @@
               </a:defRPr>
             </a:pPr>
             <a:r>
-              <a:t>Data Dictionary: Dimension Tables (DIM_CUSTOMERS &amp; DIM_PRODUCTS)</a:t>
+              <a:t>Steps of the Execution Project (Automated Pipeline Protocol)</a:t>
             </a:r>
           </a:p>
         </p:txBody>
@@ -7091,7 +6790,7 @@
               </a:defRPr>
             </a:pPr>
             <a:r>
-              <a:t>B.Sc. in Artificial Intelligence &amp; Data Science (Sem V)  •  Institute of Advanced Research  •  Second Progress Work (13/10/2026)</a:t>
+              <a:t>B.Sc. in Artificial Intelligence &amp; Data Science (Sem V)  •  Institute of Advanced Research  •  Third Progress Work (27/10/2026)</a:t>
             </a:r>
           </a:p>
         </p:txBody>
@@ -7105,7 +6804,7 @@
         <p:spPr>
           <a:xfrm>
             <a:off x="731520" y="1371600"/>
-            <a:ext cx="5486400" cy="4754880"/>
+            <a:ext cx="10728655" cy="841248"/>
           </a:xfrm>
           <a:prstGeom prst="roundRect">
             <a:avLst/>
@@ -7149,8 +6848,8 @@
         </p:nvSpPr>
         <p:spPr>
           <a:xfrm>
-            <a:off x="914400" y="1508760"/>
-            <a:ext cx="5120640" cy="4480560"/>
+            <a:off x="914400" y="1426464"/>
+            <a:ext cx="10362895" cy="731520"/>
           </a:xfrm>
           <a:prstGeom prst="rect">
             <a:avLst/>
@@ -7163,199 +6862,37 @@
           </a:bodyPr>
           <a:lstStyle/>
           <a:p>
-            <a:pPr>
-              <a:defRPr sz="1300" b="1">
+            <a:r>
+              <a:rPr b="1" sz="1050">
                 <a:solidFill>
                   <a:srgbClr val="7A003C"/>
                 </a:solidFill>
-              </a:defRPr>
-            </a:pPr>
-            <a:r>
-              <a:t>Table 3.3: DIM_CUSTOMERS (RFM Behavioral Mart)</a:t>
+              </a:rPr>
+              <a:t>Step 1: Environment Setup &amp; Dependency Verification  </a:t>
+            </a:r>
+            <a:r>
+              <a:rPr sz="950">
+                <a:solidFill>
+                  <a:srgbClr val="0F172A"/>
+                </a:solidFill>
+              </a:rPr>
+              <a:t>• Initializes Python 3.9 virtual environment and verifies Pandas, NumPy, Scikit-Learn, and SciPy packages.</a:t>
             </a:r>
           </a:p>
           <a:p>
             <a:pPr>
               <a:spcBef>
-                <a:spcPts val="300"/>
+                <a:spcPts val="200"/>
               </a:spcBef>
             </a:pPr>
             <a:r>
-              <a:rPr b="1" sz="900">
-                <a:solidFill>
-                  <a:srgbClr val="1E1B4B"/>
-                </a:solidFill>
-              </a:rPr>
-              <a:t>• customer_key (BIGINT, PK): </a:t>
-            </a:r>
-            <a:r>
-              <a:rPr sz="850">
-                <a:solidFill>
-                  <a:srgbClr val="0F172A"/>
-                </a:solidFill>
-              </a:rPr>
-              <a:t>Surrogate primary key for customer dimension.</a:t>
-            </a:r>
-          </a:p>
-          <a:p>
-            <a:pPr>
-              <a:spcBef>
-                <a:spcPts val="300"/>
-              </a:spcBef>
-            </a:pPr>
-            <a:r>
-              <a:rPr b="1" sz="900">
-                <a:solidFill>
-                  <a:srgbClr val="1E1B4B"/>
-                </a:solidFill>
-              </a:rPr>
-              <a:t>• customer_id (VARCHAR(20)): </a:t>
-            </a:r>
-            <a:r>
-              <a:rPr sz="850">
-                <a:solidFill>
-                  <a:srgbClr val="0F172A"/>
-                </a:solidFill>
-              </a:rPr>
-              <a:t>Unique authenticated natural customer ID.</a:t>
-            </a:r>
-          </a:p>
-          <a:p>
-            <a:pPr>
-              <a:spcBef>
-                <a:spcPts val="300"/>
-              </a:spcBef>
-            </a:pPr>
-            <a:r>
-              <a:rPr b="1" sz="900">
-                <a:solidFill>
-                  <a:srgbClr val="1E1B4B"/>
-                </a:solidFill>
-              </a:rPr>
-              <a:t>• recency_days (INTEGER): </a:t>
-            </a:r>
-            <a:r>
-              <a:rPr sz="850">
-                <a:solidFill>
-                  <a:srgbClr val="0F172A"/>
-                </a:solidFill>
-              </a:rPr>
-              <a:t>Days elapsed since last order relative to T_obs.</a:t>
-            </a:r>
-          </a:p>
-          <a:p>
-            <a:pPr>
-              <a:spcBef>
-                <a:spcPts val="300"/>
-              </a:spcBef>
-            </a:pPr>
-            <a:r>
-              <a:rPr b="1" sz="900">
-                <a:solidFill>
-                  <a:srgbClr val="1E1B4B"/>
-                </a:solidFill>
-              </a:rPr>
-              <a:t>• frequency_orders (INTEGER): </a:t>
-            </a:r>
-            <a:r>
-              <a:rPr sz="850">
-                <a:solidFill>
-                  <a:srgbClr val="0F172A"/>
-                </a:solidFill>
-              </a:rPr>
-              <a:t>Count of distinct checkout trips (unique orders).</a:t>
-            </a:r>
-          </a:p>
-          <a:p>
-            <a:pPr>
-              <a:spcBef>
-                <a:spcPts val="300"/>
-              </a:spcBef>
-            </a:pPr>
-            <a:r>
-              <a:rPr b="1" sz="900">
-                <a:solidFill>
-                  <a:srgbClr val="1E1B4B"/>
-                </a:solidFill>
-              </a:rPr>
-              <a:t>• monetary_total (DECIMAL(12,2)): </a:t>
-            </a:r>
-            <a:r>
-              <a:rPr sz="850">
-                <a:solidFill>
-                  <a:srgbClr val="0F172A"/>
-                </a:solidFill>
-              </a:rPr>
-              <a:t>Cumulative net customer spend across all valid orders.</a:t>
-            </a:r>
-          </a:p>
-          <a:p>
-            <a:pPr>
-              <a:spcBef>
-                <a:spcPts val="300"/>
-              </a:spcBef>
-            </a:pPr>
-            <a:r>
-              <a:rPr b="1" sz="900">
-                <a:solidFill>
-                  <a:srgbClr val="1E1B4B"/>
-                </a:solidFill>
-              </a:rPr>
-              <a:t>• avg_order_value (DECIMAL(10,2)): </a:t>
-            </a:r>
-            <a:r>
-              <a:rPr sz="850">
-                <a:solidFill>
-                  <a:srgbClr val="0F172A"/>
-                </a:solidFill>
-              </a:rPr>
-              <a:t>Average Order Value: Monetary / Frequency.</a:t>
-            </a:r>
-          </a:p>
-          <a:p>
-            <a:pPr>
-              <a:spcBef>
-                <a:spcPts val="300"/>
-              </a:spcBef>
-            </a:pPr>
-            <a:r>
-              <a:rPr b="1" sz="900">
-                <a:solidFill>
-                  <a:srgbClr val="1E1B4B"/>
-                </a:solidFill>
-              </a:rPr>
-              <a:t>• r_score, f_score, m_score (SMALLINT): </a:t>
-            </a:r>
-            <a:r>
-              <a:rPr sz="850">
-                <a:solidFill>
-                  <a:srgbClr val="0F172A"/>
-                </a:solidFill>
-              </a:rPr>
-              <a:t>Deterministic 1 to 5 quantile rank scores (pd.qcut).</a:t>
-            </a:r>
-          </a:p>
-          <a:p>
-            <a:pPr>
-              <a:spcBef>
-                <a:spcPts val="300"/>
-              </a:spcBef>
-            </a:pPr>
-            <a:r>
-              <a:rPr b="1" sz="900">
-                <a:solidFill>
-                  <a:srgbClr val="1E1B4B"/>
-                </a:solidFill>
-              </a:rPr>
-              <a:t>• segment_tier (VARCHAR(40)): </a:t>
-            </a:r>
-            <a:r>
-              <a:rPr sz="850">
-                <a:solidFill>
-                  <a:srgbClr val="0F172A"/>
-                </a:solidFill>
-              </a:rPr>
-              <a:t>Mapped business cohort ('Champions', 'At Risk Whales').</a:t>
+              <a:rPr sz="850" b="1">
+                <a:solidFill>
+                  <a:srgbClr val="2563EB"/>
+                </a:solidFill>
+                <a:latin typeface="Courier New"/>
+              </a:rPr>
+              <a:t>$ source venv/bin/activate &amp;&amp; pip install -r requirements.txt</a:t>
             </a:r>
           </a:p>
         </p:txBody>
@@ -7368,8 +6905,8 @@
         </p:nvSpPr>
         <p:spPr>
           <a:xfrm>
-            <a:off x="6492240" y="1371600"/>
-            <a:ext cx="4967935" cy="4754880"/>
+            <a:off x="731520" y="2322576"/>
+            <a:ext cx="10728655" cy="841248"/>
           </a:xfrm>
           <a:prstGeom prst="roundRect">
             <a:avLst/>
@@ -7413,8 +6950,8 @@
         </p:nvSpPr>
         <p:spPr>
           <a:xfrm>
-            <a:off x="6675120" y="1508760"/>
-            <a:ext cx="4572000" cy="4480560"/>
+            <a:off x="914400" y="2377440"/>
+            <a:ext cx="10362895" cy="731520"/>
           </a:xfrm>
           <a:prstGeom prst="rect">
             <a:avLst/>
@@ -7427,15 +6964,21 @@
           </a:bodyPr>
           <a:lstStyle/>
           <a:p>
-            <a:pPr>
-              <a:defRPr sz="1300" b="1">
+            <a:r>
+              <a:rPr b="1" sz="1050">
                 <a:solidFill>
                   <a:srgbClr val="7A003C"/>
                 </a:solidFill>
-              </a:defRPr>
-            </a:pPr>
-            <a:r>
-              <a:t>Table 3.4 &amp; 3.5: DIM_PRODUCTS &amp; DIM_DATE</a:t>
+              </a:rPr>
+              <a:t>Step 2: Synthetic Event Generation &amp; Ingestion  </a:t>
+            </a:r>
+            <a:r>
+              <a:rPr sz="950">
+                <a:solidFill>
+                  <a:srgbClr val="0F172A"/>
+                </a:solidFill>
+              </a:rPr>
+              <a:t>• Generates 15,000+ realistic transaction rows with Pareto spend distributions, cancellations, and guest sessions.</a:t>
             </a:r>
           </a:p>
           <a:p>
@@ -7445,20 +6988,99 @@
               </a:spcBef>
             </a:pPr>
             <a:r>
-              <a:rPr b="1" sz="900">
-                <a:solidFill>
-                  <a:srgbClr val="1E1B4B"/>
-                </a:solidFill>
-              </a:rPr>
-              <a:t>DIM_PRODUCTS Catalog Mart: </a:t>
-            </a:r>
-            <a:r>
-              <a:rPr sz="850">
+              <a:rPr sz="850" b="1">
+                <a:solidFill>
+                  <a:srgbClr val="2563EB"/>
+                </a:solidFill>
+                <a:latin typeface="Courier New"/>
+              </a:rPr>
+              <a:t>$ python generate_dataset.py</a:t>
+            </a:r>
+          </a:p>
+        </p:txBody>
+      </p:sp>
+      <p:sp>
+        <p:nvSpPr>
+          <p:cNvPr id="12" name="Rounded Rectangle 11"/>
+          <p:cNvSpPr/>
+          <p:nvPr/>
+        </p:nvSpPr>
+        <p:spPr>
+          <a:xfrm>
+            <a:off x="731520" y="3273552"/>
+            <a:ext cx="10728655" cy="841248"/>
+          </a:xfrm>
+          <a:prstGeom prst="roundRect">
+            <a:avLst/>
+          </a:prstGeom>
+          <a:solidFill>
+            <a:srgbClr val="F8FAFC"/>
+          </a:solidFill>
+          <a:ln w="12700">
+            <a:solidFill>
+              <a:srgbClr val="E2E8F0"/>
+            </a:solidFill>
+          </a:ln>
+        </p:spPr>
+        <p:style>
+          <a:lnRef idx="1">
+            <a:schemeClr val="accent1"/>
+          </a:lnRef>
+          <a:fillRef idx="3">
+            <a:schemeClr val="accent1"/>
+          </a:fillRef>
+          <a:effectRef idx="2">
+            <a:schemeClr val="accent1"/>
+          </a:effectRef>
+          <a:fontRef idx="minor">
+            <a:schemeClr val="lt1"/>
+          </a:fontRef>
+        </p:style>
+        <p:txBody>
+          <a:bodyPr rtlCol="0" anchor="ctr"/>
+          <a:lstStyle/>
+          <a:p>
+            <a:pPr algn="ctr"/>
+          </a:p>
+        </p:txBody>
+      </p:sp>
+      <p:sp>
+        <p:nvSpPr>
+          <p:cNvPr id="13" name="TextBox 12"/>
+          <p:cNvSpPr txBox="1"/>
+          <p:nvPr/>
+        </p:nvSpPr>
+        <p:spPr>
+          <a:xfrm>
+            <a:off x="914400" y="3328416"/>
+            <a:ext cx="10362895" cy="731520"/>
+          </a:xfrm>
+          <a:prstGeom prst="rect">
+            <a:avLst/>
+          </a:prstGeom>
+          <a:noFill/>
+        </p:spPr>
+        <p:txBody>
+          <a:bodyPr wrap="square">
+            <a:spAutoFit/>
+          </a:bodyPr>
+          <a:lstStyle/>
+          <a:p>
+            <a:r>
+              <a:rPr b="1" sz="1050">
+                <a:solidFill>
+                  <a:srgbClr val="7A003C"/>
+                </a:solidFill>
+              </a:rPr>
+              <a:t>Step 3: End-to-End Pipeline &amp; Star-Schema Build  </a:t>
+            </a:r>
+            <a:r>
+              <a:rPr sz="950">
                 <a:solidFill>
                   <a:srgbClr val="0F172A"/>
                 </a:solidFill>
               </a:rPr>
-              <a:t/>
+              <a:t>• Executes data refinery, vectorized RFM feature extraction, K-Means clustering, and star-schema CSV mart exports.</a:t>
             </a:r>
           </a:p>
           <a:p>
@@ -7468,20 +7090,99 @@
               </a:spcBef>
             </a:pPr>
             <a:r>
-              <a:rPr b="1" sz="900">
-                <a:solidFill>
-                  <a:srgbClr val="1E1B4B"/>
-                </a:solidFill>
-              </a:rPr>
-              <a:t>  • product_key (BIGINT, PK): </a:t>
-            </a:r>
-            <a:r>
-              <a:rPr sz="850">
+              <a:rPr sz="850" b="1">
+                <a:solidFill>
+                  <a:srgbClr val="2563EB"/>
+                </a:solidFill>
+                <a:latin typeface="Courier New"/>
+              </a:rPr>
+              <a:t>$ python main.py</a:t>
+            </a:r>
+          </a:p>
+        </p:txBody>
+      </p:sp>
+      <p:sp>
+        <p:nvSpPr>
+          <p:cNvPr id="14" name="Rounded Rectangle 13"/>
+          <p:cNvSpPr/>
+          <p:nvPr/>
+        </p:nvSpPr>
+        <p:spPr>
+          <a:xfrm>
+            <a:off x="731520" y="4224528"/>
+            <a:ext cx="10728655" cy="841248"/>
+          </a:xfrm>
+          <a:prstGeom prst="roundRect">
+            <a:avLst/>
+          </a:prstGeom>
+          <a:solidFill>
+            <a:srgbClr val="F8FAFC"/>
+          </a:solidFill>
+          <a:ln w="12700">
+            <a:solidFill>
+              <a:srgbClr val="E2E8F0"/>
+            </a:solidFill>
+          </a:ln>
+        </p:spPr>
+        <p:style>
+          <a:lnRef idx="1">
+            <a:schemeClr val="accent1"/>
+          </a:lnRef>
+          <a:fillRef idx="3">
+            <a:schemeClr val="accent1"/>
+          </a:fillRef>
+          <a:effectRef idx="2">
+            <a:schemeClr val="accent1"/>
+          </a:effectRef>
+          <a:fontRef idx="minor">
+            <a:schemeClr val="lt1"/>
+          </a:fontRef>
+        </p:style>
+        <p:txBody>
+          <a:bodyPr rtlCol="0" anchor="ctr"/>
+          <a:lstStyle/>
+          <a:p>
+            <a:pPr algn="ctr"/>
+          </a:p>
+        </p:txBody>
+      </p:sp>
+      <p:sp>
+        <p:nvSpPr>
+          <p:cNvPr id="15" name="TextBox 14"/>
+          <p:cNvSpPr txBox="1"/>
+          <p:nvPr/>
+        </p:nvSpPr>
+        <p:spPr>
+          <a:xfrm>
+            <a:off x="914400" y="4279392"/>
+            <a:ext cx="10362895" cy="731520"/>
+          </a:xfrm>
+          <a:prstGeom prst="rect">
+            <a:avLst/>
+          </a:prstGeom>
+          <a:noFill/>
+        </p:spPr>
+        <p:txBody>
+          <a:bodyPr wrap="square">
+            <a:spAutoFit/>
+          </a:bodyPr>
+          <a:lstStyle/>
+          <a:p>
+            <a:r>
+              <a:rPr b="1" sz="1050">
+                <a:solidFill>
+                  <a:srgbClr val="7A003C"/>
+                </a:solidFill>
+              </a:rPr>
+              <a:t>Step 4: Automated Testing &amp; Quality Assurance  </a:t>
+            </a:r>
+            <a:r>
+              <a:rPr sz="950">
                 <a:solidFill>
                   <a:srgbClr val="0F172A"/>
                 </a:solidFill>
               </a:rPr>
-              <a:t>Surrogate primary key for product catalog.</a:t>
+              <a:t>• Executes unit and integration test suite validating schema typing, Tukey IQR fences, and cluster bounds.</a:t>
             </a:r>
           </a:p>
           <a:p>
@@ -7491,20 +7192,99 @@
               </a:spcBef>
             </a:pPr>
             <a:r>
-              <a:rPr b="1" sz="900">
-                <a:solidFill>
-                  <a:srgbClr val="1E1B4B"/>
-                </a:solidFill>
-              </a:rPr>
-              <a:t>  • stock_code (VARCHAR(20)): </a:t>
-            </a:r>
-            <a:r>
-              <a:rPr sz="850">
+              <a:rPr sz="850" b="1">
+                <a:solidFill>
+                  <a:srgbClr val="2563EB"/>
+                </a:solidFill>
+                <a:latin typeface="Courier New"/>
+              </a:rPr>
+              <a:t>$ pytest tests/ -v</a:t>
+            </a:r>
+          </a:p>
+        </p:txBody>
+      </p:sp>
+      <p:sp>
+        <p:nvSpPr>
+          <p:cNvPr id="16" name="Rounded Rectangle 15"/>
+          <p:cNvSpPr/>
+          <p:nvPr/>
+        </p:nvSpPr>
+        <p:spPr>
+          <a:xfrm>
+            <a:off x="731520" y="5175504"/>
+            <a:ext cx="10728655" cy="841248"/>
+          </a:xfrm>
+          <a:prstGeom prst="roundRect">
+            <a:avLst/>
+          </a:prstGeom>
+          <a:solidFill>
+            <a:srgbClr val="F8FAFC"/>
+          </a:solidFill>
+          <a:ln w="12700">
+            <a:solidFill>
+              <a:srgbClr val="E2E8F0"/>
+            </a:solidFill>
+          </a:ln>
+        </p:spPr>
+        <p:style>
+          <a:lnRef idx="1">
+            <a:schemeClr val="accent1"/>
+          </a:lnRef>
+          <a:fillRef idx="3">
+            <a:schemeClr val="accent1"/>
+          </a:fillRef>
+          <a:effectRef idx="2">
+            <a:schemeClr val="accent1"/>
+          </a:effectRef>
+          <a:fontRef idx="minor">
+            <a:schemeClr val="lt1"/>
+          </a:fontRef>
+        </p:style>
+        <p:txBody>
+          <a:bodyPr rtlCol="0" anchor="ctr"/>
+          <a:lstStyle/>
+          <a:p>
+            <a:pPr algn="ctr"/>
+          </a:p>
+        </p:txBody>
+      </p:sp>
+      <p:sp>
+        <p:nvSpPr>
+          <p:cNvPr id="17" name="TextBox 16"/>
+          <p:cNvSpPr txBox="1"/>
+          <p:nvPr/>
+        </p:nvSpPr>
+        <p:spPr>
+          <a:xfrm>
+            <a:off x="914400" y="5230368"/>
+            <a:ext cx="10362895" cy="731520"/>
+          </a:xfrm>
+          <a:prstGeom prst="rect">
+            <a:avLst/>
+          </a:prstGeom>
+          <a:noFill/>
+        </p:spPr>
+        <p:txBody>
+          <a:bodyPr wrap="square">
+            <a:spAutoFit/>
+          </a:bodyPr>
+          <a:lstStyle/>
+          <a:p>
+            <a:r>
+              <a:rPr b="1" sz="1050">
+                <a:solidFill>
+                  <a:srgbClr val="7A003C"/>
+                </a:solidFill>
+              </a:rPr>
+              <a:t>Step 5: Executive Dashboard Launch &amp; Hosting  </a:t>
+            </a:r>
+            <a:r>
+              <a:rPr sz="950">
                 <a:solidFill>
                   <a:srgbClr val="0F172A"/>
                 </a:solidFill>
               </a:rPr>
-              <a:t>Unique SKU inventory identifier.</a:t>
+              <a:t>• Launches client-side executive dashboard on port 8000, serving KPI scorecards and interactive scatterplots.</a:t>
             </a:r>
           </a:p>
           <a:p>
@@ -7514,158 +7294,13 @@
               </a:spcBef>
             </a:pPr>
             <a:r>
-              <a:rPr b="1" sz="900">
-                <a:solidFill>
-                  <a:srgbClr val="1E1B4B"/>
-                </a:solidFill>
-              </a:rPr>
-              <a:t>  • description (VARCHAR(255)): </a:t>
-            </a:r>
-            <a:r>
-              <a:rPr sz="850">
-                <a:solidFill>
-                  <a:srgbClr val="0F172A"/>
-                </a:solidFill>
-              </a:rPr>
-              <a:t>Cleaned, sanitized item description text.</a:t>
-            </a:r>
-          </a:p>
-          <a:p>
-            <a:pPr>
-              <a:spcBef>
-                <a:spcPts val="200"/>
-              </a:spcBef>
-            </a:pPr>
-            <a:r>
-              <a:rPr b="1" sz="900">
-                <a:solidFill>
-                  <a:srgbClr val="1E1B4B"/>
-                </a:solidFill>
-              </a:rPr>
-              <a:t>  • unit_price_ref (DECIMAL): </a:t>
-            </a:r>
-            <a:r>
-              <a:rPr sz="850">
-                <a:solidFill>
-                  <a:srgbClr val="0F172A"/>
-                </a:solidFill>
-              </a:rPr>
-              <a:t>Baseline catalog reference price.</a:t>
-            </a:r>
-          </a:p>
-          <a:p>
-            <a:pPr>
-              <a:spcBef>
-                <a:spcPts val="200"/>
-              </a:spcBef>
-            </a:pPr>
-            <a:r>
-              <a:rPr b="1" sz="900">
-                <a:solidFill>
-                  <a:srgbClr val="1E1B4B"/>
-                </a:solidFill>
-              </a:rPr>
-              <a:t>DIM_DATE Temporal Mart: </a:t>
-            </a:r>
-            <a:r>
-              <a:rPr sz="850">
-                <a:solidFill>
-                  <a:srgbClr val="0F172A"/>
-                </a:solidFill>
-              </a:rPr>
-              <a:t/>
-            </a:r>
-          </a:p>
-          <a:p>
-            <a:pPr>
-              <a:spcBef>
-                <a:spcPts val="200"/>
-              </a:spcBef>
-            </a:pPr>
-            <a:r>
-              <a:rPr b="1" sz="900">
-                <a:solidFill>
-                  <a:srgbClr val="1E1B4B"/>
-                </a:solidFill>
-              </a:rPr>
-              <a:t>  • date_key (INTEGER, PK): </a:t>
-            </a:r>
-            <a:r>
-              <a:rPr sz="850">
-                <a:solidFill>
-                  <a:srgbClr val="0F172A"/>
-                </a:solidFill>
-              </a:rPr>
-              <a:t>YYYYMMDD formatted integer key (e.g. 20261013).</a:t>
-            </a:r>
-          </a:p>
-          <a:p>
-            <a:pPr>
-              <a:spcBef>
-                <a:spcPts val="200"/>
-              </a:spcBef>
-            </a:pPr>
-            <a:r>
-              <a:rPr b="1" sz="900">
-                <a:solidFill>
-                  <a:srgbClr val="1E1B4B"/>
-                </a:solidFill>
-              </a:rPr>
-              <a:t>  • full_date (DATE): </a:t>
-            </a:r>
-            <a:r>
-              <a:rPr sz="850">
-                <a:solidFill>
-                  <a:srgbClr val="0F172A"/>
-                </a:solidFill>
-              </a:rPr>
-              <a:t>Standard ISO-8601 calendar date.</a:t>
-            </a:r>
-          </a:p>
-          <a:p>
-            <a:pPr>
-              <a:spcBef>
-                <a:spcPts val="200"/>
-              </a:spcBef>
-            </a:pPr>
-            <a:r>
-              <a:rPr b="1" sz="900">
-                <a:solidFill>
-                  <a:srgbClr val="1E1B4B"/>
-                </a:solidFill>
-              </a:rPr>
-              <a:t>  • day_of_week, month, quarter: </a:t>
-            </a:r>
-            <a:r>
-              <a:rPr sz="850">
-                <a:solidFill>
-                  <a:srgbClr val="0F172A"/>
-                </a:solidFill>
-              </a:rPr>
-              <a:t>Calendar attributes for cohort time-series.</a:t>
-            </a:r>
-          </a:p>
-          <a:p>
-            <a:pPr>
-              <a:spcBef>
-                <a:spcPts val="200"/>
-              </a:spcBef>
-            </a:pPr>
-            <a:r>
-              <a:rPr b="1" sz="900">
-                <a:solidFill>
-                  <a:srgbClr val="1E1B4B"/>
-                </a:solidFill>
-              </a:rPr>
-              <a:t>  • is_weekend (BOOLEAN): </a:t>
-            </a:r>
-            <a:r>
-              <a:rPr sz="850">
-                <a:solidFill>
-                  <a:srgbClr val="0F172A"/>
-                </a:solidFill>
-              </a:rPr>
-              <a:t>Flag isolating weekend purchasing behavioral shifts.</a:t>
+              <a:rPr sz="850" b="1">
+                <a:solidFill>
+                  <a:srgbClr val="2563EB"/>
+                </a:solidFill>
+                <a:latin typeface="Courier New"/>
+              </a:rPr>
+              <a:t>$ python -m http.server 8000 --directory dashboard/</a:t>
             </a:r>
           </a:p>
         </p:txBody>
@@ -7764,7 +7399,7 @@
               </a:defRPr>
             </a:pPr>
             <a:r>
-              <a:t>SECTION 4.1  •  IMPLEMENTATION</a:t>
+              <a:t>SECTION 4.3  •  DASHBOARD NAVIGATION</a:t>
             </a:r>
           </a:p>
         </p:txBody>
@@ -7800,7 +7435,7 @@
               </a:defRPr>
             </a:pPr>
             <a:r>
-              <a:t>Screen Layouts: Executive BI Dashboard Architecture</a:t>
+              <a:t>Interactive Dashboard Navigation &amp; Visual Analytics</a:t>
             </a:r>
           </a:p>
         </p:txBody>
@@ -7917,7 +7552,7 @@
               </a:defRPr>
             </a:pPr>
             <a:r>
-              <a:t>B.Sc. in Artificial Intelligence &amp; Data Science (Sem V)  •  Institute of Advanced Research  •  Second Progress Work (13/10/2026)</a:t>
+              <a:t>B.Sc. in Artificial Intelligence &amp; Data Science (Sem V)  •  Institute of Advanced Research  •  Third Progress Work (27/10/2026)</a:t>
             </a:r>
           </a:p>
         </p:txBody>
@@ -7931,7 +7566,7 @@
         <p:spPr>
           <a:xfrm>
             <a:off x="731520" y="1371600"/>
-            <a:ext cx="6217920" cy="4754880"/>
+            <a:ext cx="5120640" cy="4754880"/>
           </a:xfrm>
           <a:prstGeom prst="roundRect">
             <a:avLst/>
@@ -7969,7 +7604,7 @@
       </p:sp>
       <p:pic>
         <p:nvPicPr>
-          <p:cNvPr id="9" name="Picture 8" descr="fig_screen_layouts.png"/>
+          <p:cNvPr id="9" name="Picture 8" descr="fig_revenue_share.png"/>
           <p:cNvPicPr>
             <a:picLocks noChangeAspect="1"/>
           </p:cNvPicPr>
@@ -7983,8 +7618,8 @@
         </p:blipFill>
         <p:spPr>
           <a:xfrm>
-            <a:off x="868680" y="1554480"/>
-            <a:ext cx="5943600" cy="3962400"/>
+            <a:off x="914400" y="1554480"/>
+            <a:ext cx="4754880" cy="2377440"/>
           </a:xfrm>
           <a:prstGeom prst="rect">
             <a:avLst/>
@@ -8000,7 +7635,7 @@
         <p:spPr>
           <a:xfrm>
             <a:off x="731520" y="5715000"/>
-            <a:ext cx="6217920" cy="320040"/>
+            <a:ext cx="5120640" cy="320040"/>
           </a:xfrm>
           <a:prstGeom prst="rect">
             <a:avLst/>
@@ -8014,14 +7649,14 @@
           <a:lstStyle/>
           <a:p>
             <a:pPr algn="ctr">
-              <a:defRPr sz="950" b="1">
+              <a:defRPr sz="900" b="1">
                 <a:solidFill>
                   <a:srgbClr val="475569"/>
                 </a:solidFill>
               </a:defRPr>
             </a:pPr>
             <a:r>
-              <a:t>Figure 4.1: Implementation Screen Layouts (4 Synchronized Views)</a:t>
+              <a:t>Figure 4.3: Segment Revenue Share Donut (72.5% Champions)</a:t>
             </a:r>
           </a:p>
         </p:txBody>
@@ -8034,8 +7669,8 @@
         </p:nvSpPr>
         <p:spPr>
           <a:xfrm>
-            <a:off x="7223760" y="1371600"/>
-            <a:ext cx="4236415" cy="4754880"/>
+            <a:off x="6126480" y="1371600"/>
+            <a:ext cx="5333695" cy="4754880"/>
           </a:xfrm>
           <a:prstGeom prst="roundRect">
             <a:avLst/>
@@ -8071,16 +7706,40 @@
           </a:p>
         </p:txBody>
       </p:sp>
-      <p:sp>
-        <p:nvSpPr>
-          <p:cNvPr id="12" name="TextBox 11"/>
+      <p:pic>
+        <p:nvPicPr>
+          <p:cNvPr id="12" name="Picture 11" descr="fig_spatial_scatter.png"/>
+          <p:cNvPicPr>
+            <a:picLocks noChangeAspect="1"/>
+          </p:cNvPicPr>
+          <p:nvPr/>
+        </p:nvPicPr>
+        <p:blipFill>
+          <a:blip r:embed="rId3"/>
+          <a:stretch>
+            <a:fillRect/>
+          </a:stretch>
+        </p:blipFill>
+        <p:spPr>
+          <a:xfrm>
+            <a:off x="6309360" y="1554480"/>
+            <a:ext cx="4937760" cy="2715768"/>
+          </a:xfrm>
+          <a:prstGeom prst="rect">
+            <a:avLst/>
+          </a:prstGeom>
+        </p:spPr>
+      </p:pic>
+      <p:sp>
+        <p:nvSpPr>
+          <p:cNvPr id="13" name="TextBox 12"/>
           <p:cNvSpPr txBox="1"/>
           <p:nvPr/>
         </p:nvSpPr>
         <p:spPr>
           <a:xfrm>
-            <a:off x="7406640" y="1508760"/>
-            <a:ext cx="3840480" cy="4480560"/>
+            <a:off x="6126480" y="5715000"/>
+            <a:ext cx="5333695" cy="320040"/>
           </a:xfrm>
           <a:prstGeom prst="rect">
             <a:avLst/>
@@ -8088,112 +7747,20 @@
           <a:noFill/>
         </p:spPr>
         <p:txBody>
-          <a:bodyPr wrap="square">
+          <a:bodyPr wrap="none">
             <a:spAutoFit/>
           </a:bodyPr>
           <a:lstStyle/>
           <a:p>
-            <a:pPr>
-              <a:defRPr sz="1350" b="1">
-                <a:solidFill>
-                  <a:srgbClr val="7A003C"/>
+            <a:pPr algn="ctr">
+              <a:defRPr sz="900" b="1">
+                <a:solidFill>
+                  <a:srgbClr val="475569"/>
                 </a:solidFill>
               </a:defRPr>
             </a:pPr>
             <a:r>
-              <a:t>4 Synchronized BI Dashboard Views</a:t>
-            </a:r>
-          </a:p>
-          <a:p>
-            <a:pPr>
-              <a:spcBef>
-                <a:spcPts val="500"/>
-              </a:spcBef>
-            </a:pPr>
-            <a:r>
-              <a:rPr b="1" sz="950">
-                <a:solidFill>
-                  <a:srgbClr val="1E1B4B"/>
-                </a:solidFill>
-              </a:rPr>
-              <a:t>• Screen 1: Executive KPI Scorecards: </a:t>
-            </a:r>
-            <a:r>
-              <a:rPr sz="900">
-                <a:solidFill>
-                  <a:srgbClr val="0F172A"/>
-                </a:solidFill>
-              </a:rPr>
-              <a:t>High-level summary displaying gross spend ($65,049.20), active customer accounts (256), average order value ($254.10), and at-risk revenue share (7.3%).</a:t>
-            </a:r>
-          </a:p>
-          <a:p>
-            <a:pPr>
-              <a:spcBef>
-                <a:spcPts val="500"/>
-              </a:spcBef>
-            </a:pPr>
-            <a:r>
-              <a:rPr b="1" sz="950">
-                <a:solidFill>
-                  <a:srgbClr val="1E1B4B"/>
-                </a:solidFill>
-              </a:rPr>
-              <a:t>• Screen 2: RFM Behavioral Scatterplot: </a:t>
-            </a:r>
-            <a:r>
-              <a:rPr sz="900">
-                <a:solidFill>
-                  <a:srgbClr val="0F172A"/>
-                </a:solidFill>
-              </a:rPr>
-              <a:t>Interactive 2D/3D canvas mapping Recency against Monetary Spend with bubble radii scaled to Frequency.</a:t>
-            </a:r>
-          </a:p>
-          <a:p>
-            <a:pPr>
-              <a:spcBef>
-                <a:spcPts val="500"/>
-              </a:spcBef>
-            </a:pPr>
-            <a:r>
-              <a:rPr b="1" sz="950">
-                <a:solidFill>
-                  <a:srgbClr val="1E1B4B"/>
-                </a:solidFill>
-              </a:rPr>
-              <a:t>• Screen 3: Customer Activation Ledger: </a:t>
-            </a:r>
-            <a:r>
-              <a:rPr sz="900">
-                <a:solidFill>
-                  <a:srgbClr val="0F172A"/>
-                </a:solidFill>
-              </a:rPr>
-              <a:t>Filterable data table with instant search, pagination, and targeted CSV audience export controls.</a:t>
-            </a:r>
-          </a:p>
-          <a:p>
-            <a:pPr>
-              <a:spcBef>
-                <a:spcPts val="500"/>
-              </a:spcBef>
-            </a:pPr>
-            <a:r>
-              <a:rPr b="1" sz="950">
-                <a:solidFill>
-                  <a:srgbClr val="1E1B4B"/>
-                </a:solidFill>
-              </a:rPr>
-              <a:t>• Screen 4: Reverse Logistics Audit Ledger: </a:t>
-            </a:r>
-            <a:r>
-              <a:rPr sz="900">
-                <a:solidFill>
-                  <a:srgbClr val="0F172A"/>
-                </a:solidFill>
-              </a:rPr>
-              <a:t>Isolated compliance table displaying quarantined cancellations and credit notes.</a:t>
+              <a:t>Figure 4.4: Multi-Dimensional Spatial RFM Bubble Scatterplot</a:t>
             </a:r>
           </a:p>
         </p:txBody>
@@ -8292,7 +7859,7 @@
               </a:defRPr>
             </a:pPr>
             <a:r>
-              <a:t>SECTION 4.1  •  DATA INTEGRITY</a:t>
+              <a:t>CHAPTER 5  •  CONCLUSION &amp; ROADMAPS</a:t>
             </a:r>
           </a:p>
         </p:txBody>
@@ -8328,7 +7895,7 @@
               </a:defRPr>
             </a:pPr>
             <a:r>
-              <a:t>Implementation: Operational Input Validations (VAL-01 to VAL-04)</a:t>
+              <a:t>Importance of Worked-Out Tasks &amp; Future Enhancements</a:t>
             </a:r>
           </a:p>
         </p:txBody>
@@ -8445,7 +8012,7 @@
               </a:defRPr>
             </a:pPr>
             <a:r>
-              <a:t>B.Sc. in Artificial Intelligence &amp; Data Science (Sem V)  •  Institute of Advanced Research  •  Second Progress Work (13/10/2026)</a:t>
+              <a:t>B.Sc. in Artificial Intelligence &amp; Data Science (Sem V)  •  Institute of Advanced Research  •  Third Progress Work (27/10/2026)</a:t>
             </a:r>
           </a:p>
         </p:txBody>
@@ -8459,292 +8026,7 @@
         <p:spPr>
           <a:xfrm>
             <a:off x="731520" y="1371600"/>
-            <a:ext cx="10728655" cy="1051560"/>
-          </a:xfrm>
-          <a:prstGeom prst="roundRect">
-            <a:avLst/>
-          </a:prstGeom>
-          <a:solidFill>
-            <a:srgbClr val="FEF2F2"/>
-          </a:solidFill>
-          <a:ln w="12700">
-            <a:solidFill>
-              <a:srgbClr val="E2E8F0"/>
-            </a:solidFill>
-          </a:ln>
-        </p:spPr>
-        <p:style>
-          <a:lnRef idx="1">
-            <a:schemeClr val="accent1"/>
-          </a:lnRef>
-          <a:fillRef idx="3">
-            <a:schemeClr val="accent1"/>
-          </a:fillRef>
-          <a:effectRef idx="2">
-            <a:schemeClr val="accent1"/>
-          </a:effectRef>
-          <a:fontRef idx="minor">
-            <a:schemeClr val="lt1"/>
-          </a:fontRef>
-        </p:style>
-        <p:txBody>
-          <a:bodyPr rtlCol="0" anchor="ctr"/>
-          <a:lstStyle/>
-          <a:p>
-            <a:pPr algn="ctr"/>
-          </a:p>
-        </p:txBody>
-      </p:sp>
-      <p:sp>
-        <p:nvSpPr>
-          <p:cNvPr id="9" name="TextBox 8"/>
-          <p:cNvSpPr txBox="1"/>
-          <p:nvPr/>
-        </p:nvSpPr>
-        <p:spPr>
-          <a:xfrm>
-            <a:off x="914400" y="1444752"/>
-            <a:ext cx="10362895" cy="905256"/>
-          </a:xfrm>
-          <a:prstGeom prst="rect">
-            <a:avLst/>
-          </a:prstGeom>
-          <a:noFill/>
-        </p:spPr>
-        <p:txBody>
-          <a:bodyPr wrap="square">
-            <a:spAutoFit/>
-          </a:bodyPr>
-          <a:lstStyle/>
-          <a:p>
-            <a:r>
-              <a:rPr sz="1100" b="1">
-                <a:solidFill>
-                  <a:srgbClr val="7A003C"/>
-                </a:solidFill>
-                <a:latin typeface="Arial"/>
-              </a:rPr>
-              <a:t>VAL-01: Scorecard Numerical Integrity Validation</a:t>
-            </a:r>
-          </a:p>
-          <a:p>
-            <a:pPr>
-              <a:spcBef>
-                <a:spcPts val="300"/>
-              </a:spcBef>
-            </a:pPr>
-            <a:r>
-              <a:rPr sz="950">
-                <a:solidFill>
-                  <a:srgbClr val="0F172A"/>
-                </a:solidFill>
-                <a:latin typeface="Arial"/>
-              </a:rPr>
-              <a:t>Enforces non-negative monetary constraints (Spend &gt;= 0.00). Active customer counts strictly verify unique authenticated non-null CustomerIDs. At-risk percentages are evaluated as: (Sum(Spend_AtRisk) / Total_Spend) * 100.</a:t>
-            </a:r>
-          </a:p>
-        </p:txBody>
-      </p:sp>
-      <p:sp>
-        <p:nvSpPr>
-          <p:cNvPr id="10" name="Rounded Rectangle 9"/>
-          <p:cNvSpPr/>
-          <p:nvPr/>
-        </p:nvSpPr>
-        <p:spPr>
-          <a:xfrm>
-            <a:off x="731520" y="2587752"/>
-            <a:ext cx="10728655" cy="1051560"/>
-          </a:xfrm>
-          <a:prstGeom prst="roundRect">
-            <a:avLst/>
-          </a:prstGeom>
-          <a:solidFill>
-            <a:srgbClr val="EFF6FF"/>
-          </a:solidFill>
-          <a:ln w="12700">
-            <a:solidFill>
-              <a:srgbClr val="E2E8F0"/>
-            </a:solidFill>
-          </a:ln>
-        </p:spPr>
-        <p:style>
-          <a:lnRef idx="1">
-            <a:schemeClr val="accent1"/>
-          </a:lnRef>
-          <a:fillRef idx="3">
-            <a:schemeClr val="accent1"/>
-          </a:fillRef>
-          <a:effectRef idx="2">
-            <a:schemeClr val="accent1"/>
-          </a:effectRef>
-          <a:fontRef idx="minor">
-            <a:schemeClr val="lt1"/>
-          </a:fontRef>
-        </p:style>
-        <p:txBody>
-          <a:bodyPr rtlCol="0" anchor="ctr"/>
-          <a:lstStyle/>
-          <a:p>
-            <a:pPr algn="ctr"/>
-          </a:p>
-        </p:txBody>
-      </p:sp>
-      <p:sp>
-        <p:nvSpPr>
-          <p:cNvPr id="11" name="TextBox 10"/>
-          <p:cNvSpPr txBox="1"/>
-          <p:nvPr/>
-        </p:nvSpPr>
-        <p:spPr>
-          <a:xfrm>
-            <a:off x="914400" y="2660904"/>
-            <a:ext cx="10362895" cy="905256"/>
-          </a:xfrm>
-          <a:prstGeom prst="rect">
-            <a:avLst/>
-          </a:prstGeom>
-          <a:noFill/>
-        </p:spPr>
-        <p:txBody>
-          <a:bodyPr wrap="square">
-            <a:spAutoFit/>
-          </a:bodyPr>
-          <a:lstStyle/>
-          <a:p>
-            <a:r>
-              <a:rPr sz="1100" b="1">
-                <a:solidFill>
-                  <a:srgbClr val="2563EB"/>
-                </a:solidFill>
-                <a:latin typeface="Arial"/>
-              </a:rPr>
-              <a:t>VAL-02: Spatial Canvas Coordinate &amp; Boundary Constraints</a:t>
-            </a:r>
-          </a:p>
-          <a:p>
-            <a:pPr>
-              <a:spcBef>
-                <a:spcPts val="300"/>
-              </a:spcBef>
-            </a:pPr>
-            <a:r>
-              <a:rPr sz="950">
-                <a:solidFill>
-                  <a:srgbClr val="0F172A"/>
-                </a:solidFill>
-                <a:latin typeface="Arial"/>
-              </a:rPr>
-              <a:t>Interactive scatterplot coordinates enforce strict domain bounds: Recency in [1..365], Frequency in [1..50], Spend in [0..10,000]. Hover tooltips execute null-safety checks before canvas event firing.</a:t>
-            </a:r>
-          </a:p>
-        </p:txBody>
-      </p:sp>
-      <p:sp>
-        <p:nvSpPr>
-          <p:cNvPr id="12" name="Rounded Rectangle 11"/>
-          <p:cNvSpPr/>
-          <p:nvPr/>
-        </p:nvSpPr>
-        <p:spPr>
-          <a:xfrm>
-            <a:off x="731520" y="3803904"/>
-            <a:ext cx="10728655" cy="1051560"/>
-          </a:xfrm>
-          <a:prstGeom prst="roundRect">
-            <a:avLst/>
-          </a:prstGeom>
-          <a:solidFill>
-            <a:srgbClr val="ECFDF5"/>
-          </a:solidFill>
-          <a:ln w="12700">
-            <a:solidFill>
-              <a:srgbClr val="E2E8F0"/>
-            </a:solidFill>
-          </a:ln>
-        </p:spPr>
-        <p:style>
-          <a:lnRef idx="1">
-            <a:schemeClr val="accent1"/>
-          </a:lnRef>
-          <a:fillRef idx="3">
-            <a:schemeClr val="accent1"/>
-          </a:fillRef>
-          <a:effectRef idx="2">
-            <a:schemeClr val="accent1"/>
-          </a:effectRef>
-          <a:fontRef idx="minor">
-            <a:schemeClr val="lt1"/>
-          </a:fontRef>
-        </p:style>
-        <p:txBody>
-          <a:bodyPr rtlCol="0" anchor="ctr"/>
-          <a:lstStyle/>
-          <a:p>
-            <a:pPr algn="ctr"/>
-          </a:p>
-        </p:txBody>
-      </p:sp>
-      <p:sp>
-        <p:nvSpPr>
-          <p:cNvPr id="13" name="TextBox 12"/>
-          <p:cNvSpPr txBox="1"/>
-          <p:nvPr/>
-        </p:nvSpPr>
-        <p:spPr>
-          <a:xfrm>
-            <a:off x="914400" y="3877056"/>
-            <a:ext cx="10362895" cy="905256"/>
-          </a:xfrm>
-          <a:prstGeom prst="rect">
-            <a:avLst/>
-          </a:prstGeom>
-          <a:noFill/>
-        </p:spPr>
-        <p:txBody>
-          <a:bodyPr wrap="square">
-            <a:spAutoFit/>
-          </a:bodyPr>
-          <a:lstStyle/>
-          <a:p>
-            <a:r>
-              <a:rPr sz="1100" b="1">
-                <a:solidFill>
-                  <a:srgbClr val="10B981"/>
-                </a:solidFill>
-                <a:latin typeface="Arial"/>
-              </a:rPr>
-              <a:t>VAL-03: Search Query Sanitization &amp; Pagination Bounds</a:t>
-            </a:r>
-          </a:p>
-          <a:p>
-            <a:pPr>
-              <a:spcBef>
-                <a:spcPts val="300"/>
-              </a:spcBef>
-            </a:pPr>
-            <a:r>
-              <a:rPr sz="950">
-                <a:solidFill>
-                  <a:srgbClr val="0F172A"/>
-                </a:solidFill>
-                <a:latin typeface="Arial"/>
-              </a:rPr>
-              <a:t>Client-side search input is sanitized against cross-site scripting (XSS) and SQL injection. Table pagination enforces bounded integer intervals (1 &lt;= Page &lt;= MaxPage).</a:t>
-            </a:r>
-          </a:p>
-        </p:txBody>
-      </p:sp>
-      <p:sp>
-        <p:nvSpPr>
-          <p:cNvPr id="14" name="Rounded Rectangle 13"/>
-          <p:cNvSpPr/>
-          <p:nvPr/>
-        </p:nvSpPr>
-        <p:spPr>
-          <a:xfrm>
-            <a:off x="731520" y="5020056"/>
-            <a:ext cx="10728655" cy="1051560"/>
+            <a:ext cx="5212080" cy="4754880"/>
           </a:xfrm>
           <a:prstGeom prst="roundRect">
             <a:avLst/>
@@ -8782,14 +8064,14 @@
       </p:sp>
       <p:sp>
         <p:nvSpPr>
-          <p:cNvPr id="15" name="TextBox 14"/>
+          <p:cNvPr id="9" name="TextBox 8"/>
           <p:cNvSpPr txBox="1"/>
           <p:nvPr/>
         </p:nvSpPr>
         <p:spPr>
           <a:xfrm>
-            <a:off x="914400" y="5093208"/>
-            <a:ext cx="10362895" cy="905256"/>
+            <a:off x="914400" y="1508760"/>
+            <a:ext cx="4846320" cy="4480560"/>
           </a:xfrm>
           <a:prstGeom prst="rect">
             <a:avLst/>
@@ -8802,30 +8084,279 @@
           </a:bodyPr>
           <a:lstStyle/>
           <a:p>
-            <a:r>
-              <a:rPr sz="1100" b="1">
-                <a:solidFill>
-                  <a:srgbClr val="1E1B4B"/>
-                </a:solidFill>
-                <a:latin typeface="Arial"/>
-              </a:rPr>
-              <a:t>VAL-04: Reverse Logistics Quarantine Constraint</a:t>
+            <a:pPr>
+              <a:defRPr sz="1300" b="1">
+                <a:solidFill>
+                  <a:srgbClr val="7A003C"/>
+                </a:solidFill>
+              </a:defRPr>
+            </a:pPr>
+            <a:r>
+              <a:t>5.1 Importance of Worked-Out Tasks</a:t>
             </a:r>
           </a:p>
           <a:p>
             <a:pPr>
               <a:spcBef>
-                <a:spcPts val="300"/>
+                <a:spcPts val="600"/>
               </a:spcBef>
             </a:pPr>
             <a:r>
-              <a:rPr sz="950">
+              <a:rPr b="1" sz="950">
+                <a:solidFill>
+                  <a:srgbClr val="1E1B4B"/>
+                </a:solidFill>
+              </a:rPr>
+              <a:t>• Elimination of Analytical Distortion: </a:t>
+            </a:r>
+            <a:r>
+              <a:rPr sz="900">
                 <a:solidFill>
                   <a:srgbClr val="0F172A"/>
                 </a:solidFill>
-                <a:latin typeface="Arial"/>
-              </a:rPr>
-              <a:t>Cancellation transactions strictly enforce regex constraint (InvoiceNo.startswith('C')) and negative quantities (Quantity &lt; 0) before insertion into audit stores.</a:t>
+              </a:rPr>
+              <a:t>Isolating returns into fact_reversals_audit.csv and capping bulk outliers ensures RFM reflects true consumer buying behavior.</a:t>
+            </a:r>
+          </a:p>
+          <a:p>
+            <a:pPr>
+              <a:spcBef>
+                <a:spcPts val="600"/>
+              </a:spcBef>
+            </a:pPr>
+            <a:r>
+              <a:rPr b="1" sz="950">
+                <a:solidFill>
+                  <a:srgbClr val="1E1B4B"/>
+                </a:solidFill>
+              </a:rPr>
+              <a:t>• Commercial Margin Optimization: </a:t>
+            </a:r>
+            <a:r>
+              <a:rPr sz="900">
+                <a:solidFill>
+                  <a:srgbClr val="0F172A"/>
+                </a:solidFill>
+              </a:rPr>
+              <a:t>Replacing blanket discounts with 8 behavioral tiers protects gross profit margins and focuses spend on high-value retention.</a:t>
+            </a:r>
+          </a:p>
+          <a:p>
+            <a:pPr>
+              <a:spcBef>
+                <a:spcPts val="600"/>
+              </a:spcBef>
+            </a:pPr>
+            <a:r>
+              <a:rPr b="1" sz="950">
+                <a:solidFill>
+                  <a:srgbClr val="1E1B4B"/>
+                </a:solidFill>
+              </a:rPr>
+              <a:t>• Enterprise Dimensional Governance: </a:t>
+            </a:r>
+            <a:r>
+              <a:rPr sz="900">
+                <a:solidFill>
+                  <a:srgbClr val="0F172A"/>
+                </a:solidFill>
+              </a:rPr>
+              <a:t>Star-schema dimensional mart allows commercial teams to query multi-dimensional customer features using SQL, Tableau, and Power BI.</a:t>
+            </a:r>
+          </a:p>
+          <a:p>
+            <a:pPr>
+              <a:spcBef>
+                <a:spcPts val="600"/>
+              </a:spcBef>
+            </a:pPr>
+            <a:r>
+              <a:rPr b="1" sz="950">
+                <a:solidFill>
+                  <a:srgbClr val="1E1B4B"/>
+                </a:solidFill>
+              </a:rPr>
+              <a:t>• Operational Activation: </a:t>
+            </a:r>
+            <a:r>
+              <a:rPr sz="900">
+                <a:solidFill>
+                  <a:srgbClr val="0F172A"/>
+                </a:solidFill>
+              </a:rPr>
+              <a:t>Interactive scorecards and CSV activation lists bridge the gap between machine learning models and daily marketing campaigns.</a:t>
+            </a:r>
+          </a:p>
+        </p:txBody>
+      </p:sp>
+      <p:sp>
+        <p:nvSpPr>
+          <p:cNvPr id="10" name="Rounded Rectangle 9"/>
+          <p:cNvSpPr/>
+          <p:nvPr/>
+        </p:nvSpPr>
+        <p:spPr>
+          <a:xfrm>
+            <a:off x="6217920" y="1371600"/>
+            <a:ext cx="5242255" cy="4754880"/>
+          </a:xfrm>
+          <a:prstGeom prst="roundRect">
+            <a:avLst/>
+          </a:prstGeom>
+          <a:solidFill>
+            <a:srgbClr val="F8FAFC"/>
+          </a:solidFill>
+          <a:ln w="12700">
+            <a:solidFill>
+              <a:srgbClr val="E2E8F0"/>
+            </a:solidFill>
+          </a:ln>
+        </p:spPr>
+        <p:style>
+          <a:lnRef idx="1">
+            <a:schemeClr val="accent1"/>
+          </a:lnRef>
+          <a:fillRef idx="3">
+            <a:schemeClr val="accent1"/>
+          </a:fillRef>
+          <a:effectRef idx="2">
+            <a:schemeClr val="accent1"/>
+          </a:effectRef>
+          <a:fontRef idx="minor">
+            <a:schemeClr val="lt1"/>
+          </a:fontRef>
+        </p:style>
+        <p:txBody>
+          <a:bodyPr rtlCol="0" anchor="ctr"/>
+          <a:lstStyle/>
+          <a:p>
+            <a:pPr algn="ctr"/>
+          </a:p>
+        </p:txBody>
+      </p:sp>
+      <p:sp>
+        <p:nvSpPr>
+          <p:cNvPr id="11" name="TextBox 10"/>
+          <p:cNvSpPr txBox="1"/>
+          <p:nvPr/>
+        </p:nvSpPr>
+        <p:spPr>
+          <a:xfrm>
+            <a:off x="6400800" y="1508760"/>
+            <a:ext cx="4846320" cy="4480560"/>
+          </a:xfrm>
+          <a:prstGeom prst="rect">
+            <a:avLst/>
+          </a:prstGeom>
+          <a:noFill/>
+        </p:spPr>
+        <p:txBody>
+          <a:bodyPr wrap="square">
+            <a:spAutoFit/>
+          </a:bodyPr>
+          <a:lstStyle/>
+          <a:p>
+            <a:pPr>
+              <a:defRPr sz="1300" b="1">
+                <a:solidFill>
+                  <a:srgbClr val="7A003C"/>
+                </a:solidFill>
+              </a:defRPr>
+            </a:pPr>
+            <a:r>
+              <a:t>5.2 Further Enhancement in Future</a:t>
+            </a:r>
+          </a:p>
+          <a:p>
+            <a:pPr>
+              <a:spcBef>
+                <a:spcPts val="600"/>
+              </a:spcBef>
+            </a:pPr>
+            <a:r>
+              <a:rPr b="1" sz="950">
+                <a:solidFill>
+                  <a:srgbClr val="1E1B4B"/>
+                </a:solidFill>
+              </a:rPr>
+              <a:t>• Deep Learning CLV Forecasting: </a:t>
+            </a:r>
+            <a:r>
+              <a:rPr sz="900">
+                <a:solidFill>
+                  <a:srgbClr val="0F172A"/>
+                </a:solidFill>
+              </a:rPr>
+              <a:t>Implementing Recurrent Neural Networks (LSTM) and Transformers to predict customer lifetime value and churn probabilities.</a:t>
+            </a:r>
+          </a:p>
+          <a:p>
+            <a:pPr>
+              <a:spcBef>
+                <a:spcPts val="600"/>
+              </a:spcBef>
+            </a:pPr>
+            <a:r>
+              <a:rPr b="1" sz="950">
+                <a:solidFill>
+                  <a:srgbClr val="1E1B4B"/>
+                </a:solidFill>
+              </a:rPr>
+              <a:t>• Real-Time Streaming Ingestion: </a:t>
+            </a:r>
+            <a:r>
+              <a:rPr sz="900">
+                <a:solidFill>
+                  <a:srgbClr val="0F172A"/>
+                </a:solidFill>
+              </a:rPr>
+              <a:t>Migrating batch ingestion to Apache Kafka and Apache Spark Streaming for sub-second transaction processing.</a:t>
+            </a:r>
+          </a:p>
+          <a:p>
+            <a:pPr>
+              <a:spcBef>
+                <a:spcPts val="600"/>
+              </a:spcBef>
+            </a:pPr>
+            <a:r>
+              <a:rPr b="1" sz="950">
+                <a:solidFill>
+                  <a:srgbClr val="1E1B4B"/>
+                </a:solidFill>
+              </a:rPr>
+              <a:t>• Automated CRM Webhooks: </a:t>
+            </a:r>
+            <a:r>
+              <a:rPr sz="900">
+                <a:solidFill>
+                  <a:srgbClr val="0F172A"/>
+                </a:solidFill>
+              </a:rPr>
+              <a:t>Building RESTful webhooks to dispatch targeted cohorts automatically into HubSpot, Salesforce Marketing Cloud, and Klaviyo.</a:t>
+            </a:r>
+          </a:p>
+          <a:p>
+            <a:pPr>
+              <a:spcBef>
+                <a:spcPts val="600"/>
+              </a:spcBef>
+            </a:pPr>
+            <a:r>
+              <a:rPr b="1" sz="950">
+                <a:solidFill>
+                  <a:srgbClr val="1E1B4B"/>
+                </a:solidFill>
+              </a:rPr>
+              <a:t>• Multi-Touch Attribution: </a:t>
+            </a:r>
+            <a:r>
+              <a:rPr sz="900">
+                <a:solidFill>
+                  <a:srgbClr val="0F172A"/>
+                </a:solidFill>
+              </a:rPr>
+              <a:t>Incorporating Shapley Value and Markov Chain attribution models to quantify marketing touchpoint impact across channels.</a:t>
             </a:r>
           </a:p>
         </p:txBody>
@@ -8960,7 +8491,7 @@
               </a:defRPr>
             </a:pPr>
             <a:r>
-              <a:t>Project Evaluation Schedule &amp; Milestone Status (Mid-Term)</a:t>
+              <a:t>References &amp; Complete Project Progress Work Schedule</a:t>
             </a:r>
           </a:p>
         </p:txBody>
@@ -9077,7 +8608,7 @@
               </a:defRPr>
             </a:pPr>
             <a:r>
-              <a:t>B.Sc. in Artificial Intelligence &amp; Data Science (Sem V)  •  Institute of Advanced Research  •  Second Progress Work (13/10/2026)</a:t>
+              <a:t>B.Sc. in Artificial Intelligence &amp; Data Science (Sem V)  •  Institute of Advanced Research  •  Third Progress Work (27/10/2026)</a:t>
             </a:r>
           </a:p>
         </p:txBody>
@@ -9150,24 +8681,24 @@
           <a:lstStyle/>
           <a:p>
             <a:pPr>
-              <a:defRPr sz="1400" b="1">
+              <a:defRPr sz="1350" b="1">
                 <a:solidFill>
                   <a:srgbClr val="7A003C"/>
                 </a:solidFill>
               </a:defRPr>
             </a:pPr>
             <a:r>
-              <a:t>Table 4.1: Comprehensive Project Progress Work Schedule</a:t>
+              <a:t>Table 6.1: Complete Project Progress Work Evaluation Schedule</a:t>
             </a:r>
           </a:p>
           <a:p>
             <a:pPr>
               <a:spcBef>
-                <a:spcPts val="800"/>
+                <a:spcPts val="700"/>
               </a:spcBef>
             </a:pPr>
             <a:r>
-              <a:rPr b="1" sz="1100">
+              <a:rPr b="1" sz="1050">
                 <a:solidFill>
                   <a:srgbClr val="475569"/>
                 </a:solidFill>
@@ -9175,7 +8706,7 @@
               <a:t>• [24/09/2026]  First Progress Work Evaluation (10 Marks) — </a:t>
             </a:r>
             <a:r>
-              <a:rPr b="1" sz="1050">
+              <a:rPr b="1" sz="1000">
                 <a:solidFill>
                   <a:srgbClr val="475569"/>
                 </a:solidFill>
@@ -9184,7 +8715,7 @@
 </a:t>
             </a:r>
             <a:r>
-              <a:rPr sz="950">
+              <a:rPr sz="900">
                 <a:solidFill>
                   <a:srgbClr val="0F172A"/>
                 </a:solidFill>
@@ -9195,19 +8726,51 @@
           <a:p>
             <a:pPr>
               <a:spcBef>
-                <a:spcPts val="800"/>
+                <a:spcPts val="700"/>
               </a:spcBef>
             </a:pPr>
             <a:r>
-              <a:rPr b="1" sz="1100">
+              <a:rPr b="1" sz="1050">
+                <a:solidFill>
+                  <a:srgbClr val="475569"/>
+                </a:solidFill>
+              </a:rPr>
+              <a:t>• [13/10/2026]  Mid-Term Examination (Second Progress) (20 Marks) — </a:t>
+            </a:r>
+            <a:r>
+              <a:rPr b="1" sz="1000">
+                <a:solidFill>
+                  <a:srgbClr val="475569"/>
+                </a:solidFill>
+              </a:rPr>
+              <a:t>COMPLETED &amp; VERIFIED
+</a:t>
+            </a:r>
+            <a:r>
+              <a:rPr sz="900">
+                <a:solidFill>
+                  <a:srgbClr val="0F172A"/>
+                </a:solidFill>
+              </a:rPr>
+              <a:t>   Curriculum Scope: Sections 2.3, 2.4, 3.1, 4.1</a:t>
+            </a:r>
+          </a:p>
+          <a:p>
+            <a:pPr>
+              <a:spcBef>
+                <a:spcPts val="700"/>
+              </a:spcBef>
+            </a:pPr>
+            <a:r>
+              <a:rPr b="1" sz="1050">
                 <a:solidFill>
                   <a:srgbClr val="10B981"/>
                 </a:solidFill>
               </a:rPr>
-              <a:t>• [13/10/2026]  Mid-Term Examination (Second Progress) (20 Marks) — </a:t>
-            </a:r>
-            <a:r>
-              <a:rPr b="1" sz="1050">
+              <a:t>• [27/10/2026]  Third Progress Work Evaluation (10 Marks) — </a:t>
+            </a:r>
+            <a:r>
+              <a:rPr b="1" sz="1000">
                 <a:solidFill>
                   <a:srgbClr val="10B981"/>
                 </a:solidFill>
@@ -9216,94 +8779,62 @@
 </a:t>
             </a:r>
             <a:r>
-              <a:rPr sz="950">
+              <a:rPr sz="900">
                 <a:solidFill>
                   <a:srgbClr val="0F172A"/>
                 </a:solidFill>
               </a:rPr>
-              <a:t>   Curriculum Scope: Sections 2.3, 2.4, 3.1, 4.1</a:t>
+              <a:t>   Curriculum Scope: Sections 4.2, 4.3, 5.1, 5.2, 6.1</a:t>
             </a:r>
           </a:p>
           <a:p>
             <a:pPr>
               <a:spcBef>
-                <a:spcPts val="800"/>
+                <a:spcPts val="700"/>
               </a:spcBef>
             </a:pPr>
             <a:r>
-              <a:rPr b="1" sz="1100">
+              <a:rPr b="1" sz="1050">
                 <a:solidFill>
                   <a:srgbClr val="2563EB"/>
                 </a:solidFill>
               </a:rPr>
-              <a:t>• [27/10/2026]  Third Progress Work Evaluation (10 Marks) — </a:t>
-            </a:r>
-            <a:r>
-              <a:rPr b="1" sz="1050">
+              <a:t>• [06/11/2026]  Report Submission (Spiral Binding) (10 Marks) — </a:t>
+            </a:r>
+            <a:r>
+              <a:rPr b="1" sz="1000">
                 <a:solidFill>
                   <a:srgbClr val="2563EB"/>
                 </a:solidFill>
               </a:rPr>
-              <a:t>Scheduled for Third Milestone
+              <a:t>Scheduled for Final Submission
 </a:t>
             </a:r>
             <a:r>
-              <a:rPr sz="950">
+              <a:rPr sz="900">
                 <a:solidFill>
                   <a:srgbClr val="0F172A"/>
                 </a:solidFill>
               </a:rPr>
-              <a:t>   Curriculum Scope: Sections 4.2 (Sample Code), 4.3 (Navigation), 5.1-5.2, 6.1</a:t>
+              <a:t>   Curriculum Scope: Final Signed Spiral Copy &amp; Media</a:t>
             </a:r>
           </a:p>
           <a:p>
             <a:pPr>
               <a:spcBef>
-                <a:spcPts val="800"/>
+                <a:spcPts val="700"/>
               </a:spcBef>
             </a:pPr>
             <a:r>
-              <a:rPr b="1" sz="1100">
-                <a:solidFill>
-                  <a:srgbClr val="475569"/>
-                </a:solidFill>
-              </a:rPr>
-              <a:t>• [06/11/2026]  Report Submission (Spiral Binding) (10 Marks) — </a:t>
-            </a:r>
-            <a:r>
               <a:rPr b="1" sz="1050">
                 <a:solidFill>
-                  <a:srgbClr val="475569"/>
-                </a:solidFill>
-              </a:rPr>
-              <a:t>Scheduled for Final Submission
-</a:t>
-            </a:r>
-            <a:r>
-              <a:rPr sz="950">
-                <a:solidFill>
-                  <a:srgbClr val="0F172A"/>
-                </a:solidFill>
-              </a:rPr>
-              <a:t>   Curriculum Scope: Final Signed Spiral Copy &amp; Media</a:t>
-            </a:r>
-          </a:p>
-          <a:p>
-            <a:pPr>
-              <a:spcBef>
-                <a:spcPts val="800"/>
-              </a:spcBef>
-            </a:pPr>
-            <a:r>
-              <a:rPr b="1" sz="1100">
-                <a:solidFill>
                   <a:srgbClr val="7A003C"/>
                 </a:solidFill>
               </a:rPr>
               <a:t>• [18-20/11/2026]  Final Examination (SEE) (50 Marks) — </a:t>
             </a:r>
             <a:r>
-              <a:rPr b="1" sz="1050">
+              <a:rPr b="1" sz="1000">
                 <a:solidFill>
                   <a:srgbClr val="7A003C"/>
                 </a:solidFill>
@@ -9312,7 +8843,7 @@
 </a:t>
             </a:r>
             <a:r>
-              <a:rPr sz="950">
+              <a:rPr sz="900">
                 <a:solidFill>
                   <a:srgbClr val="0F172A"/>
                 </a:solidFill>
@@ -9395,7 +8926,7 @@
                   <a:srgbClr val="10B981"/>
                 </a:solidFill>
               </a:rPr>
-              <a:t>MID-TERM MILESTONE STATUS (13/10/2026): </a:t>
+              <a:t>THIRD PROGRESS MILESTONE STATUS (27/10/2026): </a:t>
             </a:r>
             <a:r>
               <a:rPr sz="950">
@@ -9403,7 +8934,7 @@
                   <a:srgbClr val="0F172A"/>
                 </a:solidFill>
               </a:rPr>
-              <a:t>Cumulative completion of 30 Marks (First Progress 10 Marks + Mid-Term 20 Marks). All Class, Sequence, Data Dictionary, and UI Validation specifications fully implemented.</a:t>
+              <a:t>Cumulative completion of 40 Marks across all progress work milestones (10M + 20M + 10M). All technical chapters (Chapters 1 to 6) fully implemented, documented, and validated.</a:t>
             </a:r>
           </a:p>
         </p:txBody>

</xml_diff>